<commit_message>
docs: align proposal and slides around two ABE rationales
</commit_message>
<xml_diff>
--- a/docs/PAPER/proposal-defense/slides/NDNSF_proposal_hybrid_editable.pptx
+++ b/docs/PAPER/proposal-defense/slides/NDNSF_proposal_hybrid_editable.pptx
@@ -391,7 +391,7 @@
           <a:p>
             <a:r>
               <a:rPr lang="en-US" sz="1200"/>
-              <a:t>Design Execution authorization Discovery confidentiality DNMP-inspired roles [12] Role/command signing rules, credential and request-state checks Add encryption and group/key distribution Our per-service role cer- tificates Service/message rules plus caller or Provider credential Add equivalent encryption and lifecycle handling NDNSF ABE-backed Identity signature, encrypted challenges, and authorization/request state Service-level ABE protection of descriptor Content Trust Schema [16] alone does not encrypt Content. Trust Schema plus encryption is a valid alternative, not an impossible design.</a:t>
+              <a:t>Nodes may retrieve the same encrypted Request Data; only matching decryption capabilities expose its descriptor. The User encrypts by service attributes, without listing Provider identities. The Controller still authorizes entities and issues keys. [19] Different entities retain overlapping service permissions in individual policy keys, independently of identity-signing credentials. Architectural benefit: shared dissemination with distinct access scopes. Aggregation preserves distinctions only while objects retain separate encryption scopes.</a:t>
             </a:r>
             <a:endParaRPr lang="en-US" sz="1200"/>
           </a:p>
@@ -447,7 +447,7 @@
           <a:p>
             <a:r>
               <a:rPr lang="en-US" sz="1200"/>
-              <a:t>Enhanced NAC-ABE [19] supports key-policy ABE (KP-ABE): ciphertext attributes meet a policy in an individually issued decryption key (DKEY). Service permissions can be aggregated while identity-signing credentials remain unchanged. Challenges reuse those service permissions instead of introducing additional service-role signing credentials. This saves a second entitlement representation in this design---not all key work. User DKEYs, challenge processing, policy growth, status and rekeying still cost resources.</a:t>
+              <a:t>Design Execution authorization Discovery confidentiality DNMP-inspired roles [12] Role/command signing rules, credential and request-state checks Add encryption and group/key distribution Our per-service role cer- tificates Service/message rules plus caller or Provider credential Add equivalent encryption and lifecycle handling NDNSF ABE-backed Identity signature, encrypted challenges, and authorization/request state Service-level ABE protection of descriptor Content Trust Schema [16] validates signing relationships; it alone does not encrypt Content. NAC [4] also protects distributed content. ABE contributes attribute-policy-based decryption.</a:t>
             </a:r>
             <a:endParaRPr lang="en-US" sz="1200"/>
           </a:p>
@@ -559,7 +559,7 @@
           <a:p>
             <a:r>
               <a:rPr lang="en-US" sz="1200"/>
-              <a:t>Symmetric request-scoped keys protect input and result Content. Selection supplies necessary keys only to the selected Provider through recipient encryption. The requesting User and selected Provider share the result key; other Users are excluded under key-secrecy assumptions. Controller-signed status affects authorization after retrieval and validation. ABE rotation limits subsequent encrypted exchanges. Current rotation is Controller-wide. Disconnected revocation is not immediate; old plaintext and keys cannot be recalled. Runtime tests do not establish lower cost than certificate revocation. [28]</a:t>
+              <a:t>Challenges check decryption capability; signatures, service permissions and request state still determine invocation acceptance. Request-scoped keys protect input/results. Selection delivers keys to selected Providers; the requesting User retains access. Withdrawal requires retrieved, validated Controller status. Current ABE rotation is Controller-wide. [28] Lifecycle requirement, not a third advantage: measure policy/key size, challenge cost, propagation and rekeying. No immediate disconnected revocation or recall of old plaintext/keys.</a:t>
             </a:r>
             <a:endParaRPr lang="en-US" sz="1200"/>
           </a:p>
@@ -6372,7 +6372,7 @@
                 </a:solidFill>
                 <a:latin typeface="Latin Modern Sans"/>
               </a:rPr>
-              <a:t>RQ1: Why Protect Discovery Content?</a:t>
+              <a:t>Reason 1: Confidential Discovery Before Selection</a:t>
             </a:r>
           </a:p>
         </p:txBody>
@@ -6985,7 +6985,7 @@
       <p:grpSpPr/>
       <p:pic>
         <p:nvPicPr>
-          <p:cNvPr id="2" name="TEXT_FREE_BACKGROUND_12" descr="background-012.png"/>
+          <p:cNvPr id="2" name="TEXT_FREE_BACKGROUND_12" descr="background-005.png"/>
           <p:cNvPicPr>
             <a:picLocks noChangeAspect="1"/>
           </p:cNvPicPr>
@@ -7050,7 +7050,7 @@
                 </a:solidFill>
                 <a:latin typeface="Latin Modern Sans"/>
               </a:rPr>
-              <a:t>A Fair Comparison Includes Encryption on Both Sides</a:t>
+              <a:t>Reason 2: Separate Dissemination from Access</a:t>
             </a:r>
           </a:p>
         </p:txBody>
@@ -7063,42 +7063,51 @@
         </p:nvSpPr>
         <p:spPr>
           <a:xfrm>
-            <a:off x="1107736" y="1358722"/>
-            <a:ext cx="1082791" cy="385554"/>
-          </a:xfrm>
-          <a:prstGeom prst="rect">
-            <a:avLst/>
-          </a:prstGeom>
-          <a:noFill/>
-          <a:ln>
-            <a:noFill/>
-          </a:ln>
-        </p:spPr>
-        <p:txBody>
-          <a:bodyPr wrap="square" anchor="t" lIns="0" rIns="0" tIns="0" bIns="0">
-            <a:noAutofit/>
-          </a:bodyPr>
-          <a:lstStyle/>
-          <a:p>
-            <a:pPr algn="l">
-              <a:lnSpc>
-                <a:spcPct val="100000"/>
-              </a:lnSpc>
-              <a:spcBef>
-                <a:spcPts val="0"/>
-              </a:spcBef>
-              <a:spcAft>
-                <a:spcPts val="0"/>
-              </a:spcAft>
-            </a:pPr>
-            <a:r>
-              <a:rPr sz="2371" b="0" i="0">
-                <a:solidFill>
-                  <a:srgbClr val="000000"/>
-                </a:solidFill>
-                <a:latin typeface="Latin Modern Sans"/>
-              </a:rPr>
-              <a:t>Design</a:t>
+            <a:off x="1618972" y="2029557"/>
+            <a:ext cx="11999210" cy="929891"/>
+          </a:xfrm>
+          <a:prstGeom prst="rect">
+            <a:avLst/>
+          </a:prstGeom>
+          <a:noFill/>
+          <a:ln>
+            <a:noFill/>
+          </a:ln>
+        </p:spPr>
+        <p:txBody>
+          <a:bodyPr wrap="square" anchor="t" lIns="0" rIns="0" tIns="0" bIns="0">
+            <a:noAutofit/>
+          </a:bodyPr>
+          <a:lstStyle/>
+          <a:p>
+            <a:pPr algn="l">
+              <a:lnSpc>
+                <a:spcPct val="100000"/>
+              </a:lnSpc>
+              <a:spcBef>
+                <a:spcPts val="0"/>
+              </a:spcBef>
+              <a:spcAft>
+                <a:spcPts val="0"/>
+              </a:spcAft>
+            </a:pPr>
+            <a:r>
+              <a:rPr sz="2710" b="0" i="0">
+                <a:solidFill>
+                  <a:srgbClr val="000000"/>
+                </a:solidFill>
+                <a:latin typeface="Latin Modern Sans"/>
+              </a:rPr>
+              <a:t>Nodes may retrieve the same encrypted Request Data; only matching decryption</a:t>
+            </a:r>
+            <a:r>
+              <a:rPr sz="2710" b="0" i="0">
+                <a:solidFill>
+                  <a:srgbClr val="000000"/>
+                </a:solidFill>
+                <a:latin typeface="Latin Modern Sans"/>
+              </a:rPr>
+              <a:t> capabilities expose its descriptor.</a:t>
             </a:r>
           </a:p>
         </p:txBody>
@@ -7111,42 +7120,51 @@
         </p:nvSpPr>
         <p:spPr>
           <a:xfrm>
-            <a:off x="4951729" y="1358722"/>
-            <a:ext cx="3428411" cy="385554"/>
-          </a:xfrm>
-          <a:prstGeom prst="rect">
-            <a:avLst/>
-          </a:prstGeom>
-          <a:noFill/>
-          <a:ln>
-            <a:noFill/>
-          </a:ln>
-        </p:spPr>
-        <p:txBody>
-          <a:bodyPr wrap="square" anchor="t" lIns="0" rIns="0" tIns="0" bIns="0">
-            <a:noAutofit/>
-          </a:bodyPr>
-          <a:lstStyle/>
-          <a:p>
-            <a:pPr algn="l">
-              <a:lnSpc>
-                <a:spcPct val="100000"/>
-              </a:lnSpc>
-              <a:spcBef>
-                <a:spcPts val="0"/>
-              </a:spcBef>
-              <a:spcAft>
-                <a:spcPts val="0"/>
-              </a:spcAft>
-            </a:pPr>
-            <a:r>
-              <a:rPr sz="2371" b="0" i="0">
-                <a:solidFill>
-                  <a:srgbClr val="000000"/>
-                </a:solidFill>
-                <a:latin typeface="Latin Modern Sans"/>
-              </a:rPr>
-              <a:t>Execution authorization</a:t>
+            <a:off x="1618972" y="3001824"/>
+            <a:ext cx="11819233" cy="929891"/>
+          </a:xfrm>
+          <a:prstGeom prst="rect">
+            <a:avLst/>
+          </a:prstGeom>
+          <a:noFill/>
+          <a:ln>
+            <a:noFill/>
+          </a:ln>
+        </p:spPr>
+        <p:txBody>
+          <a:bodyPr wrap="square" anchor="t" lIns="0" rIns="0" tIns="0" bIns="0">
+            <a:noAutofit/>
+          </a:bodyPr>
+          <a:lstStyle/>
+          <a:p>
+            <a:pPr algn="l">
+              <a:lnSpc>
+                <a:spcPct val="100000"/>
+              </a:lnSpc>
+              <a:spcBef>
+                <a:spcPts val="0"/>
+              </a:spcBef>
+              <a:spcAft>
+                <a:spcPts val="0"/>
+              </a:spcAft>
+            </a:pPr>
+            <a:r>
+              <a:rPr sz="2710" b="0" i="0">
+                <a:solidFill>
+                  <a:srgbClr val="000000"/>
+                </a:solidFill>
+                <a:latin typeface="Latin Modern Sans"/>
+              </a:rPr>
+              <a:t>The User encrypts by service attributes, without listing Provider identities. The</a:t>
+            </a:r>
+            <a:r>
+              <a:rPr sz="2710" b="0" i="0">
+                <a:solidFill>
+                  <a:srgbClr val="000000"/>
+                </a:solidFill>
+                <a:latin typeface="Latin Modern Sans"/>
+              </a:rPr>
+              <a:t> Controller still authorizes entities and issues keys. [19]</a:t>
             </a:r>
           </a:p>
         </p:txBody>
@@ -7159,42 +7177,51 @@
         </p:nvSpPr>
         <p:spPr>
           <a:xfrm>
-            <a:off x="9433494" y="1358722"/>
-            <a:ext cx="3527306" cy="385554"/>
-          </a:xfrm>
-          <a:prstGeom prst="rect">
-            <a:avLst/>
-          </a:prstGeom>
-          <a:noFill/>
-          <a:ln>
-            <a:noFill/>
-          </a:ln>
-        </p:spPr>
-        <p:txBody>
-          <a:bodyPr wrap="square" anchor="t" lIns="0" rIns="0" tIns="0" bIns="0">
-            <a:noAutofit/>
-          </a:bodyPr>
-          <a:lstStyle/>
-          <a:p>
-            <a:pPr algn="l">
-              <a:lnSpc>
-                <a:spcPct val="100000"/>
-              </a:lnSpc>
-              <a:spcBef>
-                <a:spcPts val="0"/>
-              </a:spcBef>
-              <a:spcAft>
-                <a:spcPts val="0"/>
-              </a:spcAft>
-            </a:pPr>
-            <a:r>
-              <a:rPr sz="2371" b="0" i="0">
-                <a:solidFill>
-                  <a:srgbClr val="000000"/>
-                </a:solidFill>
-                <a:latin typeface="Latin Modern Sans"/>
-              </a:rPr>
-              <a:t>Discovery confidentiality</a:t>
+            <a:off x="1618972" y="3974091"/>
+            <a:ext cx="11916509" cy="929924"/>
+          </a:xfrm>
+          <a:prstGeom prst="rect">
+            <a:avLst/>
+          </a:prstGeom>
+          <a:noFill/>
+          <a:ln>
+            <a:noFill/>
+          </a:ln>
+        </p:spPr>
+        <p:txBody>
+          <a:bodyPr wrap="square" anchor="t" lIns="0" rIns="0" tIns="0" bIns="0">
+            <a:noAutofit/>
+          </a:bodyPr>
+          <a:lstStyle/>
+          <a:p>
+            <a:pPr algn="l">
+              <a:lnSpc>
+                <a:spcPct val="100000"/>
+              </a:lnSpc>
+              <a:spcBef>
+                <a:spcPts val="0"/>
+              </a:spcBef>
+              <a:spcAft>
+                <a:spcPts val="0"/>
+              </a:spcAft>
+            </a:pPr>
+            <a:r>
+              <a:rPr sz="2710" b="0" i="0">
+                <a:solidFill>
+                  <a:srgbClr val="000000"/>
+                </a:solidFill>
+                <a:latin typeface="Latin Modern Sans"/>
+              </a:rPr>
+              <a:t>Different entities retain overlapping service permissions in individual policy keys,</a:t>
+            </a:r>
+            <a:r>
+              <a:rPr sz="2710" b="0" i="0">
+                <a:solidFill>
+                  <a:srgbClr val="000000"/>
+                </a:solidFill>
+                <a:latin typeface="Latin Modern Sans"/>
+              </a:rPr>
+              <a:t> independently of identity-signing credentials.</a:t>
             </a:r>
           </a:p>
         </p:txBody>
@@ -7207,42 +7234,51 @@
         </p:nvSpPr>
         <p:spPr>
           <a:xfrm>
-            <a:off x="1107736" y="1927082"/>
-            <a:ext cx="3690615" cy="385554"/>
-          </a:xfrm>
-          <a:prstGeom prst="rect">
-            <a:avLst/>
-          </a:prstGeom>
-          <a:noFill/>
-          <a:ln>
-            <a:noFill/>
-          </a:ln>
-        </p:spPr>
-        <p:txBody>
-          <a:bodyPr wrap="square" anchor="t" lIns="0" rIns="0" tIns="0" bIns="0">
-            <a:noAutofit/>
-          </a:bodyPr>
-          <a:lstStyle/>
-          <a:p>
-            <a:pPr algn="l">
-              <a:lnSpc>
-                <a:spcPct val="100000"/>
-              </a:lnSpc>
-              <a:spcBef>
-                <a:spcPts val="0"/>
-              </a:spcBef>
-              <a:spcAft>
-                <a:spcPts val="0"/>
-              </a:spcAft>
-            </a:pPr>
-            <a:r>
-              <a:rPr sz="2371" b="0" i="0">
-                <a:solidFill>
-                  <a:srgbClr val="000000"/>
-                </a:solidFill>
-                <a:latin typeface="Latin Modern Sans"/>
-              </a:rPr>
-              <a:t>DNMP-inspired roles [12]</a:t>
+            <a:off x="1143656" y="5567779"/>
+            <a:ext cx="12477953" cy="929891"/>
+          </a:xfrm>
+          <a:prstGeom prst="rect">
+            <a:avLst/>
+          </a:prstGeom>
+          <a:noFill/>
+          <a:ln>
+            <a:noFill/>
+          </a:ln>
+        </p:spPr>
+        <p:txBody>
+          <a:bodyPr wrap="square" anchor="t" lIns="0" rIns="0" tIns="0" bIns="0">
+            <a:noAutofit/>
+          </a:bodyPr>
+          <a:lstStyle/>
+          <a:p>
+            <a:pPr algn="l">
+              <a:lnSpc>
+                <a:spcPct val="100000"/>
+              </a:lnSpc>
+              <a:spcBef>
+                <a:spcPts val="0"/>
+              </a:spcBef>
+              <a:spcAft>
+                <a:spcPts val="0"/>
+              </a:spcAft>
+            </a:pPr>
+            <a:r>
+              <a:rPr sz="2710" b="0" i="0">
+                <a:solidFill>
+                  <a:srgbClr val="000000"/>
+                </a:solidFill>
+                <a:latin typeface="Latin Modern Sans"/>
+              </a:rPr>
+              <a:t>Architectural benefit: shared dissemination with distinct access scopes. Aggregation</a:t>
+            </a:r>
+            <a:r>
+              <a:rPr sz="2710" b="0" i="0">
+                <a:solidFill>
+                  <a:srgbClr val="000000"/>
+                </a:solidFill>
+                <a:latin typeface="Latin Modern Sans"/>
+              </a:rPr>
+              <a:t> preserves distinctions only while objects retain separate encryption scopes.</a:t>
             </a:r>
           </a:p>
         </p:txBody>
@@ -7250,684 +7286,6 @@
       <p:sp>
         <p:nvSpPr>
           <p:cNvPr id="8" name="PDF_TEXT_GROUP_150"/>
-          <p:cNvSpPr txBox="1"/>
-          <p:nvPr/>
-        </p:nvSpPr>
-        <p:spPr>
-          <a:xfrm>
-            <a:off x="4951633" y="1927082"/>
-            <a:ext cx="4215475" cy="385554"/>
-          </a:xfrm>
-          <a:prstGeom prst="rect">
-            <a:avLst/>
-          </a:prstGeom>
-          <a:noFill/>
-          <a:ln>
-            <a:noFill/>
-          </a:ln>
-        </p:spPr>
-        <p:txBody>
-          <a:bodyPr wrap="square" anchor="t" lIns="0" rIns="0" tIns="0" bIns="0">
-            <a:noAutofit/>
-          </a:bodyPr>
-          <a:lstStyle/>
-          <a:p>
-            <a:pPr algn="l">
-              <a:lnSpc>
-                <a:spcPct val="100000"/>
-              </a:lnSpc>
-              <a:spcBef>
-                <a:spcPts val="0"/>
-              </a:spcBef>
-              <a:spcAft>
-                <a:spcPts val="0"/>
-              </a:spcAft>
-            </a:pPr>
-            <a:r>
-              <a:rPr sz="2371" b="0" i="0">
-                <a:solidFill>
-                  <a:srgbClr val="000000"/>
-                </a:solidFill>
-                <a:latin typeface="Latin Modern Sans"/>
-              </a:rPr>
-              <a:t>Role/command signing rules,</a:t>
-            </a:r>
-          </a:p>
-        </p:txBody>
-      </p:sp>
-      <p:sp>
-        <p:nvSpPr>
-          <p:cNvPr id="9" name="PDF_TEXT_GROUP_151"/>
-          <p:cNvSpPr txBox="1"/>
-          <p:nvPr/>
-        </p:nvSpPr>
-        <p:spPr>
-          <a:xfrm>
-            <a:off x="9433445" y="1927082"/>
-            <a:ext cx="4423717" cy="385554"/>
-          </a:xfrm>
-          <a:prstGeom prst="rect">
-            <a:avLst/>
-          </a:prstGeom>
-          <a:noFill/>
-          <a:ln>
-            <a:noFill/>
-          </a:ln>
-        </p:spPr>
-        <p:txBody>
-          <a:bodyPr wrap="square" anchor="t" lIns="0" rIns="0" tIns="0" bIns="0">
-            <a:noAutofit/>
-          </a:bodyPr>
-          <a:lstStyle/>
-          <a:p>
-            <a:pPr algn="l">
-              <a:lnSpc>
-                <a:spcPct val="100000"/>
-              </a:lnSpc>
-              <a:spcBef>
-                <a:spcPts val="0"/>
-              </a:spcBef>
-              <a:spcAft>
-                <a:spcPts val="0"/>
-              </a:spcAft>
-            </a:pPr>
-            <a:r>
-              <a:rPr sz="2371" b="0" i="0">
-                <a:solidFill>
-                  <a:srgbClr val="000000"/>
-                </a:solidFill>
-                <a:latin typeface="Latin Modern Sans"/>
-              </a:rPr>
-              <a:t>Add encryption and group/key</a:t>
-            </a:r>
-          </a:p>
-        </p:txBody>
-      </p:sp>
-      <p:sp>
-        <p:nvSpPr>
-          <p:cNvPr id="10" name="PDF_TEXT_GROUP_152"/>
-          <p:cNvSpPr txBox="1"/>
-          <p:nvPr/>
-        </p:nvSpPr>
-        <p:spPr>
-          <a:xfrm>
-            <a:off x="4951637" y="2313410"/>
-            <a:ext cx="3851309" cy="828877"/>
-          </a:xfrm>
-          <a:prstGeom prst="rect">
-            <a:avLst/>
-          </a:prstGeom>
-          <a:noFill/>
-          <a:ln>
-            <a:noFill/>
-          </a:ln>
-        </p:spPr>
-        <p:txBody>
-          <a:bodyPr wrap="square" anchor="t" lIns="0" rIns="0" tIns="0" bIns="0">
-            <a:noAutofit/>
-          </a:bodyPr>
-          <a:lstStyle/>
-          <a:p>
-            <a:pPr algn="l">
-              <a:lnSpc>
-                <a:spcPct val="100000"/>
-              </a:lnSpc>
-              <a:spcBef>
-                <a:spcPts val="0"/>
-              </a:spcBef>
-              <a:spcAft>
-                <a:spcPts val="0"/>
-              </a:spcAft>
-            </a:pPr>
-            <a:r>
-              <a:rPr sz="2371" b="0" i="0">
-                <a:solidFill>
-                  <a:srgbClr val="000000"/>
-                </a:solidFill>
-                <a:latin typeface="Latin Modern Sans"/>
-              </a:rPr>
-              <a:t>credential and request-state</a:t>
-            </a:r>
-            <a:r>
-              <a:rPr sz="2371" b="0" i="0">
-                <a:solidFill>
-                  <a:srgbClr val="000000"/>
-                </a:solidFill>
-                <a:latin typeface="Latin Modern Sans"/>
-              </a:rPr>
-              <a:t> checks</a:t>
-            </a:r>
-          </a:p>
-        </p:txBody>
-      </p:sp>
-      <p:sp>
-        <p:nvSpPr>
-          <p:cNvPr id="11" name="PDF_TEXT_GROUP_153"/>
-          <p:cNvSpPr txBox="1"/>
-          <p:nvPr/>
-        </p:nvSpPr>
-        <p:spPr>
-          <a:xfrm>
-            <a:off x="9433445" y="2313410"/>
-            <a:ext cx="1701754" cy="385554"/>
-          </a:xfrm>
-          <a:prstGeom prst="rect">
-            <a:avLst/>
-          </a:prstGeom>
-          <a:noFill/>
-          <a:ln>
-            <a:noFill/>
-          </a:ln>
-        </p:spPr>
-        <p:txBody>
-          <a:bodyPr wrap="square" anchor="t" lIns="0" rIns="0" tIns="0" bIns="0">
-            <a:noAutofit/>
-          </a:bodyPr>
-          <a:lstStyle/>
-          <a:p>
-            <a:pPr algn="l">
-              <a:lnSpc>
-                <a:spcPct val="100000"/>
-              </a:lnSpc>
-              <a:spcBef>
-                <a:spcPts val="0"/>
-              </a:spcBef>
-              <a:spcAft>
-                <a:spcPts val="0"/>
-              </a:spcAft>
-            </a:pPr>
-            <a:r>
-              <a:rPr sz="2371" b="0" i="0">
-                <a:solidFill>
-                  <a:srgbClr val="000000"/>
-                </a:solidFill>
-                <a:latin typeface="Latin Modern Sans"/>
-              </a:rPr>
-              <a:t>distribution</a:t>
-            </a:r>
-          </a:p>
-        </p:txBody>
-      </p:sp>
-      <p:sp>
-        <p:nvSpPr>
-          <p:cNvPr id="12" name="PDF_TEXT_GROUP_154"/>
-          <p:cNvSpPr txBox="1"/>
-          <p:nvPr/>
-        </p:nvSpPr>
-        <p:spPr>
-          <a:xfrm>
-            <a:off x="1107736" y="3268129"/>
-            <a:ext cx="3586085" cy="828844"/>
-          </a:xfrm>
-          <a:prstGeom prst="rect">
-            <a:avLst/>
-          </a:prstGeom>
-          <a:noFill/>
-          <a:ln>
-            <a:noFill/>
-          </a:ln>
-        </p:spPr>
-        <p:txBody>
-          <a:bodyPr wrap="square" anchor="t" lIns="0" rIns="0" tIns="0" bIns="0">
-            <a:noAutofit/>
-          </a:bodyPr>
-          <a:lstStyle/>
-          <a:p>
-            <a:pPr algn="l">
-              <a:lnSpc>
-                <a:spcPct val="100000"/>
-              </a:lnSpc>
-              <a:spcBef>
-                <a:spcPts val="0"/>
-              </a:spcBef>
-              <a:spcAft>
-                <a:spcPts val="0"/>
-              </a:spcAft>
-            </a:pPr>
-            <a:r>
-              <a:rPr sz="2371" b="0" i="0">
-                <a:solidFill>
-                  <a:srgbClr val="000000"/>
-                </a:solidFill>
-                <a:latin typeface="Latin Modern Sans"/>
-              </a:rPr>
-              <a:t>Our per-service role cer-</a:t>
-            </a:r>
-            <a:r>
-              <a:rPr sz="2371" b="0" i="0">
-                <a:solidFill>
-                  <a:srgbClr val="000000"/>
-                </a:solidFill>
-                <a:latin typeface="Latin Modern Sans"/>
-              </a:rPr>
-              <a:t>tificates</a:t>
-            </a:r>
-          </a:p>
-        </p:txBody>
-      </p:sp>
-      <p:sp>
-        <p:nvSpPr>
-          <p:cNvPr id="13" name="PDF_TEXT_GROUP_155"/>
-          <p:cNvSpPr txBox="1"/>
-          <p:nvPr/>
-        </p:nvSpPr>
-        <p:spPr>
-          <a:xfrm>
-            <a:off x="4951637" y="3268129"/>
-            <a:ext cx="3857153" cy="385554"/>
-          </a:xfrm>
-          <a:prstGeom prst="rect">
-            <a:avLst/>
-          </a:prstGeom>
-          <a:noFill/>
-          <a:ln>
-            <a:noFill/>
-          </a:ln>
-        </p:spPr>
-        <p:txBody>
-          <a:bodyPr wrap="square" anchor="t" lIns="0" rIns="0" tIns="0" bIns="0">
-            <a:noAutofit/>
-          </a:bodyPr>
-          <a:lstStyle/>
-          <a:p>
-            <a:pPr algn="l">
-              <a:lnSpc>
-                <a:spcPct val="100000"/>
-              </a:lnSpc>
-              <a:spcBef>
-                <a:spcPts val="0"/>
-              </a:spcBef>
-              <a:spcAft>
-                <a:spcPts val="0"/>
-              </a:spcAft>
-            </a:pPr>
-            <a:r>
-              <a:rPr sz="2371" b="0" i="0">
-                <a:solidFill>
-                  <a:srgbClr val="000000"/>
-                </a:solidFill>
-                <a:latin typeface="Latin Modern Sans"/>
-              </a:rPr>
-              <a:t>Service/message rules plus</a:t>
-            </a:r>
-          </a:p>
-        </p:txBody>
-      </p:sp>
-      <p:sp>
-        <p:nvSpPr>
-          <p:cNvPr id="14" name="PDF_TEXT_GROUP_156"/>
-          <p:cNvSpPr txBox="1"/>
-          <p:nvPr/>
-        </p:nvSpPr>
-        <p:spPr>
-          <a:xfrm>
-            <a:off x="9433445" y="3268129"/>
-            <a:ext cx="4423717" cy="385554"/>
-          </a:xfrm>
-          <a:prstGeom prst="rect">
-            <a:avLst/>
-          </a:prstGeom>
-          <a:noFill/>
-          <a:ln>
-            <a:noFill/>
-          </a:ln>
-        </p:spPr>
-        <p:txBody>
-          <a:bodyPr wrap="square" anchor="t" lIns="0" rIns="0" tIns="0" bIns="0">
-            <a:noAutofit/>
-          </a:bodyPr>
-          <a:lstStyle/>
-          <a:p>
-            <a:pPr algn="l">
-              <a:lnSpc>
-                <a:spcPct val="100000"/>
-              </a:lnSpc>
-              <a:spcBef>
-                <a:spcPts val="0"/>
-              </a:spcBef>
-              <a:spcAft>
-                <a:spcPts val="0"/>
-              </a:spcAft>
-            </a:pPr>
-            <a:r>
-              <a:rPr sz="2371" b="0" i="0">
-                <a:solidFill>
-                  <a:srgbClr val="000000"/>
-                </a:solidFill>
-                <a:latin typeface="Latin Modern Sans"/>
-              </a:rPr>
-              <a:t>Add equivalent encryption and</a:t>
-            </a:r>
-          </a:p>
-        </p:txBody>
-      </p:sp>
-      <p:sp>
-        <p:nvSpPr>
-          <p:cNvPr id="15" name="PDF_TEXT_GROUP_157"/>
-          <p:cNvSpPr txBox="1"/>
-          <p:nvPr/>
-        </p:nvSpPr>
-        <p:spPr>
-          <a:xfrm>
-            <a:off x="4951637" y="3654457"/>
-            <a:ext cx="3998239" cy="385554"/>
-          </a:xfrm>
-          <a:prstGeom prst="rect">
-            <a:avLst/>
-          </a:prstGeom>
-          <a:noFill/>
-          <a:ln>
-            <a:noFill/>
-          </a:ln>
-        </p:spPr>
-        <p:txBody>
-          <a:bodyPr wrap="square" anchor="t" lIns="0" rIns="0" tIns="0" bIns="0">
-            <a:noAutofit/>
-          </a:bodyPr>
-          <a:lstStyle/>
-          <a:p>
-            <a:pPr algn="l">
-              <a:lnSpc>
-                <a:spcPct val="100000"/>
-              </a:lnSpc>
-              <a:spcBef>
-                <a:spcPts val="0"/>
-              </a:spcBef>
-              <a:spcAft>
-                <a:spcPts val="0"/>
-              </a:spcAft>
-            </a:pPr>
-            <a:r>
-              <a:rPr sz="2371" b="0" i="0">
-                <a:solidFill>
-                  <a:srgbClr val="000000"/>
-                </a:solidFill>
-                <a:latin typeface="Latin Modern Sans"/>
-              </a:rPr>
-              <a:t>caller or Provider credential</a:t>
-            </a:r>
-          </a:p>
-        </p:txBody>
-      </p:sp>
-      <p:sp>
-        <p:nvSpPr>
-          <p:cNvPr id="16" name="PDF_TEXT_GROUP_158"/>
-          <p:cNvSpPr txBox="1"/>
-          <p:nvPr/>
-        </p:nvSpPr>
-        <p:spPr>
-          <a:xfrm>
-            <a:off x="9433445" y="3654457"/>
-            <a:ext cx="2472170" cy="385554"/>
-          </a:xfrm>
-          <a:prstGeom prst="rect">
-            <a:avLst/>
-          </a:prstGeom>
-          <a:noFill/>
-          <a:ln>
-            <a:noFill/>
-          </a:ln>
-        </p:spPr>
-        <p:txBody>
-          <a:bodyPr wrap="square" anchor="t" lIns="0" rIns="0" tIns="0" bIns="0">
-            <a:noAutofit/>
-          </a:bodyPr>
-          <a:lstStyle/>
-          <a:p>
-            <a:pPr algn="l">
-              <a:lnSpc>
-                <a:spcPct val="100000"/>
-              </a:lnSpc>
-              <a:spcBef>
-                <a:spcPts val="0"/>
-              </a:spcBef>
-              <a:spcAft>
-                <a:spcPts val="0"/>
-              </a:spcAft>
-            </a:pPr>
-            <a:r>
-              <a:rPr sz="2371" b="0" i="0">
-                <a:solidFill>
-                  <a:srgbClr val="000000"/>
-                </a:solidFill>
-                <a:latin typeface="Latin Modern Sans"/>
-              </a:rPr>
-              <a:t>lifecycle handling</a:t>
-            </a:r>
-          </a:p>
-        </p:txBody>
-      </p:sp>
-      <p:sp>
-        <p:nvSpPr>
-          <p:cNvPr id="17" name="PDF_TEXT_GROUP_159"/>
-          <p:cNvSpPr txBox="1"/>
-          <p:nvPr/>
-        </p:nvSpPr>
-        <p:spPr>
-          <a:xfrm>
-            <a:off x="1107736" y="4222817"/>
-            <a:ext cx="3029497" cy="385554"/>
-          </a:xfrm>
-          <a:prstGeom prst="rect">
-            <a:avLst/>
-          </a:prstGeom>
-          <a:noFill/>
-          <a:ln>
-            <a:noFill/>
-          </a:ln>
-        </p:spPr>
-        <p:txBody>
-          <a:bodyPr wrap="square" anchor="t" lIns="0" rIns="0" tIns="0" bIns="0">
-            <a:noAutofit/>
-          </a:bodyPr>
-          <a:lstStyle/>
-          <a:p>
-            <a:pPr algn="l">
-              <a:lnSpc>
-                <a:spcPct val="100000"/>
-              </a:lnSpc>
-              <a:spcBef>
-                <a:spcPts val="0"/>
-              </a:spcBef>
-              <a:spcAft>
-                <a:spcPts val="0"/>
-              </a:spcAft>
-            </a:pPr>
-            <a:r>
-              <a:rPr sz="2371" b="0" i="0">
-                <a:solidFill>
-                  <a:srgbClr val="000000"/>
-                </a:solidFill>
-                <a:latin typeface="Latin Modern Sans"/>
-              </a:rPr>
-              <a:t>NDNSF ABE-backed</a:t>
-            </a:r>
-          </a:p>
-        </p:txBody>
-      </p:sp>
-      <p:sp>
-        <p:nvSpPr>
-          <p:cNvPr id="18" name="PDF_TEXT_GROUP_160"/>
-          <p:cNvSpPr txBox="1"/>
-          <p:nvPr/>
-        </p:nvSpPr>
-        <p:spPr>
-          <a:xfrm>
-            <a:off x="4951637" y="4222817"/>
-            <a:ext cx="3962070" cy="1215172"/>
-          </a:xfrm>
-          <a:prstGeom prst="rect">
-            <a:avLst/>
-          </a:prstGeom>
-          <a:noFill/>
-          <a:ln>
-            <a:noFill/>
-          </a:ln>
-        </p:spPr>
-        <p:txBody>
-          <a:bodyPr wrap="square" anchor="t" lIns="0" rIns="0" tIns="0" bIns="0">
-            <a:noAutofit/>
-          </a:bodyPr>
-          <a:lstStyle/>
-          <a:p>
-            <a:pPr algn="l">
-              <a:lnSpc>
-                <a:spcPct val="100000"/>
-              </a:lnSpc>
-              <a:spcBef>
-                <a:spcPts val="0"/>
-              </a:spcBef>
-              <a:spcAft>
-                <a:spcPts val="0"/>
-              </a:spcAft>
-            </a:pPr>
-            <a:r>
-              <a:rPr sz="2371" b="0" i="0">
-                <a:solidFill>
-                  <a:srgbClr val="000000"/>
-                </a:solidFill>
-                <a:latin typeface="Latin Modern Sans"/>
-              </a:rPr>
-              <a:t>Identity signature, encrypted</a:t>
-            </a:r>
-            <a:r>
-              <a:rPr sz="2371" b="0" i="0">
-                <a:solidFill>
-                  <a:srgbClr val="000000"/>
-                </a:solidFill>
-                <a:latin typeface="Latin Modern Sans"/>
-              </a:rPr>
-              <a:t> challenges, and</a:t>
-            </a:r>
-            <a:r>
-              <a:rPr sz="2371" b="0" i="0">
-                <a:solidFill>
-                  <a:srgbClr val="000000"/>
-                </a:solidFill>
-                <a:latin typeface="Latin Modern Sans"/>
-              </a:rPr>
-              <a:t> authorization/request state</a:t>
-            </a:r>
-          </a:p>
-        </p:txBody>
-      </p:sp>
-      <p:sp>
-        <p:nvSpPr>
-          <p:cNvPr id="19" name="PDF_TEXT_GROUP_161"/>
-          <p:cNvSpPr txBox="1"/>
-          <p:nvPr/>
-        </p:nvSpPr>
-        <p:spPr>
-          <a:xfrm>
-            <a:off x="9433445" y="4222817"/>
-            <a:ext cx="3949534" cy="828844"/>
-          </a:xfrm>
-          <a:prstGeom prst="rect">
-            <a:avLst/>
-          </a:prstGeom>
-          <a:noFill/>
-          <a:ln>
-            <a:noFill/>
-          </a:ln>
-        </p:spPr>
-        <p:txBody>
-          <a:bodyPr wrap="square" anchor="t" lIns="0" rIns="0" tIns="0" bIns="0">
-            <a:noAutofit/>
-          </a:bodyPr>
-          <a:lstStyle/>
-          <a:p>
-            <a:pPr algn="l">
-              <a:lnSpc>
-                <a:spcPct val="100000"/>
-              </a:lnSpc>
-              <a:spcBef>
-                <a:spcPts val="0"/>
-              </a:spcBef>
-              <a:spcAft>
-                <a:spcPts val="0"/>
-              </a:spcAft>
-            </a:pPr>
-            <a:r>
-              <a:rPr sz="2371" b="0" i="0">
-                <a:solidFill>
-                  <a:srgbClr val="000000"/>
-                </a:solidFill>
-                <a:latin typeface="Latin Modern Sans"/>
-              </a:rPr>
-              <a:t>Service-level ABE protection</a:t>
-            </a:r>
-            <a:r>
-              <a:rPr sz="2371" b="0" i="0">
-                <a:solidFill>
-                  <a:srgbClr val="000000"/>
-                </a:solidFill>
-                <a:latin typeface="Latin Modern Sans"/>
-              </a:rPr>
-              <a:t> of descriptor Content</a:t>
-            </a:r>
-          </a:p>
-        </p:txBody>
-      </p:sp>
-      <p:sp>
-        <p:nvSpPr>
-          <p:cNvPr id="20" name="PDF_TEXT_GROUP_162"/>
-          <p:cNvSpPr txBox="1"/>
-          <p:nvPr/>
-        </p:nvSpPr>
-        <p:spPr>
-          <a:xfrm>
-            <a:off x="1123808" y="5890377"/>
-            <a:ext cx="12473158" cy="828844"/>
-          </a:xfrm>
-          <a:prstGeom prst="rect">
-            <a:avLst/>
-          </a:prstGeom>
-          <a:noFill/>
-          <a:ln>
-            <a:noFill/>
-          </a:ln>
-        </p:spPr>
-        <p:txBody>
-          <a:bodyPr wrap="square" anchor="t" lIns="0" rIns="0" tIns="0" bIns="0">
-            <a:noAutofit/>
-          </a:bodyPr>
-          <a:lstStyle/>
-          <a:p>
-            <a:pPr algn="l">
-              <a:lnSpc>
-                <a:spcPct val="100000"/>
-              </a:lnSpc>
-              <a:spcBef>
-                <a:spcPts val="0"/>
-              </a:spcBef>
-              <a:spcAft>
-                <a:spcPts val="0"/>
-              </a:spcAft>
-            </a:pPr>
-            <a:r>
-              <a:rPr sz="2371" b="0" i="0">
-                <a:solidFill>
-                  <a:srgbClr val="000000"/>
-                </a:solidFill>
-                <a:latin typeface="Latin Modern Sans"/>
-              </a:rPr>
-              <a:t>Trust Schema [16] alone does not encrypt Content. Trust Schema plus encryption is a valid</a:t>
-            </a:r>
-            <a:r>
-              <a:rPr sz="2371" b="0" i="0">
-                <a:solidFill>
-                  <a:srgbClr val="000000"/>
-                </a:solidFill>
-                <a:latin typeface="Latin Modern Sans"/>
-              </a:rPr>
-              <a:t> alternative, not an impossible design.</a:t>
-            </a:r>
-          </a:p>
-        </p:txBody>
-      </p:sp>
-      <p:sp>
-        <p:nvSpPr>
-          <p:cNvPr id="21" name="PDF_TEXT_GROUP_163"/>
           <p:cNvSpPr txBox="1"/>
           <p:nvPr/>
         </p:nvSpPr>
@@ -7975,7 +7333,7 @@
       </p:sp>
       <p:sp>
         <p:nvSpPr>
-          <p:cNvPr id="22" name="PDF_TEXT_GROUP_164"/>
+          <p:cNvPr id="9" name="PDF_TEXT_GROUP_151"/>
           <p:cNvSpPr txBox="1"/>
           <p:nvPr/>
         </p:nvSpPr>
@@ -8023,7 +7381,7 @@
       </p:sp>
       <p:sp>
         <p:nvSpPr>
-          <p:cNvPr id="23" name="PDF_TEXT_GROUP_165"/>
+          <p:cNvPr id="10" name="PDF_TEXT_GROUP_152"/>
           <p:cNvSpPr txBox="1"/>
           <p:nvPr/>
         </p:nvSpPr>
@@ -8071,7 +7429,7 @@
       </p:sp>
       <p:sp>
         <p:nvSpPr>
-          <p:cNvPr id="24" name="PDF_TEXT_GROUP_166"/>
+          <p:cNvPr id="11" name="PDF_TEXT_GROUP_153"/>
           <p:cNvSpPr txBox="1"/>
           <p:nvPr/>
         </p:nvSpPr>
@@ -8119,7 +7477,7 @@
       </p:sp>
       <p:sp>
         <p:nvSpPr>
-          <p:cNvPr id="25" name="PDF_TEXT_GROUP_167"/>
+          <p:cNvPr id="12" name="PDF_TEXT_GROUP_154"/>
           <p:cNvSpPr txBox="1"/>
           <p:nvPr/>
         </p:nvSpPr>
@@ -8162,6 +7520,135 @@
               </a:rPr>
               <a:t>12/38</a:t>
             </a:r>
+          </a:p>
+        </p:txBody>
+      </p:sp>
+      <p:sp>
+        <p:nvSpPr>
+          <p:cNvPr id="13" name="PDF_BULLET_SPAN_215"/>
+          <p:cNvSpPr/>
+          <p:nvPr/>
+        </p:nvSpPr>
+        <p:spPr>
+          <a:xfrm rot="5400000">
+            <a:off x="1207424" y="2115348"/>
+            <a:ext cx="197164" cy="197164"/>
+          </a:xfrm>
+          <a:prstGeom prst="triangle">
+            <a:avLst/>
+          </a:prstGeom>
+          <a:solidFill>
+            <a:srgbClr val="1A3E79"/>
+          </a:solidFill>
+          <a:ln>
+            <a:noFill/>
+          </a:ln>
+        </p:spPr>
+        <p:style>
+          <a:lnRef idx="1">
+            <a:schemeClr val="accent1"/>
+          </a:lnRef>
+          <a:fillRef idx="3">
+            <a:schemeClr val="accent1"/>
+          </a:fillRef>
+          <a:effectRef idx="2">
+            <a:schemeClr val="accent1"/>
+          </a:effectRef>
+          <a:fontRef idx="minor">
+            <a:schemeClr val="lt1"/>
+          </a:fontRef>
+        </p:style>
+        <p:txBody>
+          <a:bodyPr rtlCol="0" anchor="ctr"/>
+          <a:lstStyle/>
+          <a:p>
+            <a:pPr algn="ctr"/>
+          </a:p>
+        </p:txBody>
+      </p:sp>
+      <p:sp>
+        <p:nvSpPr>
+          <p:cNvPr id="14" name="PDF_BULLET_SPAN_218"/>
+          <p:cNvSpPr/>
+          <p:nvPr/>
+        </p:nvSpPr>
+        <p:spPr>
+          <a:xfrm rot="5400000">
+            <a:off x="1207424" y="3087615"/>
+            <a:ext cx="197164" cy="197164"/>
+          </a:xfrm>
+          <a:prstGeom prst="triangle">
+            <a:avLst/>
+          </a:prstGeom>
+          <a:solidFill>
+            <a:srgbClr val="1A3E79"/>
+          </a:solidFill>
+          <a:ln>
+            <a:noFill/>
+          </a:ln>
+        </p:spPr>
+        <p:style>
+          <a:lnRef idx="1">
+            <a:schemeClr val="accent1"/>
+          </a:lnRef>
+          <a:fillRef idx="3">
+            <a:schemeClr val="accent1"/>
+          </a:fillRef>
+          <a:effectRef idx="2">
+            <a:schemeClr val="accent1"/>
+          </a:effectRef>
+          <a:fontRef idx="minor">
+            <a:schemeClr val="lt1"/>
+          </a:fontRef>
+        </p:style>
+        <p:txBody>
+          <a:bodyPr rtlCol="0" anchor="ctr"/>
+          <a:lstStyle/>
+          <a:p>
+            <a:pPr algn="ctr"/>
+          </a:p>
+        </p:txBody>
+      </p:sp>
+      <p:sp>
+        <p:nvSpPr>
+          <p:cNvPr id="15" name="PDF_BULLET_SPAN_221"/>
+          <p:cNvSpPr/>
+          <p:nvPr/>
+        </p:nvSpPr>
+        <p:spPr>
+          <a:xfrm rot="5400000">
+            <a:off x="1207424" y="4059882"/>
+            <a:ext cx="197164" cy="197164"/>
+          </a:xfrm>
+          <a:prstGeom prst="triangle">
+            <a:avLst/>
+          </a:prstGeom>
+          <a:solidFill>
+            <a:srgbClr val="1A3E79"/>
+          </a:solidFill>
+          <a:ln>
+            <a:noFill/>
+          </a:ln>
+        </p:spPr>
+        <p:style>
+          <a:lnRef idx="1">
+            <a:schemeClr val="accent1"/>
+          </a:lnRef>
+          <a:fillRef idx="3">
+            <a:schemeClr val="accent1"/>
+          </a:fillRef>
+          <a:effectRef idx="2">
+            <a:schemeClr val="accent1"/>
+          </a:effectRef>
+          <a:fontRef idx="minor">
+            <a:schemeClr val="lt1"/>
+          </a:fontRef>
+        </p:style>
+        <p:txBody>
+          <a:bodyPr rtlCol="0" anchor="ctr"/>
+          <a:lstStyle/>
+          <a:p>
+            <a:pPr algn="ctr"/>
           </a:p>
         </p:txBody>
       </p:sp>
@@ -8209,7 +7696,7 @@
       </p:pic>
       <p:sp>
         <p:nvSpPr>
-          <p:cNvPr id="3" name="PDF_TEXT_GROUP_168"/>
+          <p:cNvPr id="3" name="PDF_TEXT_GROUP_155"/>
           <p:cNvSpPr txBox="1"/>
           <p:nvPr/>
         </p:nvSpPr>
@@ -8250,251 +7737,884 @@
                 </a:solidFill>
                 <a:latin typeface="Latin Modern Sans"/>
               </a:rPr>
-              <a:t>Why Reuse ABE Capability for Authorization?</a:t>
-            </a:r>
-          </a:p>
-        </p:txBody>
-      </p:sp>
-      <p:sp>
-        <p:nvSpPr>
-          <p:cNvPr id="4" name="PDF_TEXT_GROUP_169"/>
-          <p:cNvSpPr txBox="1"/>
-          <p:nvPr/>
-        </p:nvSpPr>
-        <p:spPr>
-          <a:xfrm>
-            <a:off x="1618972" y="1881845"/>
-            <a:ext cx="10914134" cy="929891"/>
-          </a:xfrm>
-          <a:prstGeom prst="rect">
-            <a:avLst/>
-          </a:prstGeom>
-          <a:noFill/>
-          <a:ln>
-            <a:noFill/>
-          </a:ln>
-        </p:spPr>
-        <p:txBody>
-          <a:bodyPr wrap="square" anchor="t" lIns="0" rIns="0" tIns="0" bIns="0">
-            <a:noAutofit/>
-          </a:bodyPr>
-          <a:lstStyle/>
-          <a:p>
-            <a:pPr algn="l">
-              <a:lnSpc>
-                <a:spcPct val="100000"/>
-              </a:lnSpc>
-              <a:spcBef>
-                <a:spcPts val="0"/>
-              </a:spcBef>
-              <a:spcAft>
-                <a:spcPts val="0"/>
-              </a:spcAft>
-            </a:pPr>
-            <a:r>
-              <a:rPr sz="2710" b="0" i="0">
-                <a:solidFill>
-                  <a:srgbClr val="000000"/>
-                </a:solidFill>
-                <a:latin typeface="Latin Modern Sans"/>
-              </a:rPr>
-              <a:t>Enhanced NAC-ABE [19] supports key-policy ABE (KP-ABE): ciphertext</a:t>
-            </a:r>
-            <a:r>
-              <a:rPr sz="2710" b="0" i="0">
-                <a:solidFill>
-                  <a:srgbClr val="000000"/>
-                </a:solidFill>
-                <a:latin typeface="Latin Modern Sans"/>
-              </a:rPr>
-              <a:t> attributes meet a policy in an individually issued decryption key (DKEY).</a:t>
-            </a:r>
-          </a:p>
-        </p:txBody>
-      </p:sp>
-      <p:sp>
-        <p:nvSpPr>
-          <p:cNvPr id="5" name="PDF_TEXT_GROUP_170"/>
-          <p:cNvSpPr txBox="1"/>
-          <p:nvPr/>
-        </p:nvSpPr>
-        <p:spPr>
-          <a:xfrm>
-            <a:off x="1618972" y="2854112"/>
-            <a:ext cx="11765965" cy="929891"/>
-          </a:xfrm>
-          <a:prstGeom prst="rect">
-            <a:avLst/>
-          </a:prstGeom>
-          <a:noFill/>
-          <a:ln>
-            <a:noFill/>
-          </a:ln>
-        </p:spPr>
-        <p:txBody>
-          <a:bodyPr wrap="square" anchor="t" lIns="0" rIns="0" tIns="0" bIns="0">
-            <a:noAutofit/>
-          </a:bodyPr>
-          <a:lstStyle/>
-          <a:p>
-            <a:pPr algn="l">
-              <a:lnSpc>
-                <a:spcPct val="100000"/>
-              </a:lnSpc>
-              <a:spcBef>
-                <a:spcPts val="0"/>
-              </a:spcBef>
-              <a:spcAft>
-                <a:spcPts val="0"/>
-              </a:spcAft>
-            </a:pPr>
-            <a:r>
-              <a:rPr sz="2710" b="0" i="0">
-                <a:solidFill>
-                  <a:srgbClr val="000000"/>
-                </a:solidFill>
-                <a:latin typeface="Latin Modern Sans"/>
-              </a:rPr>
-              <a:t>Service permissions can be aggregated while identity-signing credentials remain</a:t>
-            </a:r>
-            <a:r>
-              <a:rPr sz="2710" b="0" i="0">
-                <a:solidFill>
-                  <a:srgbClr val="000000"/>
-                </a:solidFill>
-                <a:latin typeface="Latin Modern Sans"/>
-              </a:rPr>
-              <a:t> unchanged.</a:t>
-            </a:r>
-          </a:p>
-        </p:txBody>
-      </p:sp>
-      <p:sp>
-        <p:nvSpPr>
-          <p:cNvPr id="6" name="PDF_TEXT_GROUP_171"/>
-          <p:cNvSpPr txBox="1"/>
-          <p:nvPr/>
-        </p:nvSpPr>
-        <p:spPr>
-          <a:xfrm>
-            <a:off x="1618972" y="3826378"/>
-            <a:ext cx="11214449" cy="929891"/>
-          </a:xfrm>
-          <a:prstGeom prst="rect">
-            <a:avLst/>
-          </a:prstGeom>
-          <a:noFill/>
-          <a:ln>
-            <a:noFill/>
-          </a:ln>
-        </p:spPr>
-        <p:txBody>
-          <a:bodyPr wrap="square" anchor="t" lIns="0" rIns="0" tIns="0" bIns="0">
-            <a:noAutofit/>
-          </a:bodyPr>
-          <a:lstStyle/>
-          <a:p>
-            <a:pPr algn="l">
-              <a:lnSpc>
-                <a:spcPct val="100000"/>
-              </a:lnSpc>
-              <a:spcBef>
-                <a:spcPts val="0"/>
-              </a:spcBef>
-              <a:spcAft>
-                <a:spcPts val="0"/>
-              </a:spcAft>
-            </a:pPr>
-            <a:r>
-              <a:rPr sz="2710" b="0" i="0">
-                <a:solidFill>
-                  <a:srgbClr val="000000"/>
-                </a:solidFill>
-                <a:latin typeface="Latin Modern Sans"/>
-              </a:rPr>
-              <a:t>Challenges reuse those service permissions instead of introducing additional</a:t>
-            </a:r>
-            <a:r>
-              <a:rPr sz="2710" b="0" i="0">
-                <a:solidFill>
-                  <a:srgbClr val="000000"/>
-                </a:solidFill>
-                <a:latin typeface="Latin Modern Sans"/>
-              </a:rPr>
-              <a:t> service-role signing credentials.</a:t>
-            </a:r>
-          </a:p>
-        </p:txBody>
-      </p:sp>
-      <p:sp>
-        <p:nvSpPr>
-          <p:cNvPr id="7" name="PDF_TEXT_GROUP_172"/>
-          <p:cNvSpPr txBox="1"/>
-          <p:nvPr/>
-        </p:nvSpPr>
-        <p:spPr>
-          <a:xfrm>
-            <a:off x="1143656" y="5420066"/>
-            <a:ext cx="11853876" cy="1367730"/>
-          </a:xfrm>
-          <a:prstGeom prst="rect">
-            <a:avLst/>
-          </a:prstGeom>
-          <a:noFill/>
-          <a:ln>
-            <a:noFill/>
-          </a:ln>
-        </p:spPr>
-        <p:txBody>
-          <a:bodyPr wrap="square" anchor="t" lIns="0" rIns="0" tIns="0" bIns="0">
-            <a:noAutofit/>
-          </a:bodyPr>
-          <a:lstStyle/>
-          <a:p>
-            <a:pPr algn="l">
-              <a:lnSpc>
-                <a:spcPct val="100000"/>
-              </a:lnSpc>
-              <a:spcBef>
-                <a:spcPts val="0"/>
-              </a:spcBef>
-              <a:spcAft>
-                <a:spcPts val="0"/>
-              </a:spcAft>
-            </a:pPr>
-            <a:r>
-              <a:rPr sz="2710" b="0" i="0">
-                <a:solidFill>
-                  <a:srgbClr val="000000"/>
-                </a:solidFill>
-                <a:latin typeface="Latin Modern Sans"/>
-              </a:rPr>
-              <a:t>This saves a second entitlement representation in this design—not all key work.</a:t>
-            </a:r>
-            <a:r>
-              <a:rPr sz="2710" b="0" i="0">
-                <a:solidFill>
-                  <a:srgbClr val="000000"/>
-                </a:solidFill>
-                <a:latin typeface="Latin Modern Sans"/>
-              </a:rPr>
-              <a:t> User DKEYs, challenge processing, policy growth, status and rekeying still cost</a:t>
-            </a:r>
-            <a:r>
-              <a:rPr sz="2710" b="0" i="0">
-                <a:solidFill>
-                  <a:srgbClr val="000000"/>
-                </a:solidFill>
-                <a:latin typeface="Latin Modern Sans"/>
-              </a:rPr>
-              <a:t> resources.</a:t>
-            </a:r>
-          </a:p>
-        </p:txBody>
-      </p:sp>
-      <p:sp>
-        <p:nvSpPr>
-          <p:cNvPr id="8" name="PDF_TEXT_GROUP_173"/>
+              <a:t>A Fair Comparison Includes Encryption on Both Sides</a:t>
+            </a:r>
+          </a:p>
+        </p:txBody>
+      </p:sp>
+      <p:sp>
+        <p:nvSpPr>
+          <p:cNvPr id="4" name="PDF_TEXT_GROUP_156"/>
+          <p:cNvSpPr txBox="1"/>
+          <p:nvPr/>
+        </p:nvSpPr>
+        <p:spPr>
+          <a:xfrm>
+            <a:off x="1107736" y="1351581"/>
+            <a:ext cx="1082791" cy="385554"/>
+          </a:xfrm>
+          <a:prstGeom prst="rect">
+            <a:avLst/>
+          </a:prstGeom>
+          <a:noFill/>
+          <a:ln>
+            <a:noFill/>
+          </a:ln>
+        </p:spPr>
+        <p:txBody>
+          <a:bodyPr wrap="square" anchor="t" lIns="0" rIns="0" tIns="0" bIns="0">
+            <a:noAutofit/>
+          </a:bodyPr>
+          <a:lstStyle/>
+          <a:p>
+            <a:pPr algn="l">
+              <a:lnSpc>
+                <a:spcPct val="100000"/>
+              </a:lnSpc>
+              <a:spcBef>
+                <a:spcPts val="0"/>
+              </a:spcBef>
+              <a:spcAft>
+                <a:spcPts val="0"/>
+              </a:spcAft>
+            </a:pPr>
+            <a:r>
+              <a:rPr sz="2371" b="0" i="0">
+                <a:solidFill>
+                  <a:srgbClr val="000000"/>
+                </a:solidFill>
+                <a:latin typeface="Latin Modern Sans"/>
+              </a:rPr>
+              <a:t>Design</a:t>
+            </a:r>
+          </a:p>
+        </p:txBody>
+      </p:sp>
+      <p:sp>
+        <p:nvSpPr>
+          <p:cNvPr id="5" name="PDF_TEXT_GROUP_157"/>
+          <p:cNvSpPr txBox="1"/>
+          <p:nvPr/>
+        </p:nvSpPr>
+        <p:spPr>
+          <a:xfrm>
+            <a:off x="4951729" y="1351581"/>
+            <a:ext cx="3428411" cy="385554"/>
+          </a:xfrm>
+          <a:prstGeom prst="rect">
+            <a:avLst/>
+          </a:prstGeom>
+          <a:noFill/>
+          <a:ln>
+            <a:noFill/>
+          </a:ln>
+        </p:spPr>
+        <p:txBody>
+          <a:bodyPr wrap="square" anchor="t" lIns="0" rIns="0" tIns="0" bIns="0">
+            <a:noAutofit/>
+          </a:bodyPr>
+          <a:lstStyle/>
+          <a:p>
+            <a:pPr algn="l">
+              <a:lnSpc>
+                <a:spcPct val="100000"/>
+              </a:lnSpc>
+              <a:spcBef>
+                <a:spcPts val="0"/>
+              </a:spcBef>
+              <a:spcAft>
+                <a:spcPts val="0"/>
+              </a:spcAft>
+            </a:pPr>
+            <a:r>
+              <a:rPr sz="2371" b="0" i="0">
+                <a:solidFill>
+                  <a:srgbClr val="000000"/>
+                </a:solidFill>
+                <a:latin typeface="Latin Modern Sans"/>
+              </a:rPr>
+              <a:t>Execution authorization</a:t>
+            </a:r>
+          </a:p>
+        </p:txBody>
+      </p:sp>
+      <p:sp>
+        <p:nvSpPr>
+          <p:cNvPr id="6" name="PDF_TEXT_GROUP_158"/>
+          <p:cNvSpPr txBox="1"/>
+          <p:nvPr/>
+        </p:nvSpPr>
+        <p:spPr>
+          <a:xfrm>
+            <a:off x="9433494" y="1351581"/>
+            <a:ext cx="3527306" cy="385554"/>
+          </a:xfrm>
+          <a:prstGeom prst="rect">
+            <a:avLst/>
+          </a:prstGeom>
+          <a:noFill/>
+          <a:ln>
+            <a:noFill/>
+          </a:ln>
+        </p:spPr>
+        <p:txBody>
+          <a:bodyPr wrap="square" anchor="t" lIns="0" rIns="0" tIns="0" bIns="0">
+            <a:noAutofit/>
+          </a:bodyPr>
+          <a:lstStyle/>
+          <a:p>
+            <a:pPr algn="l">
+              <a:lnSpc>
+                <a:spcPct val="100000"/>
+              </a:lnSpc>
+              <a:spcBef>
+                <a:spcPts val="0"/>
+              </a:spcBef>
+              <a:spcAft>
+                <a:spcPts val="0"/>
+              </a:spcAft>
+            </a:pPr>
+            <a:r>
+              <a:rPr sz="2371" b="0" i="0">
+                <a:solidFill>
+                  <a:srgbClr val="000000"/>
+                </a:solidFill>
+                <a:latin typeface="Latin Modern Sans"/>
+              </a:rPr>
+              <a:t>Discovery confidentiality</a:t>
+            </a:r>
+          </a:p>
+        </p:txBody>
+      </p:sp>
+      <p:sp>
+        <p:nvSpPr>
+          <p:cNvPr id="7" name="PDF_TEXT_GROUP_159"/>
+          <p:cNvSpPr txBox="1"/>
+          <p:nvPr/>
+        </p:nvSpPr>
+        <p:spPr>
+          <a:xfrm>
+            <a:off x="1107736" y="1919940"/>
+            <a:ext cx="3690615" cy="385554"/>
+          </a:xfrm>
+          <a:prstGeom prst="rect">
+            <a:avLst/>
+          </a:prstGeom>
+          <a:noFill/>
+          <a:ln>
+            <a:noFill/>
+          </a:ln>
+        </p:spPr>
+        <p:txBody>
+          <a:bodyPr wrap="square" anchor="t" lIns="0" rIns="0" tIns="0" bIns="0">
+            <a:noAutofit/>
+          </a:bodyPr>
+          <a:lstStyle/>
+          <a:p>
+            <a:pPr algn="l">
+              <a:lnSpc>
+                <a:spcPct val="100000"/>
+              </a:lnSpc>
+              <a:spcBef>
+                <a:spcPts val="0"/>
+              </a:spcBef>
+              <a:spcAft>
+                <a:spcPts val="0"/>
+              </a:spcAft>
+            </a:pPr>
+            <a:r>
+              <a:rPr sz="2371" b="0" i="0">
+                <a:solidFill>
+                  <a:srgbClr val="000000"/>
+                </a:solidFill>
+                <a:latin typeface="Latin Modern Sans"/>
+              </a:rPr>
+              <a:t>DNMP-inspired roles [12]</a:t>
+            </a:r>
+          </a:p>
+        </p:txBody>
+      </p:sp>
+      <p:sp>
+        <p:nvSpPr>
+          <p:cNvPr id="8" name="PDF_TEXT_GROUP_160"/>
+          <p:cNvSpPr txBox="1"/>
+          <p:nvPr/>
+        </p:nvSpPr>
+        <p:spPr>
+          <a:xfrm>
+            <a:off x="4951633" y="1919940"/>
+            <a:ext cx="4215475" cy="385554"/>
+          </a:xfrm>
+          <a:prstGeom prst="rect">
+            <a:avLst/>
+          </a:prstGeom>
+          <a:noFill/>
+          <a:ln>
+            <a:noFill/>
+          </a:ln>
+        </p:spPr>
+        <p:txBody>
+          <a:bodyPr wrap="square" anchor="t" lIns="0" rIns="0" tIns="0" bIns="0">
+            <a:noAutofit/>
+          </a:bodyPr>
+          <a:lstStyle/>
+          <a:p>
+            <a:pPr algn="l">
+              <a:lnSpc>
+                <a:spcPct val="100000"/>
+              </a:lnSpc>
+              <a:spcBef>
+                <a:spcPts val="0"/>
+              </a:spcBef>
+              <a:spcAft>
+                <a:spcPts val="0"/>
+              </a:spcAft>
+            </a:pPr>
+            <a:r>
+              <a:rPr sz="2371" b="0" i="0">
+                <a:solidFill>
+                  <a:srgbClr val="000000"/>
+                </a:solidFill>
+                <a:latin typeface="Latin Modern Sans"/>
+              </a:rPr>
+              <a:t>Role/command signing rules,</a:t>
+            </a:r>
+          </a:p>
+        </p:txBody>
+      </p:sp>
+      <p:sp>
+        <p:nvSpPr>
+          <p:cNvPr id="9" name="PDF_TEXT_GROUP_161"/>
+          <p:cNvSpPr txBox="1"/>
+          <p:nvPr/>
+        </p:nvSpPr>
+        <p:spPr>
+          <a:xfrm>
+            <a:off x="9433445" y="1919940"/>
+            <a:ext cx="4423717" cy="385554"/>
+          </a:xfrm>
+          <a:prstGeom prst="rect">
+            <a:avLst/>
+          </a:prstGeom>
+          <a:noFill/>
+          <a:ln>
+            <a:noFill/>
+          </a:ln>
+        </p:spPr>
+        <p:txBody>
+          <a:bodyPr wrap="square" anchor="t" lIns="0" rIns="0" tIns="0" bIns="0">
+            <a:noAutofit/>
+          </a:bodyPr>
+          <a:lstStyle/>
+          <a:p>
+            <a:pPr algn="l">
+              <a:lnSpc>
+                <a:spcPct val="100000"/>
+              </a:lnSpc>
+              <a:spcBef>
+                <a:spcPts val="0"/>
+              </a:spcBef>
+              <a:spcAft>
+                <a:spcPts val="0"/>
+              </a:spcAft>
+            </a:pPr>
+            <a:r>
+              <a:rPr sz="2371" b="0" i="0">
+                <a:solidFill>
+                  <a:srgbClr val="000000"/>
+                </a:solidFill>
+                <a:latin typeface="Latin Modern Sans"/>
+              </a:rPr>
+              <a:t>Add encryption and group/key</a:t>
+            </a:r>
+          </a:p>
+        </p:txBody>
+      </p:sp>
+      <p:sp>
+        <p:nvSpPr>
+          <p:cNvPr id="10" name="PDF_TEXT_GROUP_162"/>
+          <p:cNvSpPr txBox="1"/>
+          <p:nvPr/>
+        </p:nvSpPr>
+        <p:spPr>
+          <a:xfrm>
+            <a:off x="4951637" y="2306268"/>
+            <a:ext cx="3851309" cy="828844"/>
+          </a:xfrm>
+          <a:prstGeom prst="rect">
+            <a:avLst/>
+          </a:prstGeom>
+          <a:noFill/>
+          <a:ln>
+            <a:noFill/>
+          </a:ln>
+        </p:spPr>
+        <p:txBody>
+          <a:bodyPr wrap="square" anchor="t" lIns="0" rIns="0" tIns="0" bIns="0">
+            <a:noAutofit/>
+          </a:bodyPr>
+          <a:lstStyle/>
+          <a:p>
+            <a:pPr algn="l">
+              <a:lnSpc>
+                <a:spcPct val="100000"/>
+              </a:lnSpc>
+              <a:spcBef>
+                <a:spcPts val="0"/>
+              </a:spcBef>
+              <a:spcAft>
+                <a:spcPts val="0"/>
+              </a:spcAft>
+            </a:pPr>
+            <a:r>
+              <a:rPr sz="2371" b="0" i="0">
+                <a:solidFill>
+                  <a:srgbClr val="000000"/>
+                </a:solidFill>
+                <a:latin typeface="Latin Modern Sans"/>
+              </a:rPr>
+              <a:t>credential and request-state</a:t>
+            </a:r>
+            <a:r>
+              <a:rPr sz="2371" b="0" i="0">
+                <a:solidFill>
+                  <a:srgbClr val="000000"/>
+                </a:solidFill>
+                <a:latin typeface="Latin Modern Sans"/>
+              </a:rPr>
+              <a:t> checks</a:t>
+            </a:r>
+          </a:p>
+        </p:txBody>
+      </p:sp>
+      <p:sp>
+        <p:nvSpPr>
+          <p:cNvPr id="11" name="PDF_TEXT_GROUP_163"/>
+          <p:cNvSpPr txBox="1"/>
+          <p:nvPr/>
+        </p:nvSpPr>
+        <p:spPr>
+          <a:xfrm>
+            <a:off x="9433445" y="2306268"/>
+            <a:ext cx="1701754" cy="385554"/>
+          </a:xfrm>
+          <a:prstGeom prst="rect">
+            <a:avLst/>
+          </a:prstGeom>
+          <a:noFill/>
+          <a:ln>
+            <a:noFill/>
+          </a:ln>
+        </p:spPr>
+        <p:txBody>
+          <a:bodyPr wrap="square" anchor="t" lIns="0" rIns="0" tIns="0" bIns="0">
+            <a:noAutofit/>
+          </a:bodyPr>
+          <a:lstStyle/>
+          <a:p>
+            <a:pPr algn="l">
+              <a:lnSpc>
+                <a:spcPct val="100000"/>
+              </a:lnSpc>
+              <a:spcBef>
+                <a:spcPts val="0"/>
+              </a:spcBef>
+              <a:spcAft>
+                <a:spcPts val="0"/>
+              </a:spcAft>
+            </a:pPr>
+            <a:r>
+              <a:rPr sz="2371" b="0" i="0">
+                <a:solidFill>
+                  <a:srgbClr val="000000"/>
+                </a:solidFill>
+                <a:latin typeface="Latin Modern Sans"/>
+              </a:rPr>
+              <a:t>distribution</a:t>
+            </a:r>
+          </a:p>
+        </p:txBody>
+      </p:sp>
+      <p:sp>
+        <p:nvSpPr>
+          <p:cNvPr id="12" name="PDF_TEXT_GROUP_164"/>
+          <p:cNvSpPr txBox="1"/>
+          <p:nvPr/>
+        </p:nvSpPr>
+        <p:spPr>
+          <a:xfrm>
+            <a:off x="1107736" y="3260956"/>
+            <a:ext cx="3586085" cy="828844"/>
+          </a:xfrm>
+          <a:prstGeom prst="rect">
+            <a:avLst/>
+          </a:prstGeom>
+          <a:noFill/>
+          <a:ln>
+            <a:noFill/>
+          </a:ln>
+        </p:spPr>
+        <p:txBody>
+          <a:bodyPr wrap="square" anchor="t" lIns="0" rIns="0" tIns="0" bIns="0">
+            <a:noAutofit/>
+          </a:bodyPr>
+          <a:lstStyle/>
+          <a:p>
+            <a:pPr algn="l">
+              <a:lnSpc>
+                <a:spcPct val="100000"/>
+              </a:lnSpc>
+              <a:spcBef>
+                <a:spcPts val="0"/>
+              </a:spcBef>
+              <a:spcAft>
+                <a:spcPts val="0"/>
+              </a:spcAft>
+            </a:pPr>
+            <a:r>
+              <a:rPr sz="2371" b="0" i="0">
+                <a:solidFill>
+                  <a:srgbClr val="000000"/>
+                </a:solidFill>
+                <a:latin typeface="Latin Modern Sans"/>
+              </a:rPr>
+              <a:t>Our per-service role cer-</a:t>
+            </a:r>
+            <a:r>
+              <a:rPr sz="2371" b="0" i="0">
+                <a:solidFill>
+                  <a:srgbClr val="000000"/>
+                </a:solidFill>
+                <a:latin typeface="Latin Modern Sans"/>
+              </a:rPr>
+              <a:t>tificates</a:t>
+            </a:r>
+          </a:p>
+        </p:txBody>
+      </p:sp>
+      <p:sp>
+        <p:nvSpPr>
+          <p:cNvPr id="13" name="PDF_TEXT_GROUP_165"/>
+          <p:cNvSpPr txBox="1"/>
+          <p:nvPr/>
+        </p:nvSpPr>
+        <p:spPr>
+          <a:xfrm>
+            <a:off x="4951637" y="3260956"/>
+            <a:ext cx="3857153" cy="385554"/>
+          </a:xfrm>
+          <a:prstGeom prst="rect">
+            <a:avLst/>
+          </a:prstGeom>
+          <a:noFill/>
+          <a:ln>
+            <a:noFill/>
+          </a:ln>
+        </p:spPr>
+        <p:txBody>
+          <a:bodyPr wrap="square" anchor="t" lIns="0" rIns="0" tIns="0" bIns="0">
+            <a:noAutofit/>
+          </a:bodyPr>
+          <a:lstStyle/>
+          <a:p>
+            <a:pPr algn="l">
+              <a:lnSpc>
+                <a:spcPct val="100000"/>
+              </a:lnSpc>
+              <a:spcBef>
+                <a:spcPts val="0"/>
+              </a:spcBef>
+              <a:spcAft>
+                <a:spcPts val="0"/>
+              </a:spcAft>
+            </a:pPr>
+            <a:r>
+              <a:rPr sz="2371" b="0" i="0">
+                <a:solidFill>
+                  <a:srgbClr val="000000"/>
+                </a:solidFill>
+                <a:latin typeface="Latin Modern Sans"/>
+              </a:rPr>
+              <a:t>Service/message rules plus</a:t>
+            </a:r>
+          </a:p>
+        </p:txBody>
+      </p:sp>
+      <p:sp>
+        <p:nvSpPr>
+          <p:cNvPr id="14" name="PDF_TEXT_GROUP_166"/>
+          <p:cNvSpPr txBox="1"/>
+          <p:nvPr/>
+        </p:nvSpPr>
+        <p:spPr>
+          <a:xfrm>
+            <a:off x="9433445" y="3260956"/>
+            <a:ext cx="4423717" cy="385554"/>
+          </a:xfrm>
+          <a:prstGeom prst="rect">
+            <a:avLst/>
+          </a:prstGeom>
+          <a:noFill/>
+          <a:ln>
+            <a:noFill/>
+          </a:ln>
+        </p:spPr>
+        <p:txBody>
+          <a:bodyPr wrap="square" anchor="t" lIns="0" rIns="0" tIns="0" bIns="0">
+            <a:noAutofit/>
+          </a:bodyPr>
+          <a:lstStyle/>
+          <a:p>
+            <a:pPr algn="l">
+              <a:lnSpc>
+                <a:spcPct val="100000"/>
+              </a:lnSpc>
+              <a:spcBef>
+                <a:spcPts val="0"/>
+              </a:spcBef>
+              <a:spcAft>
+                <a:spcPts val="0"/>
+              </a:spcAft>
+            </a:pPr>
+            <a:r>
+              <a:rPr sz="2371" b="0" i="0">
+                <a:solidFill>
+                  <a:srgbClr val="000000"/>
+                </a:solidFill>
+                <a:latin typeface="Latin Modern Sans"/>
+              </a:rPr>
+              <a:t>Add equivalent encryption and</a:t>
+            </a:r>
+          </a:p>
+        </p:txBody>
+      </p:sp>
+      <p:sp>
+        <p:nvSpPr>
+          <p:cNvPr id="15" name="PDF_TEXT_GROUP_167"/>
+          <p:cNvSpPr txBox="1"/>
+          <p:nvPr/>
+        </p:nvSpPr>
+        <p:spPr>
+          <a:xfrm>
+            <a:off x="4951637" y="3647284"/>
+            <a:ext cx="3998239" cy="385554"/>
+          </a:xfrm>
+          <a:prstGeom prst="rect">
+            <a:avLst/>
+          </a:prstGeom>
+          <a:noFill/>
+          <a:ln>
+            <a:noFill/>
+          </a:ln>
+        </p:spPr>
+        <p:txBody>
+          <a:bodyPr wrap="square" anchor="t" lIns="0" rIns="0" tIns="0" bIns="0">
+            <a:noAutofit/>
+          </a:bodyPr>
+          <a:lstStyle/>
+          <a:p>
+            <a:pPr algn="l">
+              <a:lnSpc>
+                <a:spcPct val="100000"/>
+              </a:lnSpc>
+              <a:spcBef>
+                <a:spcPts val="0"/>
+              </a:spcBef>
+              <a:spcAft>
+                <a:spcPts val="0"/>
+              </a:spcAft>
+            </a:pPr>
+            <a:r>
+              <a:rPr sz="2371" b="0" i="0">
+                <a:solidFill>
+                  <a:srgbClr val="000000"/>
+                </a:solidFill>
+                <a:latin typeface="Latin Modern Sans"/>
+              </a:rPr>
+              <a:t>caller or Provider credential</a:t>
+            </a:r>
+          </a:p>
+        </p:txBody>
+      </p:sp>
+      <p:sp>
+        <p:nvSpPr>
+          <p:cNvPr id="16" name="PDF_TEXT_GROUP_168"/>
+          <p:cNvSpPr txBox="1"/>
+          <p:nvPr/>
+        </p:nvSpPr>
+        <p:spPr>
+          <a:xfrm>
+            <a:off x="9433445" y="3647284"/>
+            <a:ext cx="2472170" cy="385554"/>
+          </a:xfrm>
+          <a:prstGeom prst="rect">
+            <a:avLst/>
+          </a:prstGeom>
+          <a:noFill/>
+          <a:ln>
+            <a:noFill/>
+          </a:ln>
+        </p:spPr>
+        <p:txBody>
+          <a:bodyPr wrap="square" anchor="t" lIns="0" rIns="0" tIns="0" bIns="0">
+            <a:noAutofit/>
+          </a:bodyPr>
+          <a:lstStyle/>
+          <a:p>
+            <a:pPr algn="l">
+              <a:lnSpc>
+                <a:spcPct val="100000"/>
+              </a:lnSpc>
+              <a:spcBef>
+                <a:spcPts val="0"/>
+              </a:spcBef>
+              <a:spcAft>
+                <a:spcPts val="0"/>
+              </a:spcAft>
+            </a:pPr>
+            <a:r>
+              <a:rPr sz="2371" b="0" i="0">
+                <a:solidFill>
+                  <a:srgbClr val="000000"/>
+                </a:solidFill>
+                <a:latin typeface="Latin Modern Sans"/>
+              </a:rPr>
+              <a:t>lifecycle handling</a:t>
+            </a:r>
+          </a:p>
+        </p:txBody>
+      </p:sp>
+      <p:sp>
+        <p:nvSpPr>
+          <p:cNvPr id="17" name="PDF_TEXT_GROUP_169"/>
+          <p:cNvSpPr txBox="1"/>
+          <p:nvPr/>
+        </p:nvSpPr>
+        <p:spPr>
+          <a:xfrm>
+            <a:off x="1107736" y="4215643"/>
+            <a:ext cx="3029497" cy="385554"/>
+          </a:xfrm>
+          <a:prstGeom prst="rect">
+            <a:avLst/>
+          </a:prstGeom>
+          <a:noFill/>
+          <a:ln>
+            <a:noFill/>
+          </a:ln>
+        </p:spPr>
+        <p:txBody>
+          <a:bodyPr wrap="square" anchor="t" lIns="0" rIns="0" tIns="0" bIns="0">
+            <a:noAutofit/>
+          </a:bodyPr>
+          <a:lstStyle/>
+          <a:p>
+            <a:pPr algn="l">
+              <a:lnSpc>
+                <a:spcPct val="100000"/>
+              </a:lnSpc>
+              <a:spcBef>
+                <a:spcPts val="0"/>
+              </a:spcBef>
+              <a:spcAft>
+                <a:spcPts val="0"/>
+              </a:spcAft>
+            </a:pPr>
+            <a:r>
+              <a:rPr sz="2371" b="0" i="0">
+                <a:solidFill>
+                  <a:srgbClr val="000000"/>
+                </a:solidFill>
+                <a:latin typeface="Latin Modern Sans"/>
+              </a:rPr>
+              <a:t>NDNSF ABE-backed</a:t>
+            </a:r>
+          </a:p>
+        </p:txBody>
+      </p:sp>
+      <p:sp>
+        <p:nvSpPr>
+          <p:cNvPr id="18" name="PDF_TEXT_GROUP_170"/>
+          <p:cNvSpPr txBox="1"/>
+          <p:nvPr/>
+        </p:nvSpPr>
+        <p:spPr>
+          <a:xfrm>
+            <a:off x="4951637" y="4215643"/>
+            <a:ext cx="3962070" cy="1215205"/>
+          </a:xfrm>
+          <a:prstGeom prst="rect">
+            <a:avLst/>
+          </a:prstGeom>
+          <a:noFill/>
+          <a:ln>
+            <a:noFill/>
+          </a:ln>
+        </p:spPr>
+        <p:txBody>
+          <a:bodyPr wrap="square" anchor="t" lIns="0" rIns="0" tIns="0" bIns="0">
+            <a:noAutofit/>
+          </a:bodyPr>
+          <a:lstStyle/>
+          <a:p>
+            <a:pPr algn="l">
+              <a:lnSpc>
+                <a:spcPct val="100000"/>
+              </a:lnSpc>
+              <a:spcBef>
+                <a:spcPts val="0"/>
+              </a:spcBef>
+              <a:spcAft>
+                <a:spcPts val="0"/>
+              </a:spcAft>
+            </a:pPr>
+            <a:r>
+              <a:rPr sz="2371" b="0" i="0">
+                <a:solidFill>
+                  <a:srgbClr val="000000"/>
+                </a:solidFill>
+                <a:latin typeface="Latin Modern Sans"/>
+              </a:rPr>
+              <a:t>Identity signature, encrypted</a:t>
+            </a:r>
+            <a:r>
+              <a:rPr sz="2371" b="0" i="0">
+                <a:solidFill>
+                  <a:srgbClr val="000000"/>
+                </a:solidFill>
+                <a:latin typeface="Latin Modern Sans"/>
+              </a:rPr>
+              <a:t> challenges, and</a:t>
+            </a:r>
+            <a:r>
+              <a:rPr sz="2371" b="0" i="0">
+                <a:solidFill>
+                  <a:srgbClr val="000000"/>
+                </a:solidFill>
+                <a:latin typeface="Latin Modern Sans"/>
+              </a:rPr>
+              <a:t> authorization/request state</a:t>
+            </a:r>
+          </a:p>
+        </p:txBody>
+      </p:sp>
+      <p:sp>
+        <p:nvSpPr>
+          <p:cNvPr id="19" name="PDF_TEXT_GROUP_171"/>
+          <p:cNvSpPr txBox="1"/>
+          <p:nvPr/>
+        </p:nvSpPr>
+        <p:spPr>
+          <a:xfrm>
+            <a:off x="9433445" y="4215643"/>
+            <a:ext cx="3949534" cy="828844"/>
+          </a:xfrm>
+          <a:prstGeom prst="rect">
+            <a:avLst/>
+          </a:prstGeom>
+          <a:noFill/>
+          <a:ln>
+            <a:noFill/>
+          </a:ln>
+        </p:spPr>
+        <p:txBody>
+          <a:bodyPr wrap="square" anchor="t" lIns="0" rIns="0" tIns="0" bIns="0">
+            <a:noAutofit/>
+          </a:bodyPr>
+          <a:lstStyle/>
+          <a:p>
+            <a:pPr algn="l">
+              <a:lnSpc>
+                <a:spcPct val="100000"/>
+              </a:lnSpc>
+              <a:spcBef>
+                <a:spcPts val="0"/>
+              </a:spcBef>
+              <a:spcAft>
+                <a:spcPts val="0"/>
+              </a:spcAft>
+            </a:pPr>
+            <a:r>
+              <a:rPr sz="2371" b="0" i="0">
+                <a:solidFill>
+                  <a:srgbClr val="000000"/>
+                </a:solidFill>
+                <a:latin typeface="Latin Modern Sans"/>
+              </a:rPr>
+              <a:t>Service-level ABE protection</a:t>
+            </a:r>
+            <a:r>
+              <a:rPr sz="2371" b="0" i="0">
+                <a:solidFill>
+                  <a:srgbClr val="000000"/>
+                </a:solidFill>
+                <a:latin typeface="Latin Modern Sans"/>
+              </a:rPr>
+              <a:t> of descriptor Content</a:t>
+            </a:r>
+          </a:p>
+        </p:txBody>
+      </p:sp>
+      <p:sp>
+        <p:nvSpPr>
+          <p:cNvPr id="20" name="PDF_TEXT_GROUP_172"/>
+          <p:cNvSpPr txBox="1"/>
+          <p:nvPr/>
+        </p:nvSpPr>
+        <p:spPr>
+          <a:xfrm>
+            <a:off x="1123808" y="5883236"/>
+            <a:ext cx="12276129" cy="828844"/>
+          </a:xfrm>
+          <a:prstGeom prst="rect">
+            <a:avLst/>
+          </a:prstGeom>
+          <a:noFill/>
+          <a:ln>
+            <a:noFill/>
+          </a:ln>
+        </p:spPr>
+        <p:txBody>
+          <a:bodyPr wrap="square" anchor="t" lIns="0" rIns="0" tIns="0" bIns="0">
+            <a:noAutofit/>
+          </a:bodyPr>
+          <a:lstStyle/>
+          <a:p>
+            <a:pPr algn="l">
+              <a:lnSpc>
+                <a:spcPct val="100000"/>
+              </a:lnSpc>
+              <a:spcBef>
+                <a:spcPts val="0"/>
+              </a:spcBef>
+              <a:spcAft>
+                <a:spcPts val="0"/>
+              </a:spcAft>
+            </a:pPr>
+            <a:r>
+              <a:rPr sz="2371" b="0" i="0">
+                <a:solidFill>
+                  <a:srgbClr val="000000"/>
+                </a:solidFill>
+                <a:latin typeface="Latin Modern Sans"/>
+              </a:rPr>
+              <a:t>Trust Schema [16] validates signing relationships; it alone does not encrypt Content. NAC</a:t>
+            </a:r>
+            <a:r>
+              <a:rPr sz="2371" b="0" i="0">
+                <a:solidFill>
+                  <a:srgbClr val="000000"/>
+                </a:solidFill>
+                <a:latin typeface="Latin Modern Sans"/>
+              </a:rPr>
+              <a:t> [4] also protects distributed content. ABE contributes attribute-policy-based decryption.</a:t>
+            </a:r>
+          </a:p>
+        </p:txBody>
+      </p:sp>
+      <p:sp>
+        <p:nvSpPr>
+          <p:cNvPr id="21" name="PDF_TEXT_GROUP_173"/>
           <p:cNvSpPr txBox="1"/>
           <p:nvPr/>
         </p:nvSpPr>
@@ -8542,7 +8662,7 @@
       </p:sp>
       <p:sp>
         <p:nvSpPr>
-          <p:cNvPr id="9" name="PDF_TEXT_GROUP_174"/>
+          <p:cNvPr id="22" name="PDF_TEXT_GROUP_174"/>
           <p:cNvSpPr txBox="1"/>
           <p:nvPr/>
         </p:nvSpPr>
@@ -8590,7 +8710,7 @@
       </p:sp>
       <p:sp>
         <p:nvSpPr>
-          <p:cNvPr id="10" name="PDF_TEXT_GROUP_175"/>
+          <p:cNvPr id="23" name="PDF_TEXT_GROUP_175"/>
           <p:cNvSpPr txBox="1"/>
           <p:nvPr/>
         </p:nvSpPr>
@@ -8638,7 +8758,7 @@
       </p:sp>
       <p:sp>
         <p:nvSpPr>
-          <p:cNvPr id="11" name="PDF_TEXT_GROUP_176"/>
+          <p:cNvPr id="24" name="PDF_TEXT_GROUP_176"/>
           <p:cNvSpPr txBox="1"/>
           <p:nvPr/>
         </p:nvSpPr>
@@ -8686,7 +8806,7 @@
       </p:sp>
       <p:sp>
         <p:nvSpPr>
-          <p:cNvPr id="12" name="PDF_TEXT_GROUP_177"/>
+          <p:cNvPr id="25" name="PDF_TEXT_GROUP_177"/>
           <p:cNvSpPr txBox="1"/>
           <p:nvPr/>
         </p:nvSpPr>
@@ -8729,135 +8849,6 @@
               </a:rPr>
               <a:t>13/38</a:t>
             </a:r>
-          </a:p>
-        </p:txBody>
-      </p:sp>
-      <p:sp>
-        <p:nvSpPr>
-          <p:cNvPr id="13" name="PDF_BULLET_SPAN_244"/>
-          <p:cNvSpPr/>
-          <p:nvPr/>
-        </p:nvSpPr>
-        <p:spPr>
-          <a:xfrm rot="5400000">
-            <a:off x="1207424" y="1967636"/>
-            <a:ext cx="197164" cy="197164"/>
-          </a:xfrm>
-          <a:prstGeom prst="triangle">
-            <a:avLst/>
-          </a:prstGeom>
-          <a:solidFill>
-            <a:srgbClr val="1A3E79"/>
-          </a:solidFill>
-          <a:ln>
-            <a:noFill/>
-          </a:ln>
-        </p:spPr>
-        <p:style>
-          <a:lnRef idx="1">
-            <a:schemeClr val="accent1"/>
-          </a:lnRef>
-          <a:fillRef idx="3">
-            <a:schemeClr val="accent1"/>
-          </a:fillRef>
-          <a:effectRef idx="2">
-            <a:schemeClr val="accent1"/>
-          </a:effectRef>
-          <a:fontRef idx="minor">
-            <a:schemeClr val="lt1"/>
-          </a:fontRef>
-        </p:style>
-        <p:txBody>
-          <a:bodyPr rtlCol="0" anchor="ctr"/>
-          <a:lstStyle/>
-          <a:p>
-            <a:pPr algn="ctr"/>
-          </a:p>
-        </p:txBody>
-      </p:sp>
-      <p:sp>
-        <p:nvSpPr>
-          <p:cNvPr id="14" name="PDF_BULLET_SPAN_247"/>
-          <p:cNvSpPr/>
-          <p:nvPr/>
-        </p:nvSpPr>
-        <p:spPr>
-          <a:xfrm rot="5400000">
-            <a:off x="1207424" y="2939902"/>
-            <a:ext cx="197164" cy="197164"/>
-          </a:xfrm>
-          <a:prstGeom prst="triangle">
-            <a:avLst/>
-          </a:prstGeom>
-          <a:solidFill>
-            <a:srgbClr val="1A3E79"/>
-          </a:solidFill>
-          <a:ln>
-            <a:noFill/>
-          </a:ln>
-        </p:spPr>
-        <p:style>
-          <a:lnRef idx="1">
-            <a:schemeClr val="accent1"/>
-          </a:lnRef>
-          <a:fillRef idx="3">
-            <a:schemeClr val="accent1"/>
-          </a:fillRef>
-          <a:effectRef idx="2">
-            <a:schemeClr val="accent1"/>
-          </a:effectRef>
-          <a:fontRef idx="minor">
-            <a:schemeClr val="lt1"/>
-          </a:fontRef>
-        </p:style>
-        <p:txBody>
-          <a:bodyPr rtlCol="0" anchor="ctr"/>
-          <a:lstStyle/>
-          <a:p>
-            <a:pPr algn="ctr"/>
-          </a:p>
-        </p:txBody>
-      </p:sp>
-      <p:sp>
-        <p:nvSpPr>
-          <p:cNvPr id="15" name="PDF_BULLET_SPAN_250"/>
-          <p:cNvSpPr/>
-          <p:nvPr/>
-        </p:nvSpPr>
-        <p:spPr>
-          <a:xfrm rot="5400000">
-            <a:off x="1207424" y="3912169"/>
-            <a:ext cx="197164" cy="197164"/>
-          </a:xfrm>
-          <a:prstGeom prst="triangle">
-            <a:avLst/>
-          </a:prstGeom>
-          <a:solidFill>
-            <a:srgbClr val="1A3E79"/>
-          </a:solidFill>
-          <a:ln>
-            <a:noFill/>
-          </a:ln>
-        </p:spPr>
-        <p:style>
-          <a:lnRef idx="1">
-            <a:schemeClr val="accent1"/>
-          </a:lnRef>
-          <a:fillRef idx="3">
-            <a:schemeClr val="accent1"/>
-          </a:fillRef>
-          <a:effectRef idx="2">
-            <a:schemeClr val="accent1"/>
-          </a:effectRef>
-          <a:fontRef idx="minor">
-            <a:schemeClr val="lt1"/>
-          </a:fontRef>
-        </p:style>
-        <p:txBody>
-          <a:bodyPr rtlCol="0" anchor="ctr"/>
-          <a:lstStyle/>
-          <a:p>
-            <a:pPr algn="ctr"/>
           </a:p>
         </p:txBody>
       </p:sp>
@@ -9469,7 +9460,7 @@
       </p:sp>
       <p:sp>
         <p:nvSpPr>
-          <p:cNvPr id="14" name="PDF_BULLET_SPAN_262"/>
+          <p:cNvPr id="14" name="PDF_BULLET_SPAN_261"/>
           <p:cNvSpPr/>
           <p:nvPr/>
         </p:nvSpPr>
@@ -9512,7 +9503,7 @@
       </p:sp>
       <p:sp>
         <p:nvSpPr>
-          <p:cNvPr id="15" name="PDF_BULLET_SPAN_265"/>
+          <p:cNvPr id="15" name="PDF_BULLET_SPAN_264"/>
           <p:cNvSpPr/>
           <p:nvPr/>
         </p:nvSpPr>
@@ -9555,7 +9546,7 @@
       </p:sp>
       <p:sp>
         <p:nvSpPr>
-          <p:cNvPr id="16" name="PDF_BULLET_SPAN_267"/>
+          <p:cNvPr id="16" name="PDF_BULLET_SPAN_266"/>
           <p:cNvSpPr/>
           <p:nvPr/>
         </p:nvSpPr>
@@ -9598,7 +9589,7 @@
       </p:sp>
       <p:sp>
         <p:nvSpPr>
-          <p:cNvPr id="17" name="PDF_BULLET_SPAN_270"/>
+          <p:cNvPr id="17" name="PDF_BULLET_SPAN_269"/>
           <p:cNvSpPr/>
           <p:nvPr/>
         </p:nvSpPr>
@@ -9724,7 +9715,7 @@
                 </a:solidFill>
                 <a:latin typeface="Latin Modern Sans"/>
               </a:rPr>
-              <a:t>Selected Exchanges and Permission Withdrawal</a:t>
+              <a:t>Authorization Lifecycle and Costs</a:t>
             </a:r>
           </a:p>
         </p:txBody>
@@ -9737,8 +9728,8 @@
         </p:nvSpPr>
         <p:spPr>
           <a:xfrm>
-            <a:off x="1618972" y="1846589"/>
-            <a:ext cx="12195031" cy="929891"/>
+            <a:off x="1618972" y="1832822"/>
+            <a:ext cx="12231294" cy="929891"/>
           </a:xfrm>
           <a:prstGeom prst="rect">
             <a:avLst/>
@@ -9772,7 +9763,7 @@
                 </a:solidFill>
                 <a:latin typeface="Latin Modern Sans"/>
               </a:rPr>
-              <a:t>Symmetric request-scoped keys protect input and result Content. Selection</a:t>
+              <a:t>Challenges check decryption capability; signatures, service permissions and request</a:t>
             </a:r>
             <a:r>
               <a:rPr sz="2710" b="0" i="0">
@@ -9781,7 +9772,7 @@
                 </a:solidFill>
                 <a:latin typeface="Latin Modern Sans"/>
               </a:rPr>
-              <a:t> supplies necessary keys only to the selected Provider through recipient encryption.</a:t>
+              <a:t> state still determine invocation acceptance.</a:t>
             </a:r>
           </a:p>
         </p:txBody>
@@ -9794,8 +9785,8 @@
         </p:nvSpPr>
         <p:spPr>
           <a:xfrm>
-            <a:off x="1618972" y="2818856"/>
-            <a:ext cx="11771879" cy="929891"/>
+            <a:off x="1618972" y="2805089"/>
+            <a:ext cx="11481704" cy="929891"/>
           </a:xfrm>
           <a:prstGeom prst="rect">
             <a:avLst/>
@@ -9829,7 +9820,7 @@
                 </a:solidFill>
                 <a:latin typeface="Latin Modern Sans"/>
               </a:rPr>
-              <a:t>The requesting User and selected Provider share the result key; other Users are</a:t>
+              <a:t>Request-scoped keys protect input/results. Selection delivers keys to selected</a:t>
             </a:r>
             <a:r>
               <a:rPr sz="2710" b="0" i="0">
@@ -9838,7 +9829,7 @@
                 </a:solidFill>
                 <a:latin typeface="Latin Modern Sans"/>
               </a:rPr>
-              <a:t> excluded under key-secrecy assumptions.</a:t>
+              <a:t> Providers; the requesting User retains access.</a:t>
             </a:r>
           </a:p>
         </p:txBody>
@@ -9851,8 +9842,8 @@
         </p:nvSpPr>
         <p:spPr>
           <a:xfrm>
-            <a:off x="1618972" y="3791123"/>
-            <a:ext cx="11928761" cy="929891"/>
+            <a:off x="1618972" y="3777356"/>
+            <a:ext cx="11972030" cy="929924"/>
           </a:xfrm>
           <a:prstGeom prst="rect">
             <a:avLst/>
@@ -9886,7 +9877,7 @@
                 </a:solidFill>
                 <a:latin typeface="Latin Modern Sans"/>
               </a:rPr>
-              <a:t>Controller-signed status affects authorization after retrieval and validation. ABE</a:t>
+              <a:t>Withdrawal requires retrieved, validated Controller status. Current ABE rotation</a:t>
             </a:r>
             <a:r>
               <a:rPr sz="2710" b="0" i="0">
@@ -9895,7 +9886,7 @@
                 </a:solidFill>
                 <a:latin typeface="Latin Modern Sans"/>
               </a:rPr>
-              <a:t> rotation limits subsequent encrypted exchanges.</a:t>
+              <a:t> is Controller-wide. [28]</a:t>
             </a:r>
           </a:p>
         </p:txBody>
@@ -9908,8 +9899,8 @@
         </p:nvSpPr>
         <p:spPr>
           <a:xfrm>
-            <a:off x="1143656" y="5384810"/>
-            <a:ext cx="12277309" cy="1367730"/>
+            <a:off x="1143656" y="5405460"/>
+            <a:ext cx="12278260" cy="1367730"/>
           </a:xfrm>
           <a:prstGeom prst="rect">
             <a:avLst/>
@@ -9943,7 +9934,7 @@
                 </a:solidFill>
                 <a:latin typeface="Latin Modern Sans"/>
               </a:rPr>
-              <a:t>Current rotation is Controller-wide. Disconnected revocation is not immediate; old</a:t>
+              <a:t>Lifecycle requirement, not a third advantage: measure policy/key size, challenge</a:t>
             </a:r>
             <a:r>
               <a:rPr sz="2710" b="0" i="0">
@@ -9952,7 +9943,7 @@
                 </a:solidFill>
                 <a:latin typeface="Latin Modern Sans"/>
               </a:rPr>
-              <a:t> plaintext and keys cannot be recalled. Runtime tests do not establish lower cost</a:t>
+              <a:t> cost, propagation and rekeying. No immediate disconnected revocation or recall of</a:t>
             </a:r>
             <a:r>
               <a:rPr sz="2710" b="0" i="0">
@@ -9961,7 +9952,7 @@
                 </a:solidFill>
                 <a:latin typeface="Latin Modern Sans"/>
               </a:rPr>
-              <a:t> than certificate revocation. [28]</a:t>
+              <a:t> old plaintext/keys.</a:t>
             </a:r>
           </a:p>
         </p:txBody>
@@ -10208,13 +10199,13 @@
       </p:sp>
       <p:sp>
         <p:nvSpPr>
-          <p:cNvPr id="13" name="PDF_BULLET_SPAN_281"/>
+          <p:cNvPr id="13" name="PDF_BULLET_SPAN_280"/>
           <p:cNvSpPr/>
           <p:nvPr/>
         </p:nvSpPr>
         <p:spPr>
           <a:xfrm rot="5400000">
-            <a:off x="1207424" y="1932380"/>
+            <a:off x="1207424" y="1918613"/>
             <a:ext cx="197164" cy="197164"/>
           </a:xfrm>
           <a:prstGeom prst="triangle">
@@ -10251,13 +10242,13 @@
       </p:sp>
       <p:sp>
         <p:nvSpPr>
-          <p:cNvPr id="14" name="PDF_BULLET_SPAN_284"/>
+          <p:cNvPr id="14" name="PDF_BULLET_SPAN_283"/>
           <p:cNvSpPr/>
           <p:nvPr/>
         </p:nvSpPr>
         <p:spPr>
           <a:xfrm rot="5400000">
-            <a:off x="1207424" y="2904647"/>
+            <a:off x="1207424" y="2890880"/>
             <a:ext cx="197164" cy="197164"/>
           </a:xfrm>
           <a:prstGeom prst="triangle">
@@ -10294,13 +10285,13 @@
       </p:sp>
       <p:sp>
         <p:nvSpPr>
-          <p:cNvPr id="15" name="PDF_BULLET_SPAN_287"/>
+          <p:cNvPr id="15" name="PDF_BULLET_SPAN_286"/>
           <p:cNvSpPr/>
           <p:nvPr/>
         </p:nvSpPr>
         <p:spPr>
           <a:xfrm rot="5400000">
-            <a:off x="1207424" y="3876913"/>
+            <a:off x="1207424" y="3863147"/>
             <a:ext cx="197164" cy="197164"/>
           </a:xfrm>
           <a:prstGeom prst="triangle">
@@ -10943,7 +10934,7 @@
       </p:sp>
       <p:sp>
         <p:nvSpPr>
-          <p:cNvPr id="14" name="PDF_BULLET_SPAN_299"/>
+          <p:cNvPr id="14" name="PDF_BULLET_SPAN_298"/>
           <p:cNvSpPr/>
           <p:nvPr/>
         </p:nvSpPr>
@@ -10986,7 +10977,7 @@
       </p:sp>
       <p:sp>
         <p:nvSpPr>
-          <p:cNvPr id="15" name="PDF_BULLET_SPAN_301"/>
+          <p:cNvPr id="15" name="PDF_BULLET_SPAN_300"/>
           <p:cNvSpPr/>
           <p:nvPr/>
         </p:nvSpPr>
@@ -11029,7 +11020,7 @@
       </p:sp>
       <p:sp>
         <p:nvSpPr>
-          <p:cNvPr id="16" name="PDF_BULLET_SPAN_304"/>
+          <p:cNvPr id="16" name="PDF_BULLET_SPAN_303"/>
           <p:cNvSpPr/>
           <p:nvPr/>
         </p:nvSpPr>
@@ -11072,7 +11063,7 @@
       </p:sp>
       <p:sp>
         <p:nvSpPr>
-          <p:cNvPr id="17" name="PDF_BULLET_SPAN_307"/>
+          <p:cNvPr id="17" name="PDF_BULLET_SPAN_306"/>
           <p:cNvSpPr/>
           <p:nvPr/>
         </p:nvSpPr>
@@ -16474,7 +16465,7 @@
       </p:sp>
       <p:sp>
         <p:nvSpPr>
-          <p:cNvPr id="14" name="PDF_BULLET_SPAN_416"/>
+          <p:cNvPr id="14" name="PDF_BULLET_SPAN_415"/>
           <p:cNvSpPr/>
           <p:nvPr/>
         </p:nvSpPr>
@@ -16517,7 +16508,7 @@
       </p:sp>
       <p:sp>
         <p:nvSpPr>
-          <p:cNvPr id="15" name="PDF_BULLET_SPAN_418"/>
+          <p:cNvPr id="15" name="PDF_BULLET_SPAN_417"/>
           <p:cNvSpPr/>
           <p:nvPr/>
         </p:nvSpPr>
@@ -16560,7 +16551,7 @@
       </p:sp>
       <p:sp>
         <p:nvSpPr>
-          <p:cNvPr id="16" name="PDF_BULLET_SPAN_421"/>
+          <p:cNvPr id="16" name="PDF_BULLET_SPAN_420"/>
           <p:cNvSpPr/>
           <p:nvPr/>
         </p:nvSpPr>
@@ -16603,7 +16594,7 @@
       </p:sp>
       <p:sp>
         <p:nvSpPr>
-          <p:cNvPr id="17" name="PDF_BULLET_SPAN_423"/>
+          <p:cNvPr id="17" name="PDF_BULLET_SPAN_422"/>
           <p:cNvSpPr/>
           <p:nvPr/>
         </p:nvSpPr>
@@ -17465,7 +17456,7 @@
       </p:sp>
       <p:sp>
         <p:nvSpPr>
-          <p:cNvPr id="18" name="PDF_BULLET_SPAN_442"/>
+          <p:cNvPr id="18" name="PDF_BULLET_SPAN_441"/>
           <p:cNvSpPr/>
           <p:nvPr/>
         </p:nvSpPr>
@@ -17508,7 +17499,7 @@
       </p:sp>
       <p:sp>
         <p:nvSpPr>
-          <p:cNvPr id="19" name="PDF_BULLET_SPAN_445"/>
+          <p:cNvPr id="19" name="PDF_BULLET_SPAN_444"/>
           <p:cNvSpPr/>
           <p:nvPr/>
         </p:nvSpPr>
@@ -17551,7 +17542,7 @@
       </p:sp>
       <p:sp>
         <p:nvSpPr>
-          <p:cNvPr id="20" name="PDF_BULLET_SPAN_448"/>
+          <p:cNvPr id="20" name="PDF_BULLET_SPAN_447"/>
           <p:cNvSpPr/>
           <p:nvPr/>
         </p:nvSpPr>
@@ -18191,7 +18182,7 @@
       </p:sp>
       <p:sp>
         <p:nvSpPr>
-          <p:cNvPr id="14" name="PDF_BULLET_SPAN_458"/>
+          <p:cNvPr id="14" name="PDF_BULLET_SPAN_457"/>
           <p:cNvSpPr/>
           <p:nvPr/>
         </p:nvSpPr>
@@ -18234,7 +18225,7 @@
       </p:sp>
       <p:sp>
         <p:nvSpPr>
-          <p:cNvPr id="15" name="PDF_BULLET_SPAN_461"/>
+          <p:cNvPr id="15" name="PDF_BULLET_SPAN_460"/>
           <p:cNvSpPr/>
           <p:nvPr/>
         </p:nvSpPr>
@@ -18277,7 +18268,7 @@
       </p:sp>
       <p:sp>
         <p:nvSpPr>
-          <p:cNvPr id="16" name="PDF_BULLET_SPAN_464"/>
+          <p:cNvPr id="16" name="PDF_BULLET_SPAN_463"/>
           <p:cNvSpPr/>
           <p:nvPr/>
         </p:nvSpPr>
@@ -18320,7 +18311,7 @@
       </p:sp>
       <p:sp>
         <p:nvSpPr>
-          <p:cNvPr id="17" name="PDF_BULLET_SPAN_466"/>
+          <p:cNvPr id="17" name="PDF_BULLET_SPAN_465"/>
           <p:cNvSpPr/>
           <p:nvPr/>
         </p:nvSpPr>
@@ -18978,7 +18969,7 @@
       </p:sp>
       <p:sp>
         <p:nvSpPr>
-          <p:cNvPr id="14" name="PDF_BULLET_SPAN_476"/>
+          <p:cNvPr id="14" name="PDF_BULLET_SPAN_475"/>
           <p:cNvSpPr/>
           <p:nvPr/>
         </p:nvSpPr>
@@ -19021,7 +19012,7 @@
       </p:sp>
       <p:sp>
         <p:nvSpPr>
-          <p:cNvPr id="15" name="PDF_BULLET_SPAN_479"/>
+          <p:cNvPr id="15" name="PDF_BULLET_SPAN_478"/>
           <p:cNvSpPr/>
           <p:nvPr/>
         </p:nvSpPr>
@@ -19064,7 +19055,7 @@
       </p:sp>
       <p:sp>
         <p:nvSpPr>
-          <p:cNvPr id="16" name="PDF_BULLET_SPAN_482"/>
+          <p:cNvPr id="16" name="PDF_BULLET_SPAN_481"/>
           <p:cNvSpPr/>
           <p:nvPr/>
         </p:nvSpPr>
@@ -19107,7 +19098,7 @@
       </p:sp>
       <p:sp>
         <p:nvSpPr>
-          <p:cNvPr id="17" name="PDF_BULLET_SPAN_485"/>
+          <p:cNvPr id="17" name="PDF_BULLET_SPAN_484"/>
           <p:cNvSpPr/>
           <p:nvPr/>
         </p:nvSpPr>
@@ -26782,7 +26773,7 @@
       </p:sp>
       <p:sp>
         <p:nvSpPr>
-          <p:cNvPr id="14" name="PDF_BULLET_SPAN_649"/>
+          <p:cNvPr id="14" name="PDF_BULLET_SPAN_648"/>
           <p:cNvSpPr/>
           <p:nvPr/>
         </p:nvSpPr>
@@ -26825,7 +26816,7 @@
       </p:sp>
       <p:sp>
         <p:nvSpPr>
-          <p:cNvPr id="15" name="PDF_BULLET_SPAN_653"/>
+          <p:cNvPr id="15" name="PDF_BULLET_SPAN_652"/>
           <p:cNvSpPr/>
           <p:nvPr/>
         </p:nvSpPr>
@@ -26868,7 +26859,7 @@
       </p:sp>
       <p:sp>
         <p:nvSpPr>
-          <p:cNvPr id="16" name="PDF_BULLET_SPAN_657"/>
+          <p:cNvPr id="16" name="PDF_BULLET_SPAN_656"/>
           <p:cNvSpPr/>
           <p:nvPr/>
         </p:nvSpPr>
@@ -26911,7 +26902,7 @@
       </p:sp>
       <p:sp>
         <p:nvSpPr>
-          <p:cNvPr id="17" name="PDF_BULLET_SPAN_660"/>
+          <p:cNvPr id="17" name="PDF_BULLET_SPAN_659"/>
           <p:cNvSpPr/>
           <p:nvPr/>
         </p:nvSpPr>

</xml_diff>

<commit_message>
docs: simplify proposal authorization comparison to two designs
</commit_message>
<xml_diff>
--- a/docs/PAPER/proposal-defense/slides/NDNSF_proposal_hybrid_editable.pptx
+++ b/docs/PAPER/proposal-defense/slides/NDNSF_proposal_hybrid_editable.pptx
@@ -447,7 +447,7 @@
           <a:p>
             <a:r>
               <a:rPr lang="en-US" sz="1200"/>
-              <a:t>Design Execution authorization Discovery confidentiality DNMP-inspired roles [12] Role/command signing rules, credential and request-state checks Add encryption and group/key distribution Our per-service role cer- tificates Service/message rules plus caller or Provider credential Add equivalent encryption and lifecycle handling NDNSF ABE-backed Identity signature, encrypted challenges, and authorization/request state Service-level ABE protection of descriptor Content Trust Schema [16] validates signing relationships; it alone does not encrypt Content. NAC [4] also protects distributed content. ABE contributes attribute-policy-based decryption.</a:t>
+              <a:t>Design Execution authorization Discovery confidentiality DNMP-inspired roles [12] Role/command signing rules, credential and request-state checks Add encryption and group/key distribution NDNSF ABE-backed Identity signature, encrypted challenges, and authorization/request state Service-level ABE protection of descriptor Content Trust Schema [16] validates signing relationships; it alone does not encrypt Content. NAC [4] also protects distributed content. ABE contributes attribute-policy-based decryption.</a:t>
             </a:r>
             <a:endParaRPr lang="en-US" sz="1200"/>
           </a:p>
@@ -7750,7 +7750,7 @@
         </p:nvSpPr>
         <p:spPr>
           <a:xfrm>
-            <a:off x="1107736" y="1351581"/>
+            <a:off x="1107736" y="1733449"/>
             <a:ext cx="1082791" cy="385554"/>
           </a:xfrm>
           <a:prstGeom prst="rect">
@@ -7798,7 +7798,7 @@
         </p:nvSpPr>
         <p:spPr>
           <a:xfrm>
-            <a:off x="4951729" y="1351581"/>
+            <a:off x="4951729" y="1733449"/>
             <a:ext cx="3428411" cy="385554"/>
           </a:xfrm>
           <a:prstGeom prst="rect">
@@ -7846,7 +7846,7 @@
         </p:nvSpPr>
         <p:spPr>
           <a:xfrm>
-            <a:off x="9433494" y="1351581"/>
+            <a:off x="9433494" y="1733449"/>
             <a:ext cx="3527306" cy="385554"/>
           </a:xfrm>
           <a:prstGeom prst="rect">
@@ -7894,7 +7894,7 @@
         </p:nvSpPr>
         <p:spPr>
           <a:xfrm>
-            <a:off x="1107736" y="1919940"/>
+            <a:off x="1107736" y="2301809"/>
             <a:ext cx="3690615" cy="385554"/>
           </a:xfrm>
           <a:prstGeom prst="rect">
@@ -7942,7 +7942,7 @@
         </p:nvSpPr>
         <p:spPr>
           <a:xfrm>
-            <a:off x="4951633" y="1919940"/>
+            <a:off x="4951633" y="2301809"/>
             <a:ext cx="4215475" cy="385554"/>
           </a:xfrm>
           <a:prstGeom prst="rect">
@@ -7990,7 +7990,7 @@
         </p:nvSpPr>
         <p:spPr>
           <a:xfrm>
-            <a:off x="9433445" y="1919940"/>
+            <a:off x="9433445" y="2301809"/>
             <a:ext cx="4423717" cy="385554"/>
           </a:xfrm>
           <a:prstGeom prst="rect">
@@ -8038,7 +8038,7 @@
         </p:nvSpPr>
         <p:spPr>
           <a:xfrm>
-            <a:off x="4951637" y="2306268"/>
+            <a:off x="4951637" y="2688137"/>
             <a:ext cx="3851309" cy="828844"/>
           </a:xfrm>
           <a:prstGeom prst="rect">
@@ -8095,7 +8095,7 @@
         </p:nvSpPr>
         <p:spPr>
           <a:xfrm>
-            <a:off x="9433445" y="2306268"/>
+            <a:off x="9433445" y="2688137"/>
             <a:ext cx="1701754" cy="385554"/>
           </a:xfrm>
           <a:prstGeom prst="rect">
@@ -8143,8 +8143,8 @@
         </p:nvSpPr>
         <p:spPr>
           <a:xfrm>
-            <a:off x="1107736" y="3260956"/>
-            <a:ext cx="3586085" cy="828844"/>
+            <a:off x="1107736" y="3642824"/>
+            <a:ext cx="3029497" cy="385554"/>
           </a:xfrm>
           <a:prstGeom prst="rect">
             <a:avLst/>
@@ -8178,8 +8178,47 @@
                 </a:solidFill>
                 <a:latin typeface="Latin Modern Sans"/>
               </a:rPr>
-              <a:t>Our per-service role cer-</a:t>
-            </a:r>
+              <a:t>NDNSF ABE-backed</a:t>
+            </a:r>
+          </a:p>
+        </p:txBody>
+      </p:sp>
+      <p:sp>
+        <p:nvSpPr>
+          <p:cNvPr id="13" name="PDF_TEXT_GROUP_165"/>
+          <p:cNvSpPr txBox="1"/>
+          <p:nvPr/>
+        </p:nvSpPr>
+        <p:spPr>
+          <a:xfrm>
+            <a:off x="4951637" y="3642824"/>
+            <a:ext cx="3962070" cy="1215205"/>
+          </a:xfrm>
+          <a:prstGeom prst="rect">
+            <a:avLst/>
+          </a:prstGeom>
+          <a:noFill/>
+          <a:ln>
+            <a:noFill/>
+          </a:ln>
+        </p:spPr>
+        <p:txBody>
+          <a:bodyPr wrap="square" anchor="t" lIns="0" rIns="0" tIns="0" bIns="0">
+            <a:noAutofit/>
+          </a:bodyPr>
+          <a:lstStyle/>
+          <a:p>
+            <a:pPr algn="l">
+              <a:lnSpc>
+                <a:spcPct val="100000"/>
+              </a:lnSpc>
+              <a:spcBef>
+                <a:spcPts val="0"/>
+              </a:spcBef>
+              <a:spcAft>
+                <a:spcPts val="0"/>
+              </a:spcAft>
+            </a:pPr>
             <a:r>
               <a:rPr sz="2371" b="0" i="0">
                 <a:solidFill>
@@ -8187,47 +8226,8 @@
                 </a:solidFill>
                 <a:latin typeface="Latin Modern Sans"/>
               </a:rPr>
-              <a:t>tificates</a:t>
-            </a:r>
-          </a:p>
-        </p:txBody>
-      </p:sp>
-      <p:sp>
-        <p:nvSpPr>
-          <p:cNvPr id="13" name="PDF_TEXT_GROUP_165"/>
-          <p:cNvSpPr txBox="1"/>
-          <p:nvPr/>
-        </p:nvSpPr>
-        <p:spPr>
-          <a:xfrm>
-            <a:off x="4951637" y="3260956"/>
-            <a:ext cx="3857153" cy="385554"/>
-          </a:xfrm>
-          <a:prstGeom prst="rect">
-            <a:avLst/>
-          </a:prstGeom>
-          <a:noFill/>
-          <a:ln>
-            <a:noFill/>
-          </a:ln>
-        </p:spPr>
-        <p:txBody>
-          <a:bodyPr wrap="square" anchor="t" lIns="0" rIns="0" tIns="0" bIns="0">
-            <a:noAutofit/>
-          </a:bodyPr>
-          <a:lstStyle/>
-          <a:p>
-            <a:pPr algn="l">
-              <a:lnSpc>
-                <a:spcPct val="100000"/>
-              </a:lnSpc>
-              <a:spcBef>
-                <a:spcPts val="0"/>
-              </a:spcBef>
-              <a:spcAft>
-                <a:spcPts val="0"/>
-              </a:spcAft>
-            </a:pPr>
+              <a:t>Identity signature, encrypted</a:t>
+            </a:r>
             <a:r>
               <a:rPr sz="2371" b="0" i="0">
                 <a:solidFill>
@@ -8235,7 +8235,16 @@
                 </a:solidFill>
                 <a:latin typeface="Latin Modern Sans"/>
               </a:rPr>
-              <a:t>Service/message rules plus</a:t>
+              <a:t> challenges, and</a:t>
+            </a:r>
+            <a:r>
+              <a:rPr sz="2371" b="0" i="0">
+                <a:solidFill>
+                  <a:srgbClr val="000000"/>
+                </a:solidFill>
+                <a:latin typeface="Latin Modern Sans"/>
+              </a:rPr>
+              <a:t> authorization/request state</a:t>
             </a:r>
           </a:p>
         </p:txBody>
@@ -8248,8 +8257,8 @@
         </p:nvSpPr>
         <p:spPr>
           <a:xfrm>
-            <a:off x="9433445" y="3260956"/>
-            <a:ext cx="4423717" cy="385554"/>
+            <a:off x="9433445" y="3642824"/>
+            <a:ext cx="3949534" cy="828877"/>
           </a:xfrm>
           <a:prstGeom prst="rect">
             <a:avLst/>
@@ -8283,7 +8292,16 @@
                 </a:solidFill>
                 <a:latin typeface="Latin Modern Sans"/>
               </a:rPr>
-              <a:t>Add equivalent encryption and</a:t>
+              <a:t>Service-level ABE protection</a:t>
+            </a:r>
+            <a:r>
+              <a:rPr sz="2371" b="0" i="0">
+                <a:solidFill>
+                  <a:srgbClr val="000000"/>
+                </a:solidFill>
+                <a:latin typeface="Latin Modern Sans"/>
+              </a:rPr>
+              <a:t> of descriptor Content</a:t>
             </a:r>
           </a:p>
         </p:txBody>
@@ -8296,8 +8314,8 @@
         </p:nvSpPr>
         <p:spPr>
           <a:xfrm>
-            <a:off x="4951637" y="3647284"/>
-            <a:ext cx="3998239" cy="385554"/>
+            <a:off x="1123808" y="5310417"/>
+            <a:ext cx="12276129" cy="828844"/>
           </a:xfrm>
           <a:prstGeom prst="rect">
             <a:avLst/>
@@ -8331,7 +8349,16 @@
                 </a:solidFill>
                 <a:latin typeface="Latin Modern Sans"/>
               </a:rPr>
-              <a:t>caller or Provider credential</a:t>
+              <a:t>Trust Schema [16] validates signing relationships; it alone does not encrypt Content. NAC</a:t>
+            </a:r>
+            <a:r>
+              <a:rPr sz="2371" b="0" i="0">
+                <a:solidFill>
+                  <a:srgbClr val="000000"/>
+                </a:solidFill>
+                <a:latin typeface="Latin Modern Sans"/>
+              </a:rPr>
+              <a:t> [4] also protects distributed content. ABE contributes attribute-policy-based decryption.</a:t>
             </a:r>
           </a:p>
         </p:txBody>
@@ -8339,282 +8366,6 @@
       <p:sp>
         <p:nvSpPr>
           <p:cNvPr id="16" name="PDF_TEXT_GROUP_168"/>
-          <p:cNvSpPr txBox="1"/>
-          <p:nvPr/>
-        </p:nvSpPr>
-        <p:spPr>
-          <a:xfrm>
-            <a:off x="9433445" y="3647284"/>
-            <a:ext cx="2472170" cy="385554"/>
-          </a:xfrm>
-          <a:prstGeom prst="rect">
-            <a:avLst/>
-          </a:prstGeom>
-          <a:noFill/>
-          <a:ln>
-            <a:noFill/>
-          </a:ln>
-        </p:spPr>
-        <p:txBody>
-          <a:bodyPr wrap="square" anchor="t" lIns="0" rIns="0" tIns="0" bIns="0">
-            <a:noAutofit/>
-          </a:bodyPr>
-          <a:lstStyle/>
-          <a:p>
-            <a:pPr algn="l">
-              <a:lnSpc>
-                <a:spcPct val="100000"/>
-              </a:lnSpc>
-              <a:spcBef>
-                <a:spcPts val="0"/>
-              </a:spcBef>
-              <a:spcAft>
-                <a:spcPts val="0"/>
-              </a:spcAft>
-            </a:pPr>
-            <a:r>
-              <a:rPr sz="2371" b="0" i="0">
-                <a:solidFill>
-                  <a:srgbClr val="000000"/>
-                </a:solidFill>
-                <a:latin typeface="Latin Modern Sans"/>
-              </a:rPr>
-              <a:t>lifecycle handling</a:t>
-            </a:r>
-          </a:p>
-        </p:txBody>
-      </p:sp>
-      <p:sp>
-        <p:nvSpPr>
-          <p:cNvPr id="17" name="PDF_TEXT_GROUP_169"/>
-          <p:cNvSpPr txBox="1"/>
-          <p:nvPr/>
-        </p:nvSpPr>
-        <p:spPr>
-          <a:xfrm>
-            <a:off x="1107736" y="4215643"/>
-            <a:ext cx="3029497" cy="385554"/>
-          </a:xfrm>
-          <a:prstGeom prst="rect">
-            <a:avLst/>
-          </a:prstGeom>
-          <a:noFill/>
-          <a:ln>
-            <a:noFill/>
-          </a:ln>
-        </p:spPr>
-        <p:txBody>
-          <a:bodyPr wrap="square" anchor="t" lIns="0" rIns="0" tIns="0" bIns="0">
-            <a:noAutofit/>
-          </a:bodyPr>
-          <a:lstStyle/>
-          <a:p>
-            <a:pPr algn="l">
-              <a:lnSpc>
-                <a:spcPct val="100000"/>
-              </a:lnSpc>
-              <a:spcBef>
-                <a:spcPts val="0"/>
-              </a:spcBef>
-              <a:spcAft>
-                <a:spcPts val="0"/>
-              </a:spcAft>
-            </a:pPr>
-            <a:r>
-              <a:rPr sz="2371" b="0" i="0">
-                <a:solidFill>
-                  <a:srgbClr val="000000"/>
-                </a:solidFill>
-                <a:latin typeface="Latin Modern Sans"/>
-              </a:rPr>
-              <a:t>NDNSF ABE-backed</a:t>
-            </a:r>
-          </a:p>
-        </p:txBody>
-      </p:sp>
-      <p:sp>
-        <p:nvSpPr>
-          <p:cNvPr id="18" name="PDF_TEXT_GROUP_170"/>
-          <p:cNvSpPr txBox="1"/>
-          <p:nvPr/>
-        </p:nvSpPr>
-        <p:spPr>
-          <a:xfrm>
-            <a:off x="4951637" y="4215643"/>
-            <a:ext cx="3962070" cy="1215205"/>
-          </a:xfrm>
-          <a:prstGeom prst="rect">
-            <a:avLst/>
-          </a:prstGeom>
-          <a:noFill/>
-          <a:ln>
-            <a:noFill/>
-          </a:ln>
-        </p:spPr>
-        <p:txBody>
-          <a:bodyPr wrap="square" anchor="t" lIns="0" rIns="0" tIns="0" bIns="0">
-            <a:noAutofit/>
-          </a:bodyPr>
-          <a:lstStyle/>
-          <a:p>
-            <a:pPr algn="l">
-              <a:lnSpc>
-                <a:spcPct val="100000"/>
-              </a:lnSpc>
-              <a:spcBef>
-                <a:spcPts val="0"/>
-              </a:spcBef>
-              <a:spcAft>
-                <a:spcPts val="0"/>
-              </a:spcAft>
-            </a:pPr>
-            <a:r>
-              <a:rPr sz="2371" b="0" i="0">
-                <a:solidFill>
-                  <a:srgbClr val="000000"/>
-                </a:solidFill>
-                <a:latin typeface="Latin Modern Sans"/>
-              </a:rPr>
-              <a:t>Identity signature, encrypted</a:t>
-            </a:r>
-            <a:r>
-              <a:rPr sz="2371" b="0" i="0">
-                <a:solidFill>
-                  <a:srgbClr val="000000"/>
-                </a:solidFill>
-                <a:latin typeface="Latin Modern Sans"/>
-              </a:rPr>
-              <a:t> challenges, and</a:t>
-            </a:r>
-            <a:r>
-              <a:rPr sz="2371" b="0" i="0">
-                <a:solidFill>
-                  <a:srgbClr val="000000"/>
-                </a:solidFill>
-                <a:latin typeface="Latin Modern Sans"/>
-              </a:rPr>
-              <a:t> authorization/request state</a:t>
-            </a:r>
-          </a:p>
-        </p:txBody>
-      </p:sp>
-      <p:sp>
-        <p:nvSpPr>
-          <p:cNvPr id="19" name="PDF_TEXT_GROUP_171"/>
-          <p:cNvSpPr txBox="1"/>
-          <p:nvPr/>
-        </p:nvSpPr>
-        <p:spPr>
-          <a:xfrm>
-            <a:off x="9433445" y="4215643"/>
-            <a:ext cx="3949534" cy="828844"/>
-          </a:xfrm>
-          <a:prstGeom prst="rect">
-            <a:avLst/>
-          </a:prstGeom>
-          <a:noFill/>
-          <a:ln>
-            <a:noFill/>
-          </a:ln>
-        </p:spPr>
-        <p:txBody>
-          <a:bodyPr wrap="square" anchor="t" lIns="0" rIns="0" tIns="0" bIns="0">
-            <a:noAutofit/>
-          </a:bodyPr>
-          <a:lstStyle/>
-          <a:p>
-            <a:pPr algn="l">
-              <a:lnSpc>
-                <a:spcPct val="100000"/>
-              </a:lnSpc>
-              <a:spcBef>
-                <a:spcPts val="0"/>
-              </a:spcBef>
-              <a:spcAft>
-                <a:spcPts val="0"/>
-              </a:spcAft>
-            </a:pPr>
-            <a:r>
-              <a:rPr sz="2371" b="0" i="0">
-                <a:solidFill>
-                  <a:srgbClr val="000000"/>
-                </a:solidFill>
-                <a:latin typeface="Latin Modern Sans"/>
-              </a:rPr>
-              <a:t>Service-level ABE protection</a:t>
-            </a:r>
-            <a:r>
-              <a:rPr sz="2371" b="0" i="0">
-                <a:solidFill>
-                  <a:srgbClr val="000000"/>
-                </a:solidFill>
-                <a:latin typeface="Latin Modern Sans"/>
-              </a:rPr>
-              <a:t> of descriptor Content</a:t>
-            </a:r>
-          </a:p>
-        </p:txBody>
-      </p:sp>
-      <p:sp>
-        <p:nvSpPr>
-          <p:cNvPr id="20" name="PDF_TEXT_GROUP_172"/>
-          <p:cNvSpPr txBox="1"/>
-          <p:nvPr/>
-        </p:nvSpPr>
-        <p:spPr>
-          <a:xfrm>
-            <a:off x="1123808" y="5883236"/>
-            <a:ext cx="12276129" cy="828844"/>
-          </a:xfrm>
-          <a:prstGeom prst="rect">
-            <a:avLst/>
-          </a:prstGeom>
-          <a:noFill/>
-          <a:ln>
-            <a:noFill/>
-          </a:ln>
-        </p:spPr>
-        <p:txBody>
-          <a:bodyPr wrap="square" anchor="t" lIns="0" rIns="0" tIns="0" bIns="0">
-            <a:noAutofit/>
-          </a:bodyPr>
-          <a:lstStyle/>
-          <a:p>
-            <a:pPr algn="l">
-              <a:lnSpc>
-                <a:spcPct val="100000"/>
-              </a:lnSpc>
-              <a:spcBef>
-                <a:spcPts val="0"/>
-              </a:spcBef>
-              <a:spcAft>
-                <a:spcPts val="0"/>
-              </a:spcAft>
-            </a:pPr>
-            <a:r>
-              <a:rPr sz="2371" b="0" i="0">
-                <a:solidFill>
-                  <a:srgbClr val="000000"/>
-                </a:solidFill>
-                <a:latin typeface="Latin Modern Sans"/>
-              </a:rPr>
-              <a:t>Trust Schema [16] validates signing relationships; it alone does not encrypt Content. NAC</a:t>
-            </a:r>
-            <a:r>
-              <a:rPr sz="2371" b="0" i="0">
-                <a:solidFill>
-                  <a:srgbClr val="000000"/>
-                </a:solidFill>
-                <a:latin typeface="Latin Modern Sans"/>
-              </a:rPr>
-              <a:t> [4] also protects distributed content. ABE contributes attribute-policy-based decryption.</a:t>
-            </a:r>
-          </a:p>
-        </p:txBody>
-      </p:sp>
-      <p:sp>
-        <p:nvSpPr>
-          <p:cNvPr id="21" name="PDF_TEXT_GROUP_173"/>
           <p:cNvSpPr txBox="1"/>
           <p:nvPr/>
         </p:nvSpPr>
@@ -8662,7 +8413,7 @@
       </p:sp>
       <p:sp>
         <p:nvSpPr>
-          <p:cNvPr id="22" name="PDF_TEXT_GROUP_174"/>
+          <p:cNvPr id="17" name="PDF_TEXT_GROUP_169"/>
           <p:cNvSpPr txBox="1"/>
           <p:nvPr/>
         </p:nvSpPr>
@@ -8710,7 +8461,7 @@
       </p:sp>
       <p:sp>
         <p:nvSpPr>
-          <p:cNvPr id="23" name="PDF_TEXT_GROUP_175"/>
+          <p:cNvPr id="18" name="PDF_TEXT_GROUP_170"/>
           <p:cNvSpPr txBox="1"/>
           <p:nvPr/>
         </p:nvSpPr>
@@ -8758,7 +8509,7 @@
       </p:sp>
       <p:sp>
         <p:nvSpPr>
-          <p:cNvPr id="24" name="PDF_TEXT_GROUP_176"/>
+          <p:cNvPr id="19" name="PDF_TEXT_GROUP_171"/>
           <p:cNvSpPr txBox="1"/>
           <p:nvPr/>
         </p:nvSpPr>
@@ -8806,7 +8557,7 @@
       </p:sp>
       <p:sp>
         <p:nvSpPr>
-          <p:cNvPr id="25" name="PDF_TEXT_GROUP_177"/>
+          <p:cNvPr id="20" name="PDF_TEXT_GROUP_172"/>
           <p:cNvSpPr txBox="1"/>
           <p:nvPr/>
         </p:nvSpPr>
@@ -8896,7 +8647,7 @@
       </p:pic>
       <p:sp>
         <p:nvSpPr>
-          <p:cNvPr id="3" name="PDF_TEXT_GROUP_178"/>
+          <p:cNvPr id="3" name="PDF_TEXT_GROUP_173"/>
           <p:cNvSpPr txBox="1"/>
           <p:nvPr/>
         </p:nvSpPr>
@@ -8944,7 +8695,7 @@
       </p:sp>
       <p:sp>
         <p:nvSpPr>
-          <p:cNvPr id="4" name="PDF_TEXT_GROUP_179"/>
+          <p:cNvPr id="4" name="PDF_TEXT_GROUP_174"/>
           <p:cNvSpPr txBox="1"/>
           <p:nvPr/>
         </p:nvSpPr>
@@ -9001,7 +8752,7 @@
       </p:sp>
       <p:sp>
         <p:nvSpPr>
-          <p:cNvPr id="5" name="PDF_TEXT_GROUP_180"/>
+          <p:cNvPr id="5" name="PDF_TEXT_GROUP_175"/>
           <p:cNvSpPr txBox="1"/>
           <p:nvPr/>
         </p:nvSpPr>
@@ -9049,7 +8800,7 @@
       </p:sp>
       <p:sp>
         <p:nvSpPr>
-          <p:cNvPr id="6" name="PDF_TEXT_GROUP_181"/>
+          <p:cNvPr id="6" name="PDF_TEXT_GROUP_176"/>
           <p:cNvSpPr txBox="1"/>
           <p:nvPr/>
         </p:nvSpPr>
@@ -9106,7 +8857,7 @@
       </p:sp>
       <p:sp>
         <p:nvSpPr>
-          <p:cNvPr id="7" name="PDF_TEXT_GROUP_182"/>
+          <p:cNvPr id="7" name="PDF_TEXT_GROUP_177"/>
           <p:cNvSpPr txBox="1"/>
           <p:nvPr/>
         </p:nvSpPr>
@@ -9163,7 +8914,7 @@
       </p:sp>
       <p:sp>
         <p:nvSpPr>
-          <p:cNvPr id="8" name="PDF_TEXT_GROUP_183"/>
+          <p:cNvPr id="8" name="PDF_TEXT_GROUP_178"/>
           <p:cNvSpPr txBox="1"/>
           <p:nvPr/>
         </p:nvSpPr>
@@ -9220,7 +8971,7 @@
       </p:sp>
       <p:sp>
         <p:nvSpPr>
-          <p:cNvPr id="9" name="PDF_TEXT_GROUP_184"/>
+          <p:cNvPr id="9" name="PDF_TEXT_GROUP_179"/>
           <p:cNvSpPr txBox="1"/>
           <p:nvPr/>
         </p:nvSpPr>
@@ -9268,7 +9019,7 @@
       </p:sp>
       <p:sp>
         <p:nvSpPr>
-          <p:cNvPr id="10" name="PDF_TEXT_GROUP_185"/>
+          <p:cNvPr id="10" name="PDF_TEXT_GROUP_180"/>
           <p:cNvSpPr txBox="1"/>
           <p:nvPr/>
         </p:nvSpPr>
@@ -9316,7 +9067,7 @@
       </p:sp>
       <p:sp>
         <p:nvSpPr>
-          <p:cNvPr id="11" name="PDF_TEXT_GROUP_186"/>
+          <p:cNvPr id="11" name="PDF_TEXT_GROUP_181"/>
           <p:cNvSpPr txBox="1"/>
           <p:nvPr/>
         </p:nvSpPr>
@@ -9364,7 +9115,7 @@
       </p:sp>
       <p:sp>
         <p:nvSpPr>
-          <p:cNvPr id="12" name="PDF_TEXT_GROUP_187"/>
+          <p:cNvPr id="12" name="PDF_TEXT_GROUP_182"/>
           <p:cNvSpPr txBox="1"/>
           <p:nvPr/>
         </p:nvSpPr>
@@ -9412,7 +9163,7 @@
       </p:sp>
       <p:sp>
         <p:nvSpPr>
-          <p:cNvPr id="13" name="PDF_TEXT_GROUP_188"/>
+          <p:cNvPr id="13" name="PDF_TEXT_GROUP_183"/>
           <p:cNvSpPr txBox="1"/>
           <p:nvPr/>
         </p:nvSpPr>
@@ -9460,7 +9211,7 @@
       </p:sp>
       <p:sp>
         <p:nvSpPr>
-          <p:cNvPr id="14" name="PDF_BULLET_SPAN_261"/>
+          <p:cNvPr id="14" name="PDF_BULLET_SPAN_255"/>
           <p:cNvSpPr/>
           <p:nvPr/>
         </p:nvSpPr>
@@ -9503,7 +9254,7 @@
       </p:sp>
       <p:sp>
         <p:nvSpPr>
-          <p:cNvPr id="15" name="PDF_BULLET_SPAN_264"/>
+          <p:cNvPr id="15" name="PDF_BULLET_SPAN_258"/>
           <p:cNvSpPr/>
           <p:nvPr/>
         </p:nvSpPr>
@@ -9546,7 +9297,7 @@
       </p:sp>
       <p:sp>
         <p:nvSpPr>
-          <p:cNvPr id="16" name="PDF_BULLET_SPAN_266"/>
+          <p:cNvPr id="16" name="PDF_BULLET_SPAN_260"/>
           <p:cNvSpPr/>
           <p:nvPr/>
         </p:nvSpPr>
@@ -9589,7 +9340,7 @@
       </p:sp>
       <p:sp>
         <p:nvSpPr>
-          <p:cNvPr id="17" name="PDF_BULLET_SPAN_269"/>
+          <p:cNvPr id="17" name="PDF_BULLET_SPAN_263"/>
           <p:cNvSpPr/>
           <p:nvPr/>
         </p:nvSpPr>
@@ -9674,7 +9425,7 @@
       </p:pic>
       <p:sp>
         <p:nvSpPr>
-          <p:cNvPr id="3" name="PDF_TEXT_GROUP_189"/>
+          <p:cNvPr id="3" name="PDF_TEXT_GROUP_184"/>
           <p:cNvSpPr txBox="1"/>
           <p:nvPr/>
         </p:nvSpPr>
@@ -9722,7 +9473,7 @@
       </p:sp>
       <p:sp>
         <p:nvSpPr>
-          <p:cNvPr id="4" name="PDF_TEXT_GROUP_190"/>
+          <p:cNvPr id="4" name="PDF_TEXT_GROUP_185"/>
           <p:cNvSpPr txBox="1"/>
           <p:nvPr/>
         </p:nvSpPr>
@@ -9779,7 +9530,7 @@
       </p:sp>
       <p:sp>
         <p:nvSpPr>
-          <p:cNvPr id="5" name="PDF_TEXT_GROUP_191"/>
+          <p:cNvPr id="5" name="PDF_TEXT_GROUP_186"/>
           <p:cNvSpPr txBox="1"/>
           <p:nvPr/>
         </p:nvSpPr>
@@ -9836,7 +9587,7 @@
       </p:sp>
       <p:sp>
         <p:nvSpPr>
-          <p:cNvPr id="6" name="PDF_TEXT_GROUP_192"/>
+          <p:cNvPr id="6" name="PDF_TEXT_GROUP_187"/>
           <p:cNvSpPr txBox="1"/>
           <p:nvPr/>
         </p:nvSpPr>
@@ -9893,7 +9644,7 @@
       </p:sp>
       <p:sp>
         <p:nvSpPr>
-          <p:cNvPr id="7" name="PDF_TEXT_GROUP_193"/>
+          <p:cNvPr id="7" name="PDF_TEXT_GROUP_188"/>
           <p:cNvSpPr txBox="1"/>
           <p:nvPr/>
         </p:nvSpPr>
@@ -9959,7 +9710,7 @@
       </p:sp>
       <p:sp>
         <p:nvSpPr>
-          <p:cNvPr id="8" name="PDF_TEXT_GROUP_194"/>
+          <p:cNvPr id="8" name="PDF_TEXT_GROUP_189"/>
           <p:cNvSpPr txBox="1"/>
           <p:nvPr/>
         </p:nvSpPr>
@@ -10007,7 +9758,7 @@
       </p:sp>
       <p:sp>
         <p:nvSpPr>
-          <p:cNvPr id="9" name="PDF_TEXT_GROUP_195"/>
+          <p:cNvPr id="9" name="PDF_TEXT_GROUP_190"/>
           <p:cNvSpPr txBox="1"/>
           <p:nvPr/>
         </p:nvSpPr>
@@ -10055,7 +9806,7 @@
       </p:sp>
       <p:sp>
         <p:nvSpPr>
-          <p:cNvPr id="10" name="PDF_TEXT_GROUP_196"/>
+          <p:cNvPr id="10" name="PDF_TEXT_GROUP_191"/>
           <p:cNvSpPr txBox="1"/>
           <p:nvPr/>
         </p:nvSpPr>
@@ -10103,7 +9854,7 @@
       </p:sp>
       <p:sp>
         <p:nvSpPr>
-          <p:cNvPr id="11" name="PDF_TEXT_GROUP_197"/>
+          <p:cNvPr id="11" name="PDF_TEXT_GROUP_192"/>
           <p:cNvSpPr txBox="1"/>
           <p:nvPr/>
         </p:nvSpPr>
@@ -10151,7 +9902,7 @@
       </p:sp>
       <p:sp>
         <p:nvSpPr>
-          <p:cNvPr id="12" name="PDF_TEXT_GROUP_198"/>
+          <p:cNvPr id="12" name="PDF_TEXT_GROUP_193"/>
           <p:cNvSpPr txBox="1"/>
           <p:nvPr/>
         </p:nvSpPr>
@@ -10199,7 +9950,7 @@
       </p:sp>
       <p:sp>
         <p:nvSpPr>
-          <p:cNvPr id="13" name="PDF_BULLET_SPAN_280"/>
+          <p:cNvPr id="13" name="PDF_BULLET_SPAN_274"/>
           <p:cNvSpPr/>
           <p:nvPr/>
         </p:nvSpPr>
@@ -10242,7 +9993,7 @@
       </p:sp>
       <p:sp>
         <p:nvSpPr>
-          <p:cNvPr id="14" name="PDF_BULLET_SPAN_283"/>
+          <p:cNvPr id="14" name="PDF_BULLET_SPAN_277"/>
           <p:cNvSpPr/>
           <p:nvPr/>
         </p:nvSpPr>
@@ -10285,7 +10036,7 @@
       </p:sp>
       <p:sp>
         <p:nvSpPr>
-          <p:cNvPr id="15" name="PDF_BULLET_SPAN_286"/>
+          <p:cNvPr id="15" name="PDF_BULLET_SPAN_280"/>
           <p:cNvSpPr/>
           <p:nvPr/>
         </p:nvSpPr>
@@ -10370,7 +10121,7 @@
       </p:pic>
       <p:sp>
         <p:nvSpPr>
-          <p:cNvPr id="3" name="PDF_TEXT_GROUP_199"/>
+          <p:cNvPr id="3" name="PDF_TEXT_GROUP_194"/>
           <p:cNvSpPr txBox="1"/>
           <p:nvPr/>
         </p:nvSpPr>
@@ -10418,7 +10169,7 @@
       </p:sp>
       <p:sp>
         <p:nvSpPr>
-          <p:cNvPr id="4" name="PDF_TEXT_GROUP_200"/>
+          <p:cNvPr id="4" name="PDF_TEXT_GROUP_195"/>
           <p:cNvSpPr txBox="1"/>
           <p:nvPr/>
         </p:nvSpPr>
@@ -10466,7 +10217,7 @@
       </p:sp>
       <p:sp>
         <p:nvSpPr>
-          <p:cNvPr id="5" name="PDF_TEXT_GROUP_201"/>
+          <p:cNvPr id="5" name="PDF_TEXT_GROUP_196"/>
           <p:cNvSpPr txBox="1"/>
           <p:nvPr/>
         </p:nvSpPr>
@@ -10523,7 +10274,7 @@
       </p:sp>
       <p:sp>
         <p:nvSpPr>
-          <p:cNvPr id="6" name="PDF_TEXT_GROUP_202"/>
+          <p:cNvPr id="6" name="PDF_TEXT_GROUP_197"/>
           <p:cNvSpPr txBox="1"/>
           <p:nvPr/>
         </p:nvSpPr>
@@ -10580,7 +10331,7 @@
       </p:sp>
       <p:sp>
         <p:nvSpPr>
-          <p:cNvPr id="7" name="PDF_TEXT_GROUP_203"/>
+          <p:cNvPr id="7" name="PDF_TEXT_GROUP_198"/>
           <p:cNvSpPr txBox="1"/>
           <p:nvPr/>
         </p:nvSpPr>
@@ -10637,7 +10388,7 @@
       </p:sp>
       <p:sp>
         <p:nvSpPr>
-          <p:cNvPr id="8" name="PDF_TEXT_GROUP_204"/>
+          <p:cNvPr id="8" name="PDF_TEXT_GROUP_199"/>
           <p:cNvSpPr txBox="1"/>
           <p:nvPr/>
         </p:nvSpPr>
@@ -10694,7 +10445,7 @@
       </p:sp>
       <p:sp>
         <p:nvSpPr>
-          <p:cNvPr id="9" name="PDF_TEXT_GROUP_205"/>
+          <p:cNvPr id="9" name="PDF_TEXT_GROUP_200"/>
           <p:cNvSpPr txBox="1"/>
           <p:nvPr/>
         </p:nvSpPr>
@@ -10742,7 +10493,7 @@
       </p:sp>
       <p:sp>
         <p:nvSpPr>
-          <p:cNvPr id="10" name="PDF_TEXT_GROUP_206"/>
+          <p:cNvPr id="10" name="PDF_TEXT_GROUP_201"/>
           <p:cNvSpPr txBox="1"/>
           <p:nvPr/>
         </p:nvSpPr>
@@ -10790,7 +10541,7 @@
       </p:sp>
       <p:sp>
         <p:nvSpPr>
-          <p:cNvPr id="11" name="PDF_TEXT_GROUP_207"/>
+          <p:cNvPr id="11" name="PDF_TEXT_GROUP_202"/>
           <p:cNvSpPr txBox="1"/>
           <p:nvPr/>
         </p:nvSpPr>
@@ -10838,7 +10589,7 @@
       </p:sp>
       <p:sp>
         <p:nvSpPr>
-          <p:cNvPr id="12" name="PDF_TEXT_GROUP_208"/>
+          <p:cNvPr id="12" name="PDF_TEXT_GROUP_203"/>
           <p:cNvSpPr txBox="1"/>
           <p:nvPr/>
         </p:nvSpPr>
@@ -10886,7 +10637,7 @@
       </p:sp>
       <p:sp>
         <p:nvSpPr>
-          <p:cNvPr id="13" name="PDF_TEXT_GROUP_209"/>
+          <p:cNvPr id="13" name="PDF_TEXT_GROUP_204"/>
           <p:cNvSpPr txBox="1"/>
           <p:nvPr/>
         </p:nvSpPr>
@@ -10934,7 +10685,7 @@
       </p:sp>
       <p:sp>
         <p:nvSpPr>
-          <p:cNvPr id="14" name="PDF_BULLET_SPAN_298"/>
+          <p:cNvPr id="14" name="PDF_BULLET_SPAN_292"/>
           <p:cNvSpPr/>
           <p:nvPr/>
         </p:nvSpPr>
@@ -10977,7 +10728,7 @@
       </p:sp>
       <p:sp>
         <p:nvSpPr>
-          <p:cNvPr id="15" name="PDF_BULLET_SPAN_300"/>
+          <p:cNvPr id="15" name="PDF_BULLET_SPAN_294"/>
           <p:cNvSpPr/>
           <p:nvPr/>
         </p:nvSpPr>
@@ -11020,7 +10771,7 @@
       </p:sp>
       <p:sp>
         <p:nvSpPr>
-          <p:cNvPr id="16" name="PDF_BULLET_SPAN_303"/>
+          <p:cNvPr id="16" name="PDF_BULLET_SPAN_297"/>
           <p:cNvSpPr/>
           <p:nvPr/>
         </p:nvSpPr>
@@ -11063,7 +10814,7 @@
       </p:sp>
       <p:sp>
         <p:nvSpPr>
-          <p:cNvPr id="17" name="PDF_BULLET_SPAN_306"/>
+          <p:cNvPr id="17" name="PDF_BULLET_SPAN_300"/>
           <p:cNvSpPr/>
           <p:nvPr/>
         </p:nvSpPr>
@@ -11148,7 +10899,7 @@
       </p:pic>
       <p:sp>
         <p:nvSpPr>
-          <p:cNvPr id="3" name="PDF_TEXT_GROUP_210"/>
+          <p:cNvPr id="3" name="PDF_TEXT_GROUP_205"/>
           <p:cNvSpPr txBox="1"/>
           <p:nvPr/>
         </p:nvSpPr>
@@ -11196,7 +10947,7 @@
       </p:sp>
       <p:sp>
         <p:nvSpPr>
-          <p:cNvPr id="4" name="PDF_TEXT_GROUP_211"/>
+          <p:cNvPr id="4" name="PDF_TEXT_GROUP_206"/>
           <p:cNvSpPr txBox="1"/>
           <p:nvPr/>
         </p:nvSpPr>
@@ -11262,7 +11013,7 @@
       </p:sp>
       <p:sp>
         <p:nvSpPr>
-          <p:cNvPr id="5" name="PDF_TEXT_GROUP_212"/>
+          <p:cNvPr id="5" name="PDF_TEXT_GROUP_207"/>
           <p:cNvSpPr txBox="1"/>
           <p:nvPr/>
         </p:nvSpPr>
@@ -11319,7 +11070,7 @@
       </p:sp>
       <p:sp>
         <p:nvSpPr>
-          <p:cNvPr id="6" name="PDF_TEXT_GROUP_213"/>
+          <p:cNvPr id="6" name="PDF_TEXT_GROUP_208"/>
           <p:cNvSpPr txBox="1"/>
           <p:nvPr/>
         </p:nvSpPr>
@@ -11376,7 +11127,7 @@
       </p:sp>
       <p:sp>
         <p:nvSpPr>
-          <p:cNvPr id="7" name="PDF_TEXT_GROUP_214"/>
+          <p:cNvPr id="7" name="PDF_TEXT_GROUP_209"/>
           <p:cNvSpPr txBox="1"/>
           <p:nvPr/>
         </p:nvSpPr>
@@ -11442,7 +11193,7 @@
       </p:sp>
       <p:sp>
         <p:nvSpPr>
-          <p:cNvPr id="8" name="PDF_TEXT_GROUP_215"/>
+          <p:cNvPr id="8" name="PDF_TEXT_GROUP_210"/>
           <p:cNvSpPr txBox="1"/>
           <p:nvPr/>
         </p:nvSpPr>
@@ -11499,7 +11250,7 @@
       </p:sp>
       <p:sp>
         <p:nvSpPr>
-          <p:cNvPr id="9" name="PDF_TEXT_GROUP_216"/>
+          <p:cNvPr id="9" name="PDF_TEXT_GROUP_211"/>
           <p:cNvSpPr txBox="1"/>
           <p:nvPr/>
         </p:nvSpPr>
@@ -11547,7 +11298,7 @@
       </p:sp>
       <p:sp>
         <p:nvSpPr>
-          <p:cNvPr id="10" name="PDF_TEXT_GROUP_217"/>
+          <p:cNvPr id="10" name="PDF_TEXT_GROUP_212"/>
           <p:cNvSpPr txBox="1"/>
           <p:nvPr/>
         </p:nvSpPr>
@@ -11595,7 +11346,7 @@
       </p:sp>
       <p:sp>
         <p:nvSpPr>
-          <p:cNvPr id="11" name="PDF_TEXT_GROUP_218"/>
+          <p:cNvPr id="11" name="PDF_TEXT_GROUP_213"/>
           <p:cNvSpPr txBox="1"/>
           <p:nvPr/>
         </p:nvSpPr>
@@ -11643,7 +11394,7 @@
       </p:sp>
       <p:sp>
         <p:nvSpPr>
-          <p:cNvPr id="12" name="PDF_TEXT_GROUP_219"/>
+          <p:cNvPr id="12" name="PDF_TEXT_GROUP_214"/>
           <p:cNvSpPr txBox="1"/>
           <p:nvPr/>
         </p:nvSpPr>
@@ -11691,7 +11442,7 @@
       </p:sp>
       <p:sp>
         <p:nvSpPr>
-          <p:cNvPr id="13" name="PDF_TEXT_GROUP_220"/>
+          <p:cNvPr id="13" name="PDF_TEXT_GROUP_215"/>
           <p:cNvSpPr txBox="1"/>
           <p:nvPr/>
         </p:nvSpPr>
@@ -11781,7 +11532,7 @@
       </p:pic>
       <p:sp>
         <p:nvSpPr>
-          <p:cNvPr id="3" name="PDF_TEXT_GROUP_221"/>
+          <p:cNvPr id="3" name="PDF_TEXT_GROUP_216"/>
           <p:cNvSpPr txBox="1"/>
           <p:nvPr/>
         </p:nvSpPr>
@@ -11829,7 +11580,7 @@
       </p:sp>
       <p:sp>
         <p:nvSpPr>
-          <p:cNvPr id="4" name="PDF_TEXT_GROUP_222"/>
+          <p:cNvPr id="4" name="PDF_TEXT_GROUP_217"/>
           <p:cNvSpPr txBox="1"/>
           <p:nvPr/>
         </p:nvSpPr>
@@ -11877,7 +11628,7 @@
       </p:sp>
       <p:sp>
         <p:nvSpPr>
-          <p:cNvPr id="5" name="PDF_TEXT_GROUP_223"/>
+          <p:cNvPr id="5" name="PDF_TEXT_GROUP_218"/>
           <p:cNvSpPr txBox="1"/>
           <p:nvPr/>
         </p:nvSpPr>
@@ -11925,7 +11676,7 @@
       </p:sp>
       <p:sp>
         <p:nvSpPr>
-          <p:cNvPr id="6" name="PDF_TEXT_GROUP_224"/>
+          <p:cNvPr id="6" name="PDF_TEXT_GROUP_219"/>
           <p:cNvSpPr txBox="1"/>
           <p:nvPr/>
         </p:nvSpPr>
@@ -11973,7 +11724,7 @@
       </p:sp>
       <p:sp>
         <p:nvSpPr>
-          <p:cNvPr id="7" name="PDF_TEXT_GROUP_225"/>
+          <p:cNvPr id="7" name="PDF_TEXT_GROUP_220"/>
           <p:cNvSpPr txBox="1"/>
           <p:nvPr/>
         </p:nvSpPr>
@@ -12021,7 +11772,7 @@
       </p:sp>
       <p:sp>
         <p:nvSpPr>
-          <p:cNvPr id="8" name="PDF_TEXT_GROUP_226"/>
+          <p:cNvPr id="8" name="PDF_TEXT_GROUP_221"/>
           <p:cNvSpPr txBox="1"/>
           <p:nvPr/>
         </p:nvSpPr>
@@ -12078,7 +11829,7 @@
       </p:sp>
       <p:sp>
         <p:nvSpPr>
-          <p:cNvPr id="9" name="PDF_TEXT_GROUP_227"/>
+          <p:cNvPr id="9" name="PDF_TEXT_GROUP_222"/>
           <p:cNvSpPr txBox="1"/>
           <p:nvPr/>
         </p:nvSpPr>
@@ -12135,7 +11886,7 @@
       </p:sp>
       <p:sp>
         <p:nvSpPr>
-          <p:cNvPr id="10" name="PDF_TEXT_GROUP_228"/>
+          <p:cNvPr id="10" name="PDF_TEXT_GROUP_223"/>
           <p:cNvSpPr txBox="1"/>
           <p:nvPr/>
         </p:nvSpPr>
@@ -12192,7 +11943,7 @@
       </p:sp>
       <p:sp>
         <p:nvSpPr>
-          <p:cNvPr id="11" name="PDF_TEXT_GROUP_229"/>
+          <p:cNvPr id="11" name="PDF_TEXT_GROUP_224"/>
           <p:cNvSpPr txBox="1"/>
           <p:nvPr/>
         </p:nvSpPr>
@@ -12249,7 +12000,7 @@
       </p:sp>
       <p:sp>
         <p:nvSpPr>
-          <p:cNvPr id="12" name="PDF_TEXT_GROUP_230"/>
+          <p:cNvPr id="12" name="PDF_TEXT_GROUP_225"/>
           <p:cNvSpPr txBox="1"/>
           <p:nvPr/>
         </p:nvSpPr>
@@ -12306,7 +12057,7 @@
       </p:sp>
       <p:sp>
         <p:nvSpPr>
-          <p:cNvPr id="13" name="PDF_TEXT_GROUP_231"/>
+          <p:cNvPr id="13" name="PDF_TEXT_GROUP_226"/>
           <p:cNvSpPr txBox="1"/>
           <p:nvPr/>
         </p:nvSpPr>
@@ -12354,7 +12105,7 @@
       </p:sp>
       <p:sp>
         <p:nvSpPr>
-          <p:cNvPr id="14" name="PDF_TEXT_GROUP_232"/>
+          <p:cNvPr id="14" name="PDF_TEXT_GROUP_227"/>
           <p:cNvSpPr txBox="1"/>
           <p:nvPr/>
         </p:nvSpPr>
@@ -12402,7 +12153,7 @@
       </p:sp>
       <p:sp>
         <p:nvSpPr>
-          <p:cNvPr id="15" name="PDF_TEXT_GROUP_233"/>
+          <p:cNvPr id="15" name="PDF_TEXT_GROUP_228"/>
           <p:cNvSpPr txBox="1"/>
           <p:nvPr/>
         </p:nvSpPr>
@@ -12450,7 +12201,7 @@
       </p:sp>
       <p:sp>
         <p:nvSpPr>
-          <p:cNvPr id="16" name="PDF_TEXT_GROUP_234"/>
+          <p:cNvPr id="16" name="PDF_TEXT_GROUP_229"/>
           <p:cNvSpPr txBox="1"/>
           <p:nvPr/>
         </p:nvSpPr>
@@ -12498,7 +12249,7 @@
       </p:sp>
       <p:sp>
         <p:nvSpPr>
-          <p:cNvPr id="17" name="PDF_TEXT_GROUP_235"/>
+          <p:cNvPr id="17" name="PDF_TEXT_GROUP_230"/>
           <p:cNvSpPr txBox="1"/>
           <p:nvPr/>
         </p:nvSpPr>
@@ -12588,7 +12339,7 @@
       </p:pic>
       <p:sp>
         <p:nvSpPr>
-          <p:cNvPr id="3" name="PDF_TEXT_GROUP_236"/>
+          <p:cNvPr id="3" name="PDF_TEXT_GROUP_231"/>
           <p:cNvSpPr txBox="1"/>
           <p:nvPr/>
         </p:nvSpPr>
@@ -12636,7 +12387,7 @@
       </p:sp>
       <p:sp>
         <p:nvSpPr>
-          <p:cNvPr id="4" name="PDF_TEXT_GROUP_237"/>
+          <p:cNvPr id="4" name="PDF_TEXT_GROUP_232"/>
           <p:cNvSpPr txBox="1"/>
           <p:nvPr/>
         </p:nvSpPr>
@@ -12693,7 +12444,7 @@
       </p:sp>
       <p:sp>
         <p:nvSpPr>
-          <p:cNvPr id="5" name="PDF_TEXT_GROUP_238"/>
+          <p:cNvPr id="5" name="PDF_TEXT_GROUP_233"/>
           <p:cNvSpPr txBox="1"/>
           <p:nvPr/>
         </p:nvSpPr>
@@ -12750,7 +12501,7 @@
       </p:sp>
       <p:sp>
         <p:nvSpPr>
-          <p:cNvPr id="6" name="PDF_TEXT_GROUP_239"/>
+          <p:cNvPr id="6" name="PDF_TEXT_GROUP_234"/>
           <p:cNvSpPr txBox="1"/>
           <p:nvPr/>
         </p:nvSpPr>
@@ -12807,7 +12558,7 @@
       </p:sp>
       <p:sp>
         <p:nvSpPr>
-          <p:cNvPr id="7" name="PDF_TEXT_GROUP_240"/>
+          <p:cNvPr id="7" name="PDF_TEXT_GROUP_235"/>
           <p:cNvSpPr txBox="1"/>
           <p:nvPr/>
         </p:nvSpPr>
@@ -12864,7 +12615,7 @@
       </p:sp>
       <p:sp>
         <p:nvSpPr>
-          <p:cNvPr id="8" name="PDF_TEXT_GROUP_241"/>
+          <p:cNvPr id="8" name="PDF_TEXT_GROUP_236"/>
           <p:cNvSpPr txBox="1"/>
           <p:nvPr/>
         </p:nvSpPr>
@@ -12921,7 +12672,7 @@
       </p:sp>
       <p:sp>
         <p:nvSpPr>
-          <p:cNvPr id="9" name="PDF_TEXT_GROUP_242"/>
+          <p:cNvPr id="9" name="PDF_TEXT_GROUP_237"/>
           <p:cNvSpPr txBox="1"/>
           <p:nvPr/>
         </p:nvSpPr>
@@ -12978,7 +12729,7 @@
       </p:sp>
       <p:sp>
         <p:nvSpPr>
-          <p:cNvPr id="10" name="PDF_TEXT_GROUP_243"/>
+          <p:cNvPr id="10" name="PDF_TEXT_GROUP_238"/>
           <p:cNvSpPr txBox="1"/>
           <p:nvPr/>
         </p:nvSpPr>
@@ -13026,7 +12777,7 @@
       </p:sp>
       <p:sp>
         <p:nvSpPr>
-          <p:cNvPr id="11" name="PDF_TEXT_GROUP_244"/>
+          <p:cNvPr id="11" name="PDF_TEXT_GROUP_239"/>
           <p:cNvSpPr txBox="1"/>
           <p:nvPr/>
         </p:nvSpPr>
@@ -13074,7 +12825,7 @@
       </p:sp>
       <p:sp>
         <p:nvSpPr>
-          <p:cNvPr id="12" name="PDF_TEXT_GROUP_245"/>
+          <p:cNvPr id="12" name="PDF_TEXT_GROUP_240"/>
           <p:cNvSpPr txBox="1"/>
           <p:nvPr/>
         </p:nvSpPr>
@@ -13122,7 +12873,7 @@
       </p:sp>
       <p:sp>
         <p:nvSpPr>
-          <p:cNvPr id="13" name="PDF_TEXT_GROUP_246"/>
+          <p:cNvPr id="13" name="PDF_TEXT_GROUP_241"/>
           <p:cNvSpPr txBox="1"/>
           <p:nvPr/>
         </p:nvSpPr>
@@ -13170,7 +12921,7 @@
       </p:sp>
       <p:sp>
         <p:nvSpPr>
-          <p:cNvPr id="14" name="PDF_TEXT_GROUP_247"/>
+          <p:cNvPr id="14" name="PDF_TEXT_GROUP_242"/>
           <p:cNvSpPr txBox="1"/>
           <p:nvPr/>
         </p:nvSpPr>
@@ -14278,7 +14029,7 @@
       </p:pic>
       <p:sp>
         <p:nvSpPr>
-          <p:cNvPr id="3" name="PDF_TEXT_GROUP_248"/>
+          <p:cNvPr id="3" name="PDF_TEXT_GROUP_243"/>
           <p:cNvSpPr txBox="1"/>
           <p:nvPr/>
         </p:nvSpPr>
@@ -14326,7 +14077,7 @@
       </p:sp>
       <p:sp>
         <p:nvSpPr>
-          <p:cNvPr id="4" name="PDF_TEXT_GROUP_249"/>
+          <p:cNvPr id="4" name="PDF_TEXT_GROUP_244"/>
           <p:cNvSpPr txBox="1"/>
           <p:nvPr/>
         </p:nvSpPr>
@@ -14374,7 +14125,7 @@
       </p:sp>
       <p:sp>
         <p:nvSpPr>
-          <p:cNvPr id="5" name="PDF_TEXT_GROUP_250"/>
+          <p:cNvPr id="5" name="PDF_TEXT_GROUP_245"/>
           <p:cNvSpPr txBox="1"/>
           <p:nvPr/>
         </p:nvSpPr>
@@ -14422,7 +14173,7 @@
       </p:sp>
       <p:sp>
         <p:nvSpPr>
-          <p:cNvPr id="6" name="PDF_TEXT_GROUP_251"/>
+          <p:cNvPr id="6" name="PDF_TEXT_GROUP_246"/>
           <p:cNvSpPr txBox="1"/>
           <p:nvPr/>
         </p:nvSpPr>
@@ -14470,7 +14221,7 @@
       </p:sp>
       <p:sp>
         <p:nvSpPr>
-          <p:cNvPr id="7" name="PDF_TEXT_GROUP_252"/>
+          <p:cNvPr id="7" name="PDF_TEXT_GROUP_247"/>
           <p:cNvSpPr txBox="1"/>
           <p:nvPr/>
         </p:nvSpPr>
@@ -14518,7 +14269,7 @@
       </p:sp>
       <p:sp>
         <p:nvSpPr>
-          <p:cNvPr id="8" name="PDF_TEXT_GROUP_253"/>
+          <p:cNvPr id="8" name="PDF_TEXT_GROUP_248"/>
           <p:cNvSpPr txBox="1"/>
           <p:nvPr/>
         </p:nvSpPr>
@@ -14566,7 +14317,7 @@
       </p:sp>
       <p:sp>
         <p:nvSpPr>
-          <p:cNvPr id="9" name="PDF_TEXT_GROUP_254"/>
+          <p:cNvPr id="9" name="PDF_TEXT_GROUP_249"/>
           <p:cNvSpPr txBox="1"/>
           <p:nvPr/>
         </p:nvSpPr>
@@ -14623,7 +14374,7 @@
       </p:sp>
       <p:sp>
         <p:nvSpPr>
-          <p:cNvPr id="10" name="PDF_TEXT_GROUP_255"/>
+          <p:cNvPr id="10" name="PDF_TEXT_GROUP_250"/>
           <p:cNvSpPr txBox="1"/>
           <p:nvPr/>
         </p:nvSpPr>
@@ -14671,7 +14422,7 @@
       </p:sp>
       <p:sp>
         <p:nvSpPr>
-          <p:cNvPr id="11" name="PDF_TEXT_GROUP_256"/>
+          <p:cNvPr id="11" name="PDF_TEXT_GROUP_251"/>
           <p:cNvSpPr txBox="1"/>
           <p:nvPr/>
         </p:nvSpPr>
@@ -14728,7 +14479,7 @@
       </p:sp>
       <p:sp>
         <p:nvSpPr>
-          <p:cNvPr id="12" name="PDF_TEXT_GROUP_257"/>
+          <p:cNvPr id="12" name="PDF_TEXT_GROUP_252"/>
           <p:cNvSpPr txBox="1"/>
           <p:nvPr/>
         </p:nvSpPr>
@@ -14776,7 +14527,7 @@
       </p:sp>
       <p:sp>
         <p:nvSpPr>
-          <p:cNvPr id="13" name="PDF_TEXT_GROUP_258"/>
+          <p:cNvPr id="13" name="PDF_TEXT_GROUP_253"/>
           <p:cNvSpPr txBox="1"/>
           <p:nvPr/>
         </p:nvSpPr>
@@ -14833,7 +14584,7 @@
       </p:sp>
       <p:sp>
         <p:nvSpPr>
-          <p:cNvPr id="14" name="PDF_TEXT_GROUP_259"/>
+          <p:cNvPr id="14" name="PDF_TEXT_GROUP_254"/>
           <p:cNvSpPr txBox="1"/>
           <p:nvPr/>
         </p:nvSpPr>
@@ -14881,7 +14632,7 @@
       </p:sp>
       <p:sp>
         <p:nvSpPr>
-          <p:cNvPr id="15" name="PDF_TEXT_GROUP_260"/>
+          <p:cNvPr id="15" name="PDF_TEXT_GROUP_255"/>
           <p:cNvSpPr txBox="1"/>
           <p:nvPr/>
         </p:nvSpPr>
@@ -14929,7 +14680,7 @@
       </p:sp>
       <p:sp>
         <p:nvSpPr>
-          <p:cNvPr id="16" name="PDF_TEXT_GROUP_261"/>
+          <p:cNvPr id="16" name="PDF_TEXT_GROUP_256"/>
           <p:cNvSpPr txBox="1"/>
           <p:nvPr/>
         </p:nvSpPr>
@@ -14986,7 +14737,7 @@
       </p:sp>
       <p:sp>
         <p:nvSpPr>
-          <p:cNvPr id="17" name="PDF_TEXT_GROUP_262"/>
+          <p:cNvPr id="17" name="PDF_TEXT_GROUP_257"/>
           <p:cNvSpPr txBox="1"/>
           <p:nvPr/>
         </p:nvSpPr>
@@ -15034,7 +14785,7 @@
       </p:sp>
       <p:sp>
         <p:nvSpPr>
-          <p:cNvPr id="18" name="PDF_TEXT_GROUP_263"/>
+          <p:cNvPr id="18" name="PDF_TEXT_GROUP_258"/>
           <p:cNvSpPr txBox="1"/>
           <p:nvPr/>
         </p:nvSpPr>
@@ -15082,7 +14833,7 @@
       </p:sp>
       <p:sp>
         <p:nvSpPr>
-          <p:cNvPr id="19" name="PDF_TEXT_GROUP_264"/>
+          <p:cNvPr id="19" name="PDF_TEXT_GROUP_259"/>
           <p:cNvSpPr txBox="1"/>
           <p:nvPr/>
         </p:nvSpPr>
@@ -15130,7 +14881,7 @@
       </p:sp>
       <p:sp>
         <p:nvSpPr>
-          <p:cNvPr id="20" name="PDF_TEXT_GROUP_265"/>
+          <p:cNvPr id="20" name="PDF_TEXT_GROUP_260"/>
           <p:cNvSpPr txBox="1"/>
           <p:nvPr/>
         </p:nvSpPr>
@@ -15178,7 +14929,7 @@
       </p:sp>
       <p:sp>
         <p:nvSpPr>
-          <p:cNvPr id="21" name="PDF_TEXT_GROUP_266"/>
+          <p:cNvPr id="21" name="PDF_TEXT_GROUP_261"/>
           <p:cNvSpPr txBox="1"/>
           <p:nvPr/>
         </p:nvSpPr>
@@ -15268,7 +15019,7 @@
       </p:pic>
       <p:sp>
         <p:nvSpPr>
-          <p:cNvPr id="3" name="PDF_TEXT_GROUP_267"/>
+          <p:cNvPr id="3" name="PDF_TEXT_GROUP_262"/>
           <p:cNvSpPr txBox="1"/>
           <p:nvPr/>
         </p:nvSpPr>
@@ -15316,7 +15067,7 @@
       </p:sp>
       <p:sp>
         <p:nvSpPr>
-          <p:cNvPr id="4" name="PDF_TEXT_GROUP_268"/>
+          <p:cNvPr id="4" name="PDF_TEXT_GROUP_263"/>
           <p:cNvSpPr txBox="1"/>
           <p:nvPr/>
         </p:nvSpPr>
@@ -15382,7 +15133,7 @@
       </p:sp>
       <p:sp>
         <p:nvSpPr>
-          <p:cNvPr id="5" name="PDF_TEXT_GROUP_269"/>
+          <p:cNvPr id="5" name="PDF_TEXT_GROUP_264"/>
           <p:cNvSpPr txBox="1"/>
           <p:nvPr/>
         </p:nvSpPr>
@@ -15448,7 +15199,7 @@
       </p:sp>
       <p:sp>
         <p:nvSpPr>
-          <p:cNvPr id="6" name="PDF_TEXT_GROUP_270"/>
+          <p:cNvPr id="6" name="PDF_TEXT_GROUP_265"/>
           <p:cNvSpPr txBox="1"/>
           <p:nvPr/>
         </p:nvSpPr>
@@ -15514,7 +15265,7 @@
       </p:sp>
       <p:sp>
         <p:nvSpPr>
-          <p:cNvPr id="7" name="PDF_TEXT_GROUP_271"/>
+          <p:cNvPr id="7" name="PDF_TEXT_GROUP_266"/>
           <p:cNvSpPr txBox="1"/>
           <p:nvPr/>
         </p:nvSpPr>
@@ -15571,7 +15322,7 @@
       </p:sp>
       <p:sp>
         <p:nvSpPr>
-          <p:cNvPr id="8" name="PDF_TEXT_GROUP_272"/>
+          <p:cNvPr id="8" name="PDF_TEXT_GROUP_267"/>
           <p:cNvSpPr txBox="1"/>
           <p:nvPr/>
         </p:nvSpPr>
@@ -15628,7 +15379,7 @@
       </p:sp>
       <p:sp>
         <p:nvSpPr>
-          <p:cNvPr id="9" name="PDF_TEXT_GROUP_273"/>
+          <p:cNvPr id="9" name="PDF_TEXT_GROUP_268"/>
           <p:cNvSpPr txBox="1"/>
           <p:nvPr/>
         </p:nvSpPr>
@@ -15676,7 +15427,7 @@
       </p:sp>
       <p:sp>
         <p:nvSpPr>
-          <p:cNvPr id="10" name="PDF_TEXT_GROUP_274"/>
+          <p:cNvPr id="10" name="PDF_TEXT_GROUP_269"/>
           <p:cNvSpPr txBox="1"/>
           <p:nvPr/>
         </p:nvSpPr>
@@ -15724,7 +15475,7 @@
       </p:sp>
       <p:sp>
         <p:nvSpPr>
-          <p:cNvPr id="11" name="PDF_TEXT_GROUP_275"/>
+          <p:cNvPr id="11" name="PDF_TEXT_GROUP_270"/>
           <p:cNvSpPr txBox="1"/>
           <p:nvPr/>
         </p:nvSpPr>
@@ -15772,7 +15523,7 @@
       </p:sp>
       <p:sp>
         <p:nvSpPr>
-          <p:cNvPr id="12" name="PDF_TEXT_GROUP_276"/>
+          <p:cNvPr id="12" name="PDF_TEXT_GROUP_271"/>
           <p:cNvSpPr txBox="1"/>
           <p:nvPr/>
         </p:nvSpPr>
@@ -15820,7 +15571,7 @@
       </p:sp>
       <p:sp>
         <p:nvSpPr>
-          <p:cNvPr id="13" name="PDF_TEXT_GROUP_277"/>
+          <p:cNvPr id="13" name="PDF_TEXT_GROUP_272"/>
           <p:cNvSpPr txBox="1"/>
           <p:nvPr/>
         </p:nvSpPr>
@@ -15910,7 +15661,7 @@
       </p:pic>
       <p:sp>
         <p:nvSpPr>
-          <p:cNvPr id="3" name="PDF_TEXT_GROUP_278"/>
+          <p:cNvPr id="3" name="PDF_TEXT_GROUP_273"/>
           <p:cNvSpPr txBox="1"/>
           <p:nvPr/>
         </p:nvSpPr>
@@ -15958,7 +15709,7 @@
       </p:sp>
       <p:sp>
         <p:nvSpPr>
-          <p:cNvPr id="4" name="PDF_TEXT_GROUP_279"/>
+          <p:cNvPr id="4" name="PDF_TEXT_GROUP_274"/>
           <p:cNvSpPr txBox="1"/>
           <p:nvPr/>
         </p:nvSpPr>
@@ -16006,7 +15757,7 @@
       </p:sp>
       <p:sp>
         <p:nvSpPr>
-          <p:cNvPr id="5" name="PDF_TEXT_GROUP_280"/>
+          <p:cNvPr id="5" name="PDF_TEXT_GROUP_275"/>
           <p:cNvSpPr txBox="1"/>
           <p:nvPr/>
         </p:nvSpPr>
@@ -16063,7 +15814,7 @@
       </p:sp>
       <p:sp>
         <p:nvSpPr>
-          <p:cNvPr id="6" name="PDF_TEXT_GROUP_281"/>
+          <p:cNvPr id="6" name="PDF_TEXT_GROUP_276"/>
           <p:cNvSpPr txBox="1"/>
           <p:nvPr/>
         </p:nvSpPr>
@@ -16111,7 +15862,7 @@
       </p:sp>
       <p:sp>
         <p:nvSpPr>
-          <p:cNvPr id="7" name="PDF_TEXT_GROUP_282"/>
+          <p:cNvPr id="7" name="PDF_TEXT_GROUP_277"/>
           <p:cNvSpPr txBox="1"/>
           <p:nvPr/>
         </p:nvSpPr>
@@ -16168,7 +15919,7 @@
       </p:sp>
       <p:sp>
         <p:nvSpPr>
-          <p:cNvPr id="8" name="PDF_TEXT_GROUP_283"/>
+          <p:cNvPr id="8" name="PDF_TEXT_GROUP_278"/>
           <p:cNvSpPr txBox="1"/>
           <p:nvPr/>
         </p:nvSpPr>
@@ -16225,7 +15976,7 @@
       </p:sp>
       <p:sp>
         <p:nvSpPr>
-          <p:cNvPr id="9" name="PDF_TEXT_GROUP_284"/>
+          <p:cNvPr id="9" name="PDF_TEXT_GROUP_279"/>
           <p:cNvSpPr txBox="1"/>
           <p:nvPr/>
         </p:nvSpPr>
@@ -16273,7 +16024,7 @@
       </p:sp>
       <p:sp>
         <p:nvSpPr>
-          <p:cNvPr id="10" name="PDF_TEXT_GROUP_285"/>
+          <p:cNvPr id="10" name="PDF_TEXT_GROUP_280"/>
           <p:cNvSpPr txBox="1"/>
           <p:nvPr/>
         </p:nvSpPr>
@@ -16321,7 +16072,7 @@
       </p:sp>
       <p:sp>
         <p:nvSpPr>
-          <p:cNvPr id="11" name="PDF_TEXT_GROUP_286"/>
+          <p:cNvPr id="11" name="PDF_TEXT_GROUP_281"/>
           <p:cNvSpPr txBox="1"/>
           <p:nvPr/>
         </p:nvSpPr>
@@ -16369,7 +16120,7 @@
       </p:sp>
       <p:sp>
         <p:nvSpPr>
-          <p:cNvPr id="12" name="PDF_TEXT_GROUP_287"/>
+          <p:cNvPr id="12" name="PDF_TEXT_GROUP_282"/>
           <p:cNvSpPr txBox="1"/>
           <p:nvPr/>
         </p:nvSpPr>
@@ -16417,7 +16168,7 @@
       </p:sp>
       <p:sp>
         <p:nvSpPr>
-          <p:cNvPr id="13" name="PDF_TEXT_GROUP_288"/>
+          <p:cNvPr id="13" name="PDF_TEXT_GROUP_283"/>
           <p:cNvSpPr txBox="1"/>
           <p:nvPr/>
         </p:nvSpPr>
@@ -16465,7 +16216,7 @@
       </p:sp>
       <p:sp>
         <p:nvSpPr>
-          <p:cNvPr id="14" name="PDF_BULLET_SPAN_415"/>
+          <p:cNvPr id="14" name="PDF_BULLET_SPAN_409"/>
           <p:cNvSpPr/>
           <p:nvPr/>
         </p:nvSpPr>
@@ -16508,7 +16259,7 @@
       </p:sp>
       <p:sp>
         <p:nvSpPr>
-          <p:cNvPr id="15" name="PDF_BULLET_SPAN_417"/>
+          <p:cNvPr id="15" name="PDF_BULLET_SPAN_411"/>
           <p:cNvSpPr/>
           <p:nvPr/>
         </p:nvSpPr>
@@ -16551,7 +16302,7 @@
       </p:sp>
       <p:sp>
         <p:nvSpPr>
-          <p:cNvPr id="16" name="PDF_BULLET_SPAN_420"/>
+          <p:cNvPr id="16" name="PDF_BULLET_SPAN_414"/>
           <p:cNvSpPr/>
           <p:nvPr/>
         </p:nvSpPr>
@@ -16594,7 +16345,7 @@
       </p:sp>
       <p:sp>
         <p:nvSpPr>
-          <p:cNvPr id="17" name="PDF_BULLET_SPAN_422"/>
+          <p:cNvPr id="17" name="PDF_BULLET_SPAN_416"/>
           <p:cNvSpPr/>
           <p:nvPr/>
         </p:nvSpPr>
@@ -16679,7 +16430,7 @@
       </p:pic>
       <p:sp>
         <p:nvSpPr>
-          <p:cNvPr id="3" name="PDF_TEXT_GROUP_289"/>
+          <p:cNvPr id="3" name="PDF_TEXT_GROUP_284"/>
           <p:cNvSpPr txBox="1"/>
           <p:nvPr/>
         </p:nvSpPr>
@@ -16727,7 +16478,7 @@
       </p:sp>
       <p:sp>
         <p:nvSpPr>
-          <p:cNvPr id="4" name="PDF_TEXT_GROUP_290"/>
+          <p:cNvPr id="4" name="PDF_TEXT_GROUP_285"/>
           <p:cNvSpPr txBox="1"/>
           <p:nvPr/>
         </p:nvSpPr>
@@ -16785,7 +16536,7 @@
       </p:sp>
       <p:sp>
         <p:nvSpPr>
-          <p:cNvPr id="5" name="PDF_TEXT_GROUP_291"/>
+          <p:cNvPr id="5" name="PDF_TEXT_GROUP_286"/>
           <p:cNvSpPr txBox="1"/>
           <p:nvPr/>
         </p:nvSpPr>
@@ -16843,7 +16594,7 @@
       </p:sp>
       <p:sp>
         <p:nvSpPr>
-          <p:cNvPr id="6" name="PDF_TEXT_GROUP_292"/>
+          <p:cNvPr id="6" name="PDF_TEXT_GROUP_287"/>
           <p:cNvSpPr txBox="1"/>
           <p:nvPr/>
         </p:nvSpPr>
@@ -16901,7 +16652,7 @@
       </p:sp>
       <p:sp>
         <p:nvSpPr>
-          <p:cNvPr id="7" name="PDF_TEXT_GROUP_293"/>
+          <p:cNvPr id="7" name="PDF_TEXT_GROUP_288"/>
           <p:cNvSpPr txBox="1"/>
           <p:nvPr/>
         </p:nvSpPr>
@@ -16949,7 +16700,7 @@
       </p:sp>
       <p:sp>
         <p:nvSpPr>
-          <p:cNvPr id="8" name="PDF_TEXT_GROUP_294"/>
+          <p:cNvPr id="8" name="PDF_TEXT_GROUP_289"/>
           <p:cNvSpPr txBox="1"/>
           <p:nvPr/>
         </p:nvSpPr>
@@ -16997,7 +16748,7 @@
       </p:sp>
       <p:sp>
         <p:nvSpPr>
-          <p:cNvPr id="9" name="PDF_TEXT_GROUP_295"/>
+          <p:cNvPr id="9" name="PDF_TEXT_GROUP_290"/>
           <p:cNvSpPr txBox="1"/>
           <p:nvPr/>
         </p:nvSpPr>
@@ -17054,7 +16805,7 @@
       </p:sp>
       <p:sp>
         <p:nvSpPr>
-          <p:cNvPr id="10" name="PDF_TEXT_GROUP_296"/>
+          <p:cNvPr id="10" name="PDF_TEXT_GROUP_291"/>
           <p:cNvSpPr txBox="1"/>
           <p:nvPr/>
         </p:nvSpPr>
@@ -17111,7 +16862,7 @@
       </p:sp>
       <p:sp>
         <p:nvSpPr>
-          <p:cNvPr id="11" name="PDF_TEXT_GROUP_297"/>
+          <p:cNvPr id="11" name="PDF_TEXT_GROUP_292"/>
           <p:cNvSpPr txBox="1"/>
           <p:nvPr/>
         </p:nvSpPr>
@@ -17159,7 +16910,7 @@
       </p:sp>
       <p:sp>
         <p:nvSpPr>
-          <p:cNvPr id="12" name="PDF_TEXT_GROUP_298"/>
+          <p:cNvPr id="12" name="PDF_TEXT_GROUP_293"/>
           <p:cNvSpPr txBox="1"/>
           <p:nvPr/>
         </p:nvSpPr>
@@ -17216,7 +16967,7 @@
       </p:sp>
       <p:sp>
         <p:nvSpPr>
-          <p:cNvPr id="13" name="PDF_TEXT_GROUP_299"/>
+          <p:cNvPr id="13" name="PDF_TEXT_GROUP_294"/>
           <p:cNvSpPr txBox="1"/>
           <p:nvPr/>
         </p:nvSpPr>
@@ -17264,7 +17015,7 @@
       </p:sp>
       <p:sp>
         <p:nvSpPr>
-          <p:cNvPr id="14" name="PDF_TEXT_GROUP_300"/>
+          <p:cNvPr id="14" name="PDF_TEXT_GROUP_295"/>
           <p:cNvSpPr txBox="1"/>
           <p:nvPr/>
         </p:nvSpPr>
@@ -17312,7 +17063,7 @@
       </p:sp>
       <p:sp>
         <p:nvSpPr>
-          <p:cNvPr id="15" name="PDF_TEXT_GROUP_301"/>
+          <p:cNvPr id="15" name="PDF_TEXT_GROUP_296"/>
           <p:cNvSpPr txBox="1"/>
           <p:nvPr/>
         </p:nvSpPr>
@@ -17360,7 +17111,7 @@
       </p:sp>
       <p:sp>
         <p:nvSpPr>
-          <p:cNvPr id="16" name="PDF_TEXT_GROUP_302"/>
+          <p:cNvPr id="16" name="PDF_TEXT_GROUP_297"/>
           <p:cNvSpPr txBox="1"/>
           <p:nvPr/>
         </p:nvSpPr>
@@ -17408,7 +17159,7 @@
       </p:sp>
       <p:sp>
         <p:nvSpPr>
-          <p:cNvPr id="17" name="PDF_TEXT_GROUP_303"/>
+          <p:cNvPr id="17" name="PDF_TEXT_GROUP_298"/>
           <p:cNvSpPr txBox="1"/>
           <p:nvPr/>
         </p:nvSpPr>
@@ -17456,7 +17207,7 @@
       </p:sp>
       <p:sp>
         <p:nvSpPr>
-          <p:cNvPr id="18" name="PDF_BULLET_SPAN_441"/>
+          <p:cNvPr id="18" name="PDF_BULLET_SPAN_435"/>
           <p:cNvSpPr/>
           <p:nvPr/>
         </p:nvSpPr>
@@ -17499,7 +17250,7 @@
       </p:sp>
       <p:sp>
         <p:nvSpPr>
-          <p:cNvPr id="19" name="PDF_BULLET_SPAN_444"/>
+          <p:cNvPr id="19" name="PDF_BULLET_SPAN_438"/>
           <p:cNvSpPr/>
           <p:nvPr/>
         </p:nvSpPr>
@@ -17542,7 +17293,7 @@
       </p:sp>
       <p:sp>
         <p:nvSpPr>
-          <p:cNvPr id="20" name="PDF_BULLET_SPAN_447"/>
+          <p:cNvPr id="20" name="PDF_BULLET_SPAN_441"/>
           <p:cNvSpPr/>
           <p:nvPr/>
         </p:nvSpPr>
@@ -17627,7 +17378,7 @@
       </p:pic>
       <p:sp>
         <p:nvSpPr>
-          <p:cNvPr id="3" name="PDF_TEXT_GROUP_304"/>
+          <p:cNvPr id="3" name="PDF_TEXT_GROUP_299"/>
           <p:cNvSpPr txBox="1"/>
           <p:nvPr/>
         </p:nvSpPr>
@@ -17675,7 +17426,7 @@
       </p:sp>
       <p:sp>
         <p:nvSpPr>
-          <p:cNvPr id="4" name="PDF_TEXT_GROUP_305"/>
+          <p:cNvPr id="4" name="PDF_TEXT_GROUP_300"/>
           <p:cNvSpPr txBox="1"/>
           <p:nvPr/>
         </p:nvSpPr>
@@ -17732,7 +17483,7 @@
       </p:sp>
       <p:sp>
         <p:nvSpPr>
-          <p:cNvPr id="5" name="PDF_TEXT_GROUP_306"/>
+          <p:cNvPr id="5" name="PDF_TEXT_GROUP_301"/>
           <p:cNvSpPr txBox="1"/>
           <p:nvPr/>
         </p:nvSpPr>
@@ -17789,7 +17540,7 @@
       </p:sp>
       <p:sp>
         <p:nvSpPr>
-          <p:cNvPr id="6" name="PDF_TEXT_GROUP_307"/>
+          <p:cNvPr id="6" name="PDF_TEXT_GROUP_302"/>
           <p:cNvSpPr txBox="1"/>
           <p:nvPr/>
         </p:nvSpPr>
@@ -17837,7 +17588,7 @@
       </p:sp>
       <p:sp>
         <p:nvSpPr>
-          <p:cNvPr id="7" name="PDF_TEXT_GROUP_308"/>
+          <p:cNvPr id="7" name="PDF_TEXT_GROUP_303"/>
           <p:cNvSpPr txBox="1"/>
           <p:nvPr/>
         </p:nvSpPr>
@@ -17894,7 +17645,7 @@
       </p:sp>
       <p:sp>
         <p:nvSpPr>
-          <p:cNvPr id="8" name="PDF_TEXT_GROUP_309"/>
+          <p:cNvPr id="8" name="PDF_TEXT_GROUP_304"/>
           <p:cNvSpPr txBox="1"/>
           <p:nvPr/>
         </p:nvSpPr>
@@ -17942,7 +17693,7 @@
       </p:sp>
       <p:sp>
         <p:nvSpPr>
-          <p:cNvPr id="9" name="PDF_TEXT_GROUP_310"/>
+          <p:cNvPr id="9" name="PDF_TEXT_GROUP_305"/>
           <p:cNvSpPr txBox="1"/>
           <p:nvPr/>
         </p:nvSpPr>
@@ -17990,7 +17741,7 @@
       </p:sp>
       <p:sp>
         <p:nvSpPr>
-          <p:cNvPr id="10" name="PDF_TEXT_GROUP_311"/>
+          <p:cNvPr id="10" name="PDF_TEXT_GROUP_306"/>
           <p:cNvSpPr txBox="1"/>
           <p:nvPr/>
         </p:nvSpPr>
@@ -18038,7 +17789,7 @@
       </p:sp>
       <p:sp>
         <p:nvSpPr>
-          <p:cNvPr id="11" name="PDF_TEXT_GROUP_312"/>
+          <p:cNvPr id="11" name="PDF_TEXT_GROUP_307"/>
           <p:cNvSpPr txBox="1"/>
           <p:nvPr/>
         </p:nvSpPr>
@@ -18086,7 +17837,7 @@
       </p:sp>
       <p:sp>
         <p:nvSpPr>
-          <p:cNvPr id="12" name="PDF_TEXT_GROUP_313"/>
+          <p:cNvPr id="12" name="PDF_TEXT_GROUP_308"/>
           <p:cNvSpPr txBox="1"/>
           <p:nvPr/>
         </p:nvSpPr>
@@ -18134,7 +17885,7 @@
       </p:sp>
       <p:sp>
         <p:nvSpPr>
-          <p:cNvPr id="13" name="PDF_TEXT_GROUP_314"/>
+          <p:cNvPr id="13" name="PDF_TEXT_GROUP_309"/>
           <p:cNvSpPr txBox="1"/>
           <p:nvPr/>
         </p:nvSpPr>
@@ -18182,7 +17933,7 @@
       </p:sp>
       <p:sp>
         <p:nvSpPr>
-          <p:cNvPr id="14" name="PDF_BULLET_SPAN_457"/>
+          <p:cNvPr id="14" name="PDF_BULLET_SPAN_451"/>
           <p:cNvSpPr/>
           <p:nvPr/>
         </p:nvSpPr>
@@ -18225,7 +17976,7 @@
       </p:sp>
       <p:sp>
         <p:nvSpPr>
-          <p:cNvPr id="15" name="PDF_BULLET_SPAN_460"/>
+          <p:cNvPr id="15" name="PDF_BULLET_SPAN_454"/>
           <p:cNvSpPr/>
           <p:nvPr/>
         </p:nvSpPr>
@@ -18268,7 +18019,7 @@
       </p:sp>
       <p:sp>
         <p:nvSpPr>
-          <p:cNvPr id="16" name="PDF_BULLET_SPAN_463"/>
+          <p:cNvPr id="16" name="PDF_BULLET_SPAN_457"/>
           <p:cNvSpPr/>
           <p:nvPr/>
         </p:nvSpPr>
@@ -18311,7 +18062,7 @@
       </p:sp>
       <p:sp>
         <p:nvSpPr>
-          <p:cNvPr id="17" name="PDF_BULLET_SPAN_465"/>
+          <p:cNvPr id="17" name="PDF_BULLET_SPAN_459"/>
           <p:cNvSpPr/>
           <p:nvPr/>
         </p:nvSpPr>
@@ -18396,7 +18147,7 @@
       </p:pic>
       <p:sp>
         <p:nvSpPr>
-          <p:cNvPr id="3" name="PDF_TEXT_GROUP_315"/>
+          <p:cNvPr id="3" name="PDF_TEXT_GROUP_310"/>
           <p:cNvSpPr txBox="1"/>
           <p:nvPr/>
         </p:nvSpPr>
@@ -18444,7 +18195,7 @@
       </p:sp>
       <p:sp>
         <p:nvSpPr>
-          <p:cNvPr id="4" name="PDF_TEXT_GROUP_316"/>
+          <p:cNvPr id="4" name="PDF_TEXT_GROUP_311"/>
           <p:cNvSpPr txBox="1"/>
           <p:nvPr/>
         </p:nvSpPr>
@@ -18501,7 +18252,7 @@
       </p:sp>
       <p:sp>
         <p:nvSpPr>
-          <p:cNvPr id="5" name="PDF_TEXT_GROUP_317"/>
+          <p:cNvPr id="5" name="PDF_TEXT_GROUP_312"/>
           <p:cNvSpPr txBox="1"/>
           <p:nvPr/>
         </p:nvSpPr>
@@ -18558,7 +18309,7 @@
       </p:sp>
       <p:sp>
         <p:nvSpPr>
-          <p:cNvPr id="6" name="PDF_TEXT_GROUP_318"/>
+          <p:cNvPr id="6" name="PDF_TEXT_GROUP_313"/>
           <p:cNvSpPr txBox="1"/>
           <p:nvPr/>
         </p:nvSpPr>
@@ -18615,7 +18366,7 @@
       </p:sp>
       <p:sp>
         <p:nvSpPr>
-          <p:cNvPr id="7" name="PDF_TEXT_GROUP_319"/>
+          <p:cNvPr id="7" name="PDF_TEXT_GROUP_314"/>
           <p:cNvSpPr txBox="1"/>
           <p:nvPr/>
         </p:nvSpPr>
@@ -18672,7 +18423,7 @@
       </p:sp>
       <p:sp>
         <p:nvSpPr>
-          <p:cNvPr id="8" name="PDF_TEXT_GROUP_320"/>
+          <p:cNvPr id="8" name="PDF_TEXT_GROUP_315"/>
           <p:cNvSpPr txBox="1"/>
           <p:nvPr/>
         </p:nvSpPr>
@@ -18729,7 +18480,7 @@
       </p:sp>
       <p:sp>
         <p:nvSpPr>
-          <p:cNvPr id="9" name="PDF_TEXT_GROUP_321"/>
+          <p:cNvPr id="9" name="PDF_TEXT_GROUP_316"/>
           <p:cNvSpPr txBox="1"/>
           <p:nvPr/>
         </p:nvSpPr>
@@ -18777,7 +18528,7 @@
       </p:sp>
       <p:sp>
         <p:nvSpPr>
-          <p:cNvPr id="10" name="PDF_TEXT_GROUP_322"/>
+          <p:cNvPr id="10" name="PDF_TEXT_GROUP_317"/>
           <p:cNvSpPr txBox="1"/>
           <p:nvPr/>
         </p:nvSpPr>
@@ -18825,7 +18576,7 @@
       </p:sp>
       <p:sp>
         <p:nvSpPr>
-          <p:cNvPr id="11" name="PDF_TEXT_GROUP_323"/>
+          <p:cNvPr id="11" name="PDF_TEXT_GROUP_318"/>
           <p:cNvSpPr txBox="1"/>
           <p:nvPr/>
         </p:nvSpPr>
@@ -18873,7 +18624,7 @@
       </p:sp>
       <p:sp>
         <p:nvSpPr>
-          <p:cNvPr id="12" name="PDF_TEXT_GROUP_324"/>
+          <p:cNvPr id="12" name="PDF_TEXT_GROUP_319"/>
           <p:cNvSpPr txBox="1"/>
           <p:nvPr/>
         </p:nvSpPr>
@@ -18921,7 +18672,7 @@
       </p:sp>
       <p:sp>
         <p:nvSpPr>
-          <p:cNvPr id="13" name="PDF_TEXT_GROUP_325"/>
+          <p:cNvPr id="13" name="PDF_TEXT_GROUP_320"/>
           <p:cNvSpPr txBox="1"/>
           <p:nvPr/>
         </p:nvSpPr>
@@ -18969,7 +18720,7 @@
       </p:sp>
       <p:sp>
         <p:nvSpPr>
-          <p:cNvPr id="14" name="PDF_BULLET_SPAN_475"/>
+          <p:cNvPr id="14" name="PDF_BULLET_SPAN_469"/>
           <p:cNvSpPr/>
           <p:nvPr/>
         </p:nvSpPr>
@@ -19012,7 +18763,7 @@
       </p:sp>
       <p:sp>
         <p:nvSpPr>
-          <p:cNvPr id="15" name="PDF_BULLET_SPAN_478"/>
+          <p:cNvPr id="15" name="PDF_BULLET_SPAN_472"/>
           <p:cNvSpPr/>
           <p:nvPr/>
         </p:nvSpPr>
@@ -19055,7 +18806,7 @@
       </p:sp>
       <p:sp>
         <p:nvSpPr>
-          <p:cNvPr id="16" name="PDF_BULLET_SPAN_481"/>
+          <p:cNvPr id="16" name="PDF_BULLET_SPAN_475"/>
           <p:cNvSpPr/>
           <p:nvPr/>
         </p:nvSpPr>
@@ -19098,7 +18849,7 @@
       </p:sp>
       <p:sp>
         <p:nvSpPr>
-          <p:cNvPr id="17" name="PDF_BULLET_SPAN_484"/>
+          <p:cNvPr id="17" name="PDF_BULLET_SPAN_478"/>
           <p:cNvSpPr/>
           <p:nvPr/>
         </p:nvSpPr>
@@ -19183,7 +18934,7 @@
       </p:pic>
       <p:sp>
         <p:nvSpPr>
-          <p:cNvPr id="3" name="PDF_TEXT_GROUP_326"/>
+          <p:cNvPr id="3" name="PDF_TEXT_GROUP_321"/>
           <p:cNvSpPr txBox="1"/>
           <p:nvPr/>
         </p:nvSpPr>
@@ -19231,7 +18982,7 @@
       </p:sp>
       <p:sp>
         <p:nvSpPr>
-          <p:cNvPr id="4" name="PDF_TEXT_GROUP_327"/>
+          <p:cNvPr id="4" name="PDF_TEXT_GROUP_322"/>
           <p:cNvSpPr txBox="1"/>
           <p:nvPr/>
         </p:nvSpPr>
@@ -19279,7 +19030,7 @@
       </p:sp>
       <p:sp>
         <p:nvSpPr>
-          <p:cNvPr id="5" name="PDF_TEXT_GROUP_328"/>
+          <p:cNvPr id="5" name="PDF_TEXT_GROUP_323"/>
           <p:cNvSpPr txBox="1"/>
           <p:nvPr/>
         </p:nvSpPr>
@@ -19327,7 +19078,7 @@
       </p:sp>
       <p:sp>
         <p:nvSpPr>
-          <p:cNvPr id="6" name="PDF_TEXT_GROUP_329"/>
+          <p:cNvPr id="6" name="PDF_TEXT_GROUP_324"/>
           <p:cNvSpPr txBox="1"/>
           <p:nvPr/>
         </p:nvSpPr>
@@ -19375,7 +19126,7 @@
       </p:sp>
       <p:sp>
         <p:nvSpPr>
-          <p:cNvPr id="7" name="PDF_TEXT_GROUP_330"/>
+          <p:cNvPr id="7" name="PDF_TEXT_GROUP_325"/>
           <p:cNvSpPr txBox="1"/>
           <p:nvPr/>
         </p:nvSpPr>
@@ -19423,7 +19174,7 @@
       </p:sp>
       <p:sp>
         <p:nvSpPr>
-          <p:cNvPr id="8" name="PDF_TEXT_GROUP_331"/>
+          <p:cNvPr id="8" name="PDF_TEXT_GROUP_326"/>
           <p:cNvSpPr txBox="1"/>
           <p:nvPr/>
         </p:nvSpPr>
@@ -19471,7 +19222,7 @@
       </p:sp>
       <p:sp>
         <p:nvSpPr>
-          <p:cNvPr id="9" name="PDF_TEXT_GROUP_332"/>
+          <p:cNvPr id="9" name="PDF_TEXT_GROUP_327"/>
           <p:cNvSpPr txBox="1"/>
           <p:nvPr/>
         </p:nvSpPr>
@@ -19519,7 +19270,7 @@
       </p:sp>
       <p:sp>
         <p:nvSpPr>
-          <p:cNvPr id="10" name="PDF_TEXT_GROUP_333"/>
+          <p:cNvPr id="10" name="PDF_TEXT_GROUP_328"/>
           <p:cNvSpPr txBox="1"/>
           <p:nvPr/>
         </p:nvSpPr>
@@ -19567,7 +19318,7 @@
       </p:sp>
       <p:sp>
         <p:nvSpPr>
-          <p:cNvPr id="11" name="PDF_TEXT_GROUP_334"/>
+          <p:cNvPr id="11" name="PDF_TEXT_GROUP_329"/>
           <p:cNvSpPr txBox="1"/>
           <p:nvPr/>
         </p:nvSpPr>
@@ -19615,7 +19366,7 @@
       </p:sp>
       <p:sp>
         <p:nvSpPr>
-          <p:cNvPr id="12" name="PDF_TEXT_GROUP_335"/>
+          <p:cNvPr id="12" name="PDF_TEXT_GROUP_330"/>
           <p:cNvSpPr txBox="1"/>
           <p:nvPr/>
         </p:nvSpPr>
@@ -19663,7 +19414,7 @@
       </p:sp>
       <p:sp>
         <p:nvSpPr>
-          <p:cNvPr id="13" name="PDF_TEXT_GROUP_336"/>
+          <p:cNvPr id="13" name="PDF_TEXT_GROUP_331"/>
           <p:cNvSpPr txBox="1"/>
           <p:nvPr/>
         </p:nvSpPr>
@@ -19711,7 +19462,7 @@
       </p:sp>
       <p:sp>
         <p:nvSpPr>
-          <p:cNvPr id="14" name="PDF_TEXT_GROUP_337"/>
+          <p:cNvPr id="14" name="PDF_TEXT_GROUP_332"/>
           <p:cNvSpPr txBox="1"/>
           <p:nvPr/>
         </p:nvSpPr>
@@ -19759,7 +19510,7 @@
       </p:sp>
       <p:sp>
         <p:nvSpPr>
-          <p:cNvPr id="15" name="PDF_TEXT_GROUP_338"/>
+          <p:cNvPr id="15" name="PDF_TEXT_GROUP_333"/>
           <p:cNvSpPr txBox="1"/>
           <p:nvPr/>
         </p:nvSpPr>
@@ -19807,7 +19558,7 @@
       </p:sp>
       <p:sp>
         <p:nvSpPr>
-          <p:cNvPr id="16" name="PDF_TEXT_GROUP_339"/>
+          <p:cNvPr id="16" name="PDF_TEXT_GROUP_334"/>
           <p:cNvSpPr txBox="1"/>
           <p:nvPr/>
         </p:nvSpPr>
@@ -19855,7 +19606,7 @@
       </p:sp>
       <p:sp>
         <p:nvSpPr>
-          <p:cNvPr id="17" name="PDF_TEXT_GROUP_340"/>
+          <p:cNvPr id="17" name="PDF_TEXT_GROUP_335"/>
           <p:cNvSpPr txBox="1"/>
           <p:nvPr/>
         </p:nvSpPr>
@@ -19903,7 +19654,7 @@
       </p:sp>
       <p:sp>
         <p:nvSpPr>
-          <p:cNvPr id="18" name="PDF_TEXT_GROUP_341"/>
+          <p:cNvPr id="18" name="PDF_TEXT_GROUP_336"/>
           <p:cNvSpPr txBox="1"/>
           <p:nvPr/>
         </p:nvSpPr>
@@ -19951,7 +19702,7 @@
       </p:sp>
       <p:sp>
         <p:nvSpPr>
-          <p:cNvPr id="19" name="PDF_TEXT_GROUP_342"/>
+          <p:cNvPr id="19" name="PDF_TEXT_GROUP_337"/>
           <p:cNvSpPr txBox="1"/>
           <p:nvPr/>
         </p:nvSpPr>
@@ -19999,7 +19750,7 @@
       </p:sp>
       <p:sp>
         <p:nvSpPr>
-          <p:cNvPr id="20" name="PDF_TEXT_GROUP_343"/>
+          <p:cNvPr id="20" name="PDF_TEXT_GROUP_338"/>
           <p:cNvSpPr txBox="1"/>
           <p:nvPr/>
         </p:nvSpPr>
@@ -20047,7 +19798,7 @@
       </p:sp>
       <p:sp>
         <p:nvSpPr>
-          <p:cNvPr id="21" name="PDF_TEXT_GROUP_344"/>
+          <p:cNvPr id="21" name="PDF_TEXT_GROUP_339"/>
           <p:cNvSpPr txBox="1"/>
           <p:nvPr/>
         </p:nvSpPr>
@@ -20104,7 +19855,7 @@
       </p:sp>
       <p:sp>
         <p:nvSpPr>
-          <p:cNvPr id="22" name="PDF_TEXT_GROUP_345"/>
+          <p:cNvPr id="22" name="PDF_TEXT_GROUP_340"/>
           <p:cNvSpPr txBox="1"/>
           <p:nvPr/>
         </p:nvSpPr>
@@ -20152,7 +19903,7 @@
       </p:sp>
       <p:sp>
         <p:nvSpPr>
-          <p:cNvPr id="23" name="PDF_TEXT_GROUP_346"/>
+          <p:cNvPr id="23" name="PDF_TEXT_GROUP_341"/>
           <p:cNvSpPr txBox="1"/>
           <p:nvPr/>
         </p:nvSpPr>
@@ -20200,7 +19951,7 @@
       </p:sp>
       <p:sp>
         <p:nvSpPr>
-          <p:cNvPr id="24" name="PDF_TEXT_GROUP_347"/>
+          <p:cNvPr id="24" name="PDF_TEXT_GROUP_342"/>
           <p:cNvSpPr txBox="1"/>
           <p:nvPr/>
         </p:nvSpPr>
@@ -20248,7 +19999,7 @@
       </p:sp>
       <p:sp>
         <p:nvSpPr>
-          <p:cNvPr id="25" name="PDF_TEXT_GROUP_348"/>
+          <p:cNvPr id="25" name="PDF_TEXT_GROUP_343"/>
           <p:cNvSpPr txBox="1"/>
           <p:nvPr/>
         </p:nvSpPr>
@@ -20296,7 +20047,7 @@
       </p:sp>
       <p:sp>
         <p:nvSpPr>
-          <p:cNvPr id="26" name="PDF_TEXT_GROUP_349"/>
+          <p:cNvPr id="26" name="PDF_TEXT_GROUP_344"/>
           <p:cNvSpPr txBox="1"/>
           <p:nvPr/>
         </p:nvSpPr>
@@ -20386,7 +20137,7 @@
       </p:pic>
       <p:sp>
         <p:nvSpPr>
-          <p:cNvPr id="3" name="PDF_TEXT_GROUP_350"/>
+          <p:cNvPr id="3" name="PDF_TEXT_GROUP_345"/>
           <p:cNvSpPr txBox="1"/>
           <p:nvPr/>
         </p:nvSpPr>
@@ -20434,7 +20185,7 @@
       </p:sp>
       <p:sp>
         <p:nvSpPr>
-          <p:cNvPr id="4" name="PDF_TEXT_GROUP_351"/>
+          <p:cNvPr id="4" name="PDF_TEXT_GROUP_346"/>
           <p:cNvSpPr txBox="1"/>
           <p:nvPr/>
         </p:nvSpPr>
@@ -20491,7 +20242,7 @@
       </p:sp>
       <p:sp>
         <p:nvSpPr>
-          <p:cNvPr id="5" name="PDF_TEXT_GROUP_352"/>
+          <p:cNvPr id="5" name="PDF_TEXT_GROUP_347"/>
           <p:cNvSpPr txBox="1"/>
           <p:nvPr/>
         </p:nvSpPr>
@@ -20539,7 +20290,7 @@
       </p:sp>
       <p:sp>
         <p:nvSpPr>
-          <p:cNvPr id="6" name="PDF_TEXT_GROUP_353"/>
+          <p:cNvPr id="6" name="PDF_TEXT_GROUP_348"/>
           <p:cNvSpPr txBox="1"/>
           <p:nvPr/>
         </p:nvSpPr>
@@ -20587,7 +20338,7 @@
       </p:sp>
       <p:sp>
         <p:nvSpPr>
-          <p:cNvPr id="7" name="PDF_TEXT_GROUP_354"/>
+          <p:cNvPr id="7" name="PDF_TEXT_GROUP_349"/>
           <p:cNvSpPr txBox="1"/>
           <p:nvPr/>
         </p:nvSpPr>
@@ -20635,7 +20386,7 @@
       </p:sp>
       <p:sp>
         <p:nvSpPr>
-          <p:cNvPr id="8" name="PDF_TEXT_GROUP_355"/>
+          <p:cNvPr id="8" name="PDF_TEXT_GROUP_350"/>
           <p:cNvSpPr txBox="1"/>
           <p:nvPr/>
         </p:nvSpPr>
@@ -20701,7 +20452,7 @@
       </p:sp>
       <p:sp>
         <p:nvSpPr>
-          <p:cNvPr id="9" name="PDF_TEXT_GROUP_357"/>
+          <p:cNvPr id="9" name="PDF_TEXT_GROUP_352"/>
           <p:cNvSpPr txBox="1"/>
           <p:nvPr/>
         </p:nvSpPr>
@@ -20749,7 +20500,7 @@
       </p:sp>
       <p:sp>
         <p:nvSpPr>
-          <p:cNvPr id="10" name="PDF_TEXT_GROUP_356"/>
+          <p:cNvPr id="10" name="PDF_TEXT_GROUP_351"/>
           <p:cNvSpPr txBox="1"/>
           <p:nvPr/>
         </p:nvSpPr>
@@ -20851,7 +20602,7 @@
       </p:sp>
       <p:sp>
         <p:nvSpPr>
-          <p:cNvPr id="11" name="PDF_TEXT_GROUP_358"/>
+          <p:cNvPr id="11" name="PDF_TEXT_GROUP_353"/>
           <p:cNvSpPr txBox="1"/>
           <p:nvPr/>
         </p:nvSpPr>
@@ -20917,7 +20668,7 @@
       </p:sp>
       <p:sp>
         <p:nvSpPr>
-          <p:cNvPr id="12" name="PDF_TEXT_GROUP_360"/>
+          <p:cNvPr id="12" name="PDF_TEXT_GROUP_355"/>
           <p:cNvSpPr txBox="1"/>
           <p:nvPr/>
         </p:nvSpPr>
@@ -20965,7 +20716,7 @@
       </p:sp>
       <p:sp>
         <p:nvSpPr>
-          <p:cNvPr id="13" name="PDF_TEXT_GROUP_359"/>
+          <p:cNvPr id="13" name="PDF_TEXT_GROUP_354"/>
           <p:cNvSpPr txBox="1"/>
           <p:nvPr/>
         </p:nvSpPr>
@@ -21067,7 +20818,7 @@
       </p:sp>
       <p:sp>
         <p:nvSpPr>
-          <p:cNvPr id="14" name="PDF_TEXT_GROUP_361"/>
+          <p:cNvPr id="14" name="PDF_TEXT_GROUP_356"/>
           <p:cNvSpPr txBox="1"/>
           <p:nvPr/>
         </p:nvSpPr>
@@ -21124,7 +20875,7 @@
       </p:sp>
       <p:sp>
         <p:nvSpPr>
-          <p:cNvPr id="15" name="PDF_TEXT_GROUP_362"/>
+          <p:cNvPr id="15" name="PDF_TEXT_GROUP_357"/>
           <p:cNvSpPr txBox="1"/>
           <p:nvPr/>
         </p:nvSpPr>
@@ -21172,7 +20923,7 @@
       </p:sp>
       <p:sp>
         <p:nvSpPr>
-          <p:cNvPr id="16" name="PDF_TEXT_GROUP_363"/>
+          <p:cNvPr id="16" name="PDF_TEXT_GROUP_358"/>
           <p:cNvSpPr txBox="1"/>
           <p:nvPr/>
         </p:nvSpPr>
@@ -21220,7 +20971,7 @@
       </p:sp>
       <p:sp>
         <p:nvSpPr>
-          <p:cNvPr id="17" name="PDF_TEXT_GROUP_364"/>
+          <p:cNvPr id="17" name="PDF_TEXT_GROUP_359"/>
           <p:cNvSpPr txBox="1"/>
           <p:nvPr/>
         </p:nvSpPr>
@@ -21268,7 +21019,7 @@
       </p:sp>
       <p:sp>
         <p:nvSpPr>
-          <p:cNvPr id="18" name="PDF_TEXT_GROUP_365"/>
+          <p:cNvPr id="18" name="PDF_TEXT_GROUP_360"/>
           <p:cNvSpPr txBox="1"/>
           <p:nvPr/>
         </p:nvSpPr>
@@ -21316,7 +21067,7 @@
       </p:sp>
       <p:sp>
         <p:nvSpPr>
-          <p:cNvPr id="19" name="PDF_TEXT_GROUP_366"/>
+          <p:cNvPr id="19" name="PDF_TEXT_GROUP_361"/>
           <p:cNvSpPr txBox="1"/>
           <p:nvPr/>
         </p:nvSpPr>
@@ -21406,7 +21157,7 @@
       </p:pic>
       <p:sp>
         <p:nvSpPr>
-          <p:cNvPr id="3" name="PDF_TEXT_GROUP_367"/>
+          <p:cNvPr id="3" name="PDF_TEXT_GROUP_362"/>
           <p:cNvSpPr txBox="1"/>
           <p:nvPr/>
         </p:nvSpPr>
@@ -21454,7 +21205,7 @@
       </p:sp>
       <p:sp>
         <p:nvSpPr>
-          <p:cNvPr id="4" name="PDF_TEXT_GROUP_368"/>
+          <p:cNvPr id="4" name="PDF_TEXT_GROUP_363"/>
           <p:cNvSpPr txBox="1"/>
           <p:nvPr/>
         </p:nvSpPr>
@@ -21502,7 +21253,7 @@
       </p:sp>
       <p:sp>
         <p:nvSpPr>
-          <p:cNvPr id="5" name="PDF_TEXT_GROUP_369"/>
+          <p:cNvPr id="5" name="PDF_TEXT_GROUP_364"/>
           <p:cNvSpPr txBox="1"/>
           <p:nvPr/>
         </p:nvSpPr>
@@ -21550,7 +21301,7 @@
       </p:sp>
       <p:sp>
         <p:nvSpPr>
-          <p:cNvPr id="6" name="PDF_TEXT_GROUP_370"/>
+          <p:cNvPr id="6" name="PDF_TEXT_GROUP_365"/>
           <p:cNvSpPr txBox="1"/>
           <p:nvPr/>
         </p:nvSpPr>
@@ -21598,7 +21349,7 @@
       </p:sp>
       <p:sp>
         <p:nvSpPr>
-          <p:cNvPr id="7" name="PDF_TEXT_GROUP_371"/>
+          <p:cNvPr id="7" name="PDF_TEXT_GROUP_366"/>
           <p:cNvSpPr txBox="1"/>
           <p:nvPr/>
         </p:nvSpPr>
@@ -21646,7 +21397,7 @@
       </p:sp>
       <p:sp>
         <p:nvSpPr>
-          <p:cNvPr id="8" name="PDF_TEXT_GROUP_372"/>
+          <p:cNvPr id="8" name="PDF_TEXT_GROUP_367"/>
           <p:cNvSpPr txBox="1"/>
           <p:nvPr/>
         </p:nvSpPr>
@@ -21694,7 +21445,7 @@
       </p:sp>
       <p:sp>
         <p:nvSpPr>
-          <p:cNvPr id="9" name="PDF_TEXT_GROUP_373"/>
+          <p:cNvPr id="9" name="PDF_TEXT_GROUP_368"/>
           <p:cNvSpPr txBox="1"/>
           <p:nvPr/>
         </p:nvSpPr>
@@ -21742,7 +21493,7 @@
       </p:sp>
       <p:sp>
         <p:nvSpPr>
-          <p:cNvPr id="10" name="PDF_TEXT_GROUP_374"/>
+          <p:cNvPr id="10" name="PDF_TEXT_GROUP_369"/>
           <p:cNvSpPr txBox="1"/>
           <p:nvPr/>
         </p:nvSpPr>
@@ -21790,7 +21541,7 @@
       </p:sp>
       <p:sp>
         <p:nvSpPr>
-          <p:cNvPr id="11" name="PDF_TEXT_GROUP_375"/>
+          <p:cNvPr id="11" name="PDF_TEXT_GROUP_370"/>
           <p:cNvSpPr txBox="1"/>
           <p:nvPr/>
         </p:nvSpPr>
@@ -21838,7 +21589,7 @@
       </p:sp>
       <p:sp>
         <p:nvSpPr>
-          <p:cNvPr id="12" name="PDF_TEXT_GROUP_376"/>
+          <p:cNvPr id="12" name="PDF_TEXT_GROUP_371"/>
           <p:cNvSpPr txBox="1"/>
           <p:nvPr/>
         </p:nvSpPr>
@@ -21886,7 +21637,7 @@
       </p:sp>
       <p:sp>
         <p:nvSpPr>
-          <p:cNvPr id="13" name="PDF_TEXT_GROUP_377"/>
+          <p:cNvPr id="13" name="PDF_TEXT_GROUP_372"/>
           <p:cNvSpPr txBox="1"/>
           <p:nvPr/>
         </p:nvSpPr>
@@ -21934,7 +21685,7 @@
       </p:sp>
       <p:sp>
         <p:nvSpPr>
-          <p:cNvPr id="14" name="PDF_TEXT_GROUP_378"/>
+          <p:cNvPr id="14" name="PDF_TEXT_GROUP_373"/>
           <p:cNvSpPr txBox="1"/>
           <p:nvPr/>
         </p:nvSpPr>
@@ -21982,7 +21733,7 @@
       </p:sp>
       <p:sp>
         <p:nvSpPr>
-          <p:cNvPr id="15" name="PDF_TEXT_GROUP_379"/>
+          <p:cNvPr id="15" name="PDF_TEXT_GROUP_374"/>
           <p:cNvSpPr txBox="1"/>
           <p:nvPr/>
         </p:nvSpPr>
@@ -22030,7 +21781,7 @@
       </p:sp>
       <p:sp>
         <p:nvSpPr>
-          <p:cNvPr id="16" name="PDF_TEXT_GROUP_380"/>
+          <p:cNvPr id="16" name="PDF_TEXT_GROUP_375"/>
           <p:cNvSpPr txBox="1"/>
           <p:nvPr/>
         </p:nvSpPr>
@@ -22087,7 +21838,7 @@
       </p:sp>
       <p:sp>
         <p:nvSpPr>
-          <p:cNvPr id="17" name="PDF_TEXT_GROUP_381"/>
+          <p:cNvPr id="17" name="PDF_TEXT_GROUP_376"/>
           <p:cNvSpPr txBox="1"/>
           <p:nvPr/>
         </p:nvSpPr>
@@ -22135,7 +21886,7 @@
       </p:sp>
       <p:sp>
         <p:nvSpPr>
-          <p:cNvPr id="18" name="PDF_TEXT_GROUP_382"/>
+          <p:cNvPr id="18" name="PDF_TEXT_GROUP_377"/>
           <p:cNvSpPr txBox="1"/>
           <p:nvPr/>
         </p:nvSpPr>
@@ -22183,7 +21934,7 @@
       </p:sp>
       <p:sp>
         <p:nvSpPr>
-          <p:cNvPr id="19" name="PDF_TEXT_GROUP_383"/>
+          <p:cNvPr id="19" name="PDF_TEXT_GROUP_378"/>
           <p:cNvSpPr txBox="1"/>
           <p:nvPr/>
         </p:nvSpPr>
@@ -22231,7 +21982,7 @@
       </p:sp>
       <p:sp>
         <p:nvSpPr>
-          <p:cNvPr id="20" name="PDF_TEXT_GROUP_384"/>
+          <p:cNvPr id="20" name="PDF_TEXT_GROUP_379"/>
           <p:cNvSpPr txBox="1"/>
           <p:nvPr/>
         </p:nvSpPr>
@@ -22279,7 +22030,7 @@
       </p:sp>
       <p:sp>
         <p:nvSpPr>
-          <p:cNvPr id="21" name="PDF_TEXT_GROUP_385"/>
+          <p:cNvPr id="21" name="PDF_TEXT_GROUP_380"/>
           <p:cNvSpPr txBox="1"/>
           <p:nvPr/>
         </p:nvSpPr>
@@ -22369,7 +22120,7 @@
       </p:pic>
       <p:sp>
         <p:nvSpPr>
-          <p:cNvPr id="3" name="PDF_TEXT_GROUP_386"/>
+          <p:cNvPr id="3" name="PDF_TEXT_GROUP_381"/>
           <p:cNvSpPr txBox="1"/>
           <p:nvPr/>
         </p:nvSpPr>
@@ -22417,7 +22168,7 @@
       </p:sp>
       <p:sp>
         <p:nvSpPr>
-          <p:cNvPr id="4" name="PDF_TEXT_GROUP_387"/>
+          <p:cNvPr id="4" name="PDF_TEXT_GROUP_382"/>
           <p:cNvSpPr txBox="1"/>
           <p:nvPr/>
         </p:nvSpPr>
@@ -22465,7 +22216,7 @@
       </p:sp>
       <p:sp>
         <p:nvSpPr>
-          <p:cNvPr id="5" name="PDF_TEXT_GROUP_388"/>
+          <p:cNvPr id="5" name="PDF_TEXT_GROUP_383"/>
           <p:cNvSpPr txBox="1"/>
           <p:nvPr/>
         </p:nvSpPr>
@@ -22513,7 +22264,7 @@
       </p:sp>
       <p:sp>
         <p:nvSpPr>
-          <p:cNvPr id="6" name="PDF_TEXT_GROUP_389"/>
+          <p:cNvPr id="6" name="PDF_TEXT_GROUP_384"/>
           <p:cNvSpPr txBox="1"/>
           <p:nvPr/>
         </p:nvSpPr>
@@ -22561,7 +22312,7 @@
       </p:sp>
       <p:sp>
         <p:nvSpPr>
-          <p:cNvPr id="7" name="PDF_TEXT_GROUP_390"/>
+          <p:cNvPr id="7" name="PDF_TEXT_GROUP_385"/>
           <p:cNvSpPr txBox="1"/>
           <p:nvPr/>
         </p:nvSpPr>
@@ -22609,7 +22360,7 @@
       </p:sp>
       <p:sp>
         <p:nvSpPr>
-          <p:cNvPr id="8" name="PDF_TEXT_GROUP_391"/>
+          <p:cNvPr id="8" name="PDF_TEXT_GROUP_386"/>
           <p:cNvSpPr txBox="1"/>
           <p:nvPr/>
         </p:nvSpPr>
@@ -22657,7 +22408,7 @@
       </p:sp>
       <p:sp>
         <p:nvSpPr>
-          <p:cNvPr id="9" name="PDF_TEXT_GROUP_392"/>
+          <p:cNvPr id="9" name="PDF_TEXT_GROUP_387"/>
           <p:cNvSpPr txBox="1"/>
           <p:nvPr/>
         </p:nvSpPr>
@@ -22705,7 +22456,7 @@
       </p:sp>
       <p:sp>
         <p:nvSpPr>
-          <p:cNvPr id="10" name="PDF_TEXT_GROUP_393"/>
+          <p:cNvPr id="10" name="PDF_TEXT_GROUP_388"/>
           <p:cNvSpPr txBox="1"/>
           <p:nvPr/>
         </p:nvSpPr>
@@ -22753,7 +22504,7 @@
       </p:sp>
       <p:sp>
         <p:nvSpPr>
-          <p:cNvPr id="11" name="PDF_TEXT_GROUP_394"/>
+          <p:cNvPr id="11" name="PDF_TEXT_GROUP_389"/>
           <p:cNvSpPr txBox="1"/>
           <p:nvPr/>
         </p:nvSpPr>
@@ -22801,7 +22552,7 @@
       </p:sp>
       <p:sp>
         <p:nvSpPr>
-          <p:cNvPr id="12" name="PDF_TEXT_GROUP_395"/>
+          <p:cNvPr id="12" name="PDF_TEXT_GROUP_390"/>
           <p:cNvSpPr txBox="1"/>
           <p:nvPr/>
         </p:nvSpPr>
@@ -22849,7 +22600,7 @@
       </p:sp>
       <p:sp>
         <p:nvSpPr>
-          <p:cNvPr id="13" name="PDF_TEXT_GROUP_396"/>
+          <p:cNvPr id="13" name="PDF_TEXT_GROUP_391"/>
           <p:cNvSpPr txBox="1"/>
           <p:nvPr/>
         </p:nvSpPr>
@@ -22897,7 +22648,7 @@
       </p:sp>
       <p:sp>
         <p:nvSpPr>
-          <p:cNvPr id="14" name="PDF_TEXT_GROUP_397"/>
+          <p:cNvPr id="14" name="PDF_TEXT_GROUP_392"/>
           <p:cNvSpPr txBox="1"/>
           <p:nvPr/>
         </p:nvSpPr>
@@ -22954,7 +22705,7 @@
       </p:sp>
       <p:sp>
         <p:nvSpPr>
-          <p:cNvPr id="15" name="PDF_TEXT_GROUP_398"/>
+          <p:cNvPr id="15" name="PDF_TEXT_GROUP_393"/>
           <p:cNvSpPr txBox="1"/>
           <p:nvPr/>
         </p:nvSpPr>
@@ -23002,7 +22753,7 @@
       </p:sp>
       <p:sp>
         <p:nvSpPr>
-          <p:cNvPr id="16" name="PDF_TEXT_GROUP_399"/>
+          <p:cNvPr id="16" name="PDF_TEXT_GROUP_394"/>
           <p:cNvSpPr txBox="1"/>
           <p:nvPr/>
         </p:nvSpPr>
@@ -23050,7 +22801,7 @@
       </p:sp>
       <p:sp>
         <p:nvSpPr>
-          <p:cNvPr id="17" name="PDF_TEXT_GROUP_400"/>
+          <p:cNvPr id="17" name="PDF_TEXT_GROUP_395"/>
           <p:cNvSpPr txBox="1"/>
           <p:nvPr/>
         </p:nvSpPr>
@@ -23098,7 +22849,7 @@
       </p:sp>
       <p:sp>
         <p:nvSpPr>
-          <p:cNvPr id="18" name="PDF_TEXT_GROUP_401"/>
+          <p:cNvPr id="18" name="PDF_TEXT_GROUP_396"/>
           <p:cNvSpPr txBox="1"/>
           <p:nvPr/>
         </p:nvSpPr>
@@ -23146,7 +22897,7 @@
       </p:sp>
       <p:sp>
         <p:nvSpPr>
-          <p:cNvPr id="19" name="PDF_TEXT_GROUP_402"/>
+          <p:cNvPr id="19" name="PDF_TEXT_GROUP_397"/>
           <p:cNvSpPr txBox="1"/>
           <p:nvPr/>
         </p:nvSpPr>
@@ -23194,7 +22945,7 @@
       </p:sp>
       <p:sp>
         <p:nvSpPr>
-          <p:cNvPr id="20" name="PDF_TEXT_GROUP_403"/>
+          <p:cNvPr id="20" name="PDF_TEXT_GROUP_398"/>
           <p:cNvSpPr txBox="1"/>
           <p:nvPr/>
         </p:nvSpPr>
@@ -23896,7 +23647,7 @@
       </p:pic>
       <p:sp>
         <p:nvSpPr>
-          <p:cNvPr id="3" name="PDF_TEXT_GROUP_404"/>
+          <p:cNvPr id="3" name="PDF_TEXT_GROUP_399"/>
           <p:cNvSpPr txBox="1"/>
           <p:nvPr/>
         </p:nvSpPr>
@@ -23944,7 +23695,7 @@
       </p:sp>
       <p:sp>
         <p:nvSpPr>
-          <p:cNvPr id="4" name="PDF_TEXT_GROUP_405"/>
+          <p:cNvPr id="4" name="PDF_TEXT_GROUP_400"/>
           <p:cNvSpPr txBox="1"/>
           <p:nvPr/>
         </p:nvSpPr>
@@ -23992,7 +23743,7 @@
       </p:sp>
       <p:sp>
         <p:nvSpPr>
-          <p:cNvPr id="5" name="PDF_TEXT_GROUP_406"/>
+          <p:cNvPr id="5" name="PDF_TEXT_GROUP_401"/>
           <p:cNvSpPr txBox="1"/>
           <p:nvPr/>
         </p:nvSpPr>
@@ -24040,7 +23791,7 @@
       </p:sp>
       <p:sp>
         <p:nvSpPr>
-          <p:cNvPr id="6" name="PDF_TEXT_GROUP_407"/>
+          <p:cNvPr id="6" name="PDF_TEXT_GROUP_402"/>
           <p:cNvSpPr txBox="1"/>
           <p:nvPr/>
         </p:nvSpPr>
@@ -24088,7 +23839,7 @@
       </p:sp>
       <p:sp>
         <p:nvSpPr>
-          <p:cNvPr id="7" name="PDF_TEXT_GROUP_408"/>
+          <p:cNvPr id="7" name="PDF_TEXT_GROUP_403"/>
           <p:cNvSpPr txBox="1"/>
           <p:nvPr/>
         </p:nvSpPr>
@@ -24136,7 +23887,7 @@
       </p:sp>
       <p:sp>
         <p:nvSpPr>
-          <p:cNvPr id="8" name="PDF_TEXT_GROUP_409"/>
+          <p:cNvPr id="8" name="PDF_TEXT_GROUP_404"/>
           <p:cNvSpPr txBox="1"/>
           <p:nvPr/>
         </p:nvSpPr>
@@ -24184,7 +23935,7 @@
       </p:sp>
       <p:sp>
         <p:nvSpPr>
-          <p:cNvPr id="9" name="PDF_TEXT_GROUP_410"/>
+          <p:cNvPr id="9" name="PDF_TEXT_GROUP_405"/>
           <p:cNvSpPr txBox="1"/>
           <p:nvPr/>
         </p:nvSpPr>
@@ -24232,7 +23983,7 @@
       </p:sp>
       <p:sp>
         <p:nvSpPr>
-          <p:cNvPr id="10" name="PDF_TEXT_GROUP_411"/>
+          <p:cNvPr id="10" name="PDF_TEXT_GROUP_406"/>
           <p:cNvSpPr txBox="1"/>
           <p:nvPr/>
         </p:nvSpPr>
@@ -24289,7 +24040,7 @@
       </p:sp>
       <p:sp>
         <p:nvSpPr>
-          <p:cNvPr id="11" name="PDF_TEXT_GROUP_412"/>
+          <p:cNvPr id="11" name="PDF_TEXT_GROUP_407"/>
           <p:cNvSpPr txBox="1"/>
           <p:nvPr/>
         </p:nvSpPr>
@@ -24346,7 +24097,7 @@
       </p:sp>
       <p:sp>
         <p:nvSpPr>
-          <p:cNvPr id="12" name="PDF_TEXT_GROUP_413"/>
+          <p:cNvPr id="12" name="PDF_TEXT_GROUP_408"/>
           <p:cNvSpPr txBox="1"/>
           <p:nvPr/>
         </p:nvSpPr>
@@ -24394,7 +24145,7 @@
       </p:sp>
       <p:sp>
         <p:nvSpPr>
-          <p:cNvPr id="13" name="PDF_TEXT_GROUP_414"/>
+          <p:cNvPr id="13" name="PDF_TEXT_GROUP_409"/>
           <p:cNvSpPr txBox="1"/>
           <p:nvPr/>
         </p:nvSpPr>
@@ -24442,7 +24193,7 @@
       </p:sp>
       <p:sp>
         <p:nvSpPr>
-          <p:cNvPr id="14" name="PDF_TEXT_GROUP_415"/>
+          <p:cNvPr id="14" name="PDF_TEXT_GROUP_410"/>
           <p:cNvSpPr txBox="1"/>
           <p:nvPr/>
         </p:nvSpPr>
@@ -24490,7 +24241,7 @@
       </p:sp>
       <p:sp>
         <p:nvSpPr>
-          <p:cNvPr id="15" name="PDF_TEXT_GROUP_416"/>
+          <p:cNvPr id="15" name="PDF_TEXT_GROUP_411"/>
           <p:cNvSpPr txBox="1"/>
           <p:nvPr/>
         </p:nvSpPr>
@@ -24547,7 +24298,7 @@
       </p:sp>
       <p:sp>
         <p:nvSpPr>
-          <p:cNvPr id="16" name="PDF_TEXT_GROUP_417"/>
+          <p:cNvPr id="16" name="PDF_TEXT_GROUP_412"/>
           <p:cNvSpPr txBox="1"/>
           <p:nvPr/>
         </p:nvSpPr>
@@ -24595,7 +24346,7 @@
       </p:sp>
       <p:sp>
         <p:nvSpPr>
-          <p:cNvPr id="17" name="PDF_TEXT_GROUP_418"/>
+          <p:cNvPr id="17" name="PDF_TEXT_GROUP_413"/>
           <p:cNvSpPr txBox="1"/>
           <p:nvPr/>
         </p:nvSpPr>
@@ -24643,7 +24394,7 @@
       </p:sp>
       <p:sp>
         <p:nvSpPr>
-          <p:cNvPr id="18" name="PDF_TEXT_GROUP_419"/>
+          <p:cNvPr id="18" name="PDF_TEXT_GROUP_414"/>
           <p:cNvSpPr txBox="1"/>
           <p:nvPr/>
         </p:nvSpPr>
@@ -24691,7 +24442,7 @@
       </p:sp>
       <p:sp>
         <p:nvSpPr>
-          <p:cNvPr id="19" name="PDF_TEXT_GROUP_420"/>
+          <p:cNvPr id="19" name="PDF_TEXT_GROUP_415"/>
           <p:cNvSpPr txBox="1"/>
           <p:nvPr/>
         </p:nvSpPr>
@@ -24739,7 +24490,7 @@
       </p:sp>
       <p:sp>
         <p:nvSpPr>
-          <p:cNvPr id="20" name="PDF_TEXT_GROUP_421"/>
+          <p:cNvPr id="20" name="PDF_TEXT_GROUP_416"/>
           <p:cNvSpPr txBox="1"/>
           <p:nvPr/>
         </p:nvSpPr>
@@ -24796,7 +24547,7 @@
       </p:sp>
       <p:sp>
         <p:nvSpPr>
-          <p:cNvPr id="21" name="PDF_TEXT_GROUP_422"/>
+          <p:cNvPr id="21" name="PDF_TEXT_GROUP_417"/>
           <p:cNvSpPr txBox="1"/>
           <p:nvPr/>
         </p:nvSpPr>
@@ -24853,7 +24604,7 @@
       </p:sp>
       <p:sp>
         <p:nvSpPr>
-          <p:cNvPr id="22" name="PDF_TEXT_GROUP_423"/>
+          <p:cNvPr id="22" name="PDF_TEXT_GROUP_418"/>
           <p:cNvSpPr txBox="1"/>
           <p:nvPr/>
         </p:nvSpPr>
@@ -24901,7 +24652,7 @@
       </p:sp>
       <p:sp>
         <p:nvSpPr>
-          <p:cNvPr id="23" name="PDF_TEXT_GROUP_424"/>
+          <p:cNvPr id="23" name="PDF_TEXT_GROUP_419"/>
           <p:cNvSpPr txBox="1"/>
           <p:nvPr/>
         </p:nvSpPr>
@@ -24949,7 +24700,7 @@
       </p:sp>
       <p:sp>
         <p:nvSpPr>
-          <p:cNvPr id="24" name="PDF_TEXT_GROUP_425"/>
+          <p:cNvPr id="24" name="PDF_TEXT_GROUP_420"/>
           <p:cNvSpPr txBox="1"/>
           <p:nvPr/>
         </p:nvSpPr>
@@ -24997,7 +24748,7 @@
       </p:sp>
       <p:sp>
         <p:nvSpPr>
-          <p:cNvPr id="25" name="PDF_TEXT_GROUP_426"/>
+          <p:cNvPr id="25" name="PDF_TEXT_GROUP_421"/>
           <p:cNvSpPr txBox="1"/>
           <p:nvPr/>
         </p:nvSpPr>
@@ -25045,7 +24796,7 @@
       </p:sp>
       <p:sp>
         <p:nvSpPr>
-          <p:cNvPr id="26" name="PDF_TEXT_GROUP_427"/>
+          <p:cNvPr id="26" name="PDF_TEXT_GROUP_422"/>
           <p:cNvSpPr txBox="1"/>
           <p:nvPr/>
         </p:nvSpPr>
@@ -25093,7 +24844,7 @@
       </p:sp>
       <p:sp>
         <p:nvSpPr>
-          <p:cNvPr id="27" name="PDF_TEXT_GROUP_428"/>
+          <p:cNvPr id="27" name="PDF_TEXT_GROUP_423"/>
           <p:cNvSpPr txBox="1"/>
           <p:nvPr/>
         </p:nvSpPr>
@@ -25183,7 +24934,7 @@
       </p:pic>
       <p:sp>
         <p:nvSpPr>
-          <p:cNvPr id="3" name="PDF_TEXT_GROUP_429"/>
+          <p:cNvPr id="3" name="PDF_TEXT_GROUP_424"/>
           <p:cNvSpPr txBox="1"/>
           <p:nvPr/>
         </p:nvSpPr>
@@ -25231,7 +24982,7 @@
       </p:sp>
       <p:sp>
         <p:nvSpPr>
-          <p:cNvPr id="4" name="PDF_TEXT_GROUP_430"/>
+          <p:cNvPr id="4" name="PDF_TEXT_GROUP_425"/>
           <p:cNvSpPr txBox="1"/>
           <p:nvPr/>
         </p:nvSpPr>
@@ -25279,7 +25030,7 @@
       </p:sp>
       <p:sp>
         <p:nvSpPr>
-          <p:cNvPr id="5" name="PDF_TEXT_GROUP_431"/>
+          <p:cNvPr id="5" name="PDF_TEXT_GROUP_426"/>
           <p:cNvSpPr txBox="1"/>
           <p:nvPr/>
         </p:nvSpPr>
@@ -25327,7 +25078,7 @@
       </p:sp>
       <p:sp>
         <p:nvSpPr>
-          <p:cNvPr id="6" name="PDF_TEXT_GROUP_432"/>
+          <p:cNvPr id="6" name="PDF_TEXT_GROUP_427"/>
           <p:cNvSpPr txBox="1"/>
           <p:nvPr/>
         </p:nvSpPr>
@@ -25375,7 +25126,7 @@
       </p:sp>
       <p:sp>
         <p:nvSpPr>
-          <p:cNvPr id="7" name="PDF_TEXT_GROUP_433"/>
+          <p:cNvPr id="7" name="PDF_TEXT_GROUP_428"/>
           <p:cNvSpPr txBox="1"/>
           <p:nvPr/>
         </p:nvSpPr>
@@ -25432,7 +25183,7 @@
       </p:sp>
       <p:sp>
         <p:nvSpPr>
-          <p:cNvPr id="8" name="PDF_TEXT_GROUP_434"/>
+          <p:cNvPr id="8" name="PDF_TEXT_GROUP_429"/>
           <p:cNvSpPr txBox="1"/>
           <p:nvPr/>
         </p:nvSpPr>
@@ -25489,7 +25240,7 @@
       </p:sp>
       <p:sp>
         <p:nvSpPr>
-          <p:cNvPr id="9" name="PDF_TEXT_GROUP_435"/>
+          <p:cNvPr id="9" name="PDF_TEXT_GROUP_430"/>
           <p:cNvSpPr txBox="1"/>
           <p:nvPr/>
         </p:nvSpPr>
@@ -25546,7 +25297,7 @@
       </p:sp>
       <p:sp>
         <p:nvSpPr>
-          <p:cNvPr id="10" name="PDF_TEXT_GROUP_436"/>
+          <p:cNvPr id="10" name="PDF_TEXT_GROUP_431"/>
           <p:cNvSpPr txBox="1"/>
           <p:nvPr/>
         </p:nvSpPr>
@@ -25594,7 +25345,7 @@
       </p:sp>
       <p:sp>
         <p:nvSpPr>
-          <p:cNvPr id="11" name="PDF_TEXT_GROUP_437"/>
+          <p:cNvPr id="11" name="PDF_TEXT_GROUP_432"/>
           <p:cNvSpPr txBox="1"/>
           <p:nvPr/>
         </p:nvSpPr>
@@ -25642,7 +25393,7 @@
       </p:sp>
       <p:sp>
         <p:nvSpPr>
-          <p:cNvPr id="12" name="PDF_TEXT_GROUP_438"/>
+          <p:cNvPr id="12" name="PDF_TEXT_GROUP_433"/>
           <p:cNvSpPr txBox="1"/>
           <p:nvPr/>
         </p:nvSpPr>
@@ -25690,7 +25441,7 @@
       </p:sp>
       <p:sp>
         <p:nvSpPr>
-          <p:cNvPr id="13" name="PDF_TEXT_GROUP_439"/>
+          <p:cNvPr id="13" name="PDF_TEXT_GROUP_434"/>
           <p:cNvSpPr txBox="1"/>
           <p:nvPr/>
         </p:nvSpPr>
@@ -25747,7 +25498,7 @@
       </p:sp>
       <p:sp>
         <p:nvSpPr>
-          <p:cNvPr id="14" name="PDF_TEXT_GROUP_440"/>
+          <p:cNvPr id="14" name="PDF_TEXT_GROUP_435"/>
           <p:cNvSpPr txBox="1"/>
           <p:nvPr/>
         </p:nvSpPr>
@@ -25795,7 +25546,7 @@
       </p:sp>
       <p:sp>
         <p:nvSpPr>
-          <p:cNvPr id="15" name="PDF_TEXT_GROUP_441"/>
+          <p:cNvPr id="15" name="PDF_TEXT_GROUP_436"/>
           <p:cNvSpPr txBox="1"/>
           <p:nvPr/>
         </p:nvSpPr>
@@ -25843,7 +25594,7 @@
       </p:sp>
       <p:sp>
         <p:nvSpPr>
-          <p:cNvPr id="16" name="PDF_TEXT_GROUP_442"/>
+          <p:cNvPr id="16" name="PDF_TEXT_GROUP_437"/>
           <p:cNvSpPr txBox="1"/>
           <p:nvPr/>
         </p:nvSpPr>
@@ -25900,7 +25651,7 @@
       </p:sp>
       <p:sp>
         <p:nvSpPr>
-          <p:cNvPr id="17" name="PDF_TEXT_GROUP_443"/>
+          <p:cNvPr id="17" name="PDF_TEXT_GROUP_438"/>
           <p:cNvSpPr txBox="1"/>
           <p:nvPr/>
         </p:nvSpPr>
@@ -25948,7 +25699,7 @@
       </p:sp>
       <p:sp>
         <p:nvSpPr>
-          <p:cNvPr id="18" name="PDF_TEXT_GROUP_444"/>
+          <p:cNvPr id="18" name="PDF_TEXT_GROUP_439"/>
           <p:cNvSpPr txBox="1"/>
           <p:nvPr/>
         </p:nvSpPr>
@@ -25996,7 +25747,7 @@
       </p:sp>
       <p:sp>
         <p:nvSpPr>
-          <p:cNvPr id="19" name="PDF_TEXT_GROUP_445"/>
+          <p:cNvPr id="19" name="PDF_TEXT_GROUP_440"/>
           <p:cNvSpPr txBox="1"/>
           <p:nvPr/>
         </p:nvSpPr>
@@ -26044,7 +25795,7 @@
       </p:sp>
       <p:sp>
         <p:nvSpPr>
-          <p:cNvPr id="20" name="PDF_TEXT_GROUP_446"/>
+          <p:cNvPr id="20" name="PDF_TEXT_GROUP_441"/>
           <p:cNvSpPr txBox="1"/>
           <p:nvPr/>
         </p:nvSpPr>
@@ -26092,7 +25843,7 @@
       </p:sp>
       <p:sp>
         <p:nvSpPr>
-          <p:cNvPr id="21" name="PDF_TEXT_GROUP_447"/>
+          <p:cNvPr id="21" name="PDF_TEXT_GROUP_442"/>
           <p:cNvSpPr txBox="1"/>
           <p:nvPr/>
         </p:nvSpPr>
@@ -26182,7 +25933,7 @@
       </p:pic>
       <p:sp>
         <p:nvSpPr>
-          <p:cNvPr id="3" name="PDF_TEXT_GROUP_448"/>
+          <p:cNvPr id="3" name="PDF_TEXT_GROUP_443"/>
           <p:cNvSpPr txBox="1"/>
           <p:nvPr/>
         </p:nvSpPr>
@@ -26230,7 +25981,7 @@
       </p:sp>
       <p:sp>
         <p:nvSpPr>
-          <p:cNvPr id="4" name="PDF_TEXT_GROUP_449"/>
+          <p:cNvPr id="4" name="PDF_TEXT_GROUP_444"/>
           <p:cNvSpPr txBox="1"/>
           <p:nvPr/>
         </p:nvSpPr>
@@ -26296,7 +26047,7 @@
       </p:sp>
       <p:sp>
         <p:nvSpPr>
-          <p:cNvPr id="5" name="PDF_TEXT_GROUP_450"/>
+          <p:cNvPr id="5" name="PDF_TEXT_GROUP_445"/>
           <p:cNvSpPr txBox="1"/>
           <p:nvPr/>
         </p:nvSpPr>
@@ -26362,7 +26113,7 @@
       </p:sp>
       <p:sp>
         <p:nvSpPr>
-          <p:cNvPr id="6" name="PDF_TEXT_GROUP_451"/>
+          <p:cNvPr id="6" name="PDF_TEXT_GROUP_446"/>
           <p:cNvSpPr txBox="1"/>
           <p:nvPr/>
         </p:nvSpPr>
@@ -26419,7 +26170,7 @@
       </p:sp>
       <p:sp>
         <p:nvSpPr>
-          <p:cNvPr id="7" name="PDF_TEXT_GROUP_452"/>
+          <p:cNvPr id="7" name="PDF_TEXT_GROUP_447"/>
           <p:cNvSpPr txBox="1"/>
           <p:nvPr/>
         </p:nvSpPr>
@@ -26476,7 +26227,7 @@
       </p:sp>
       <p:sp>
         <p:nvSpPr>
-          <p:cNvPr id="8" name="PDF_TEXT_GROUP_453"/>
+          <p:cNvPr id="8" name="PDF_TEXT_GROUP_448"/>
           <p:cNvSpPr txBox="1"/>
           <p:nvPr/>
         </p:nvSpPr>
@@ -26533,7 +26284,7 @@
       </p:sp>
       <p:sp>
         <p:nvSpPr>
-          <p:cNvPr id="9" name="PDF_TEXT_GROUP_454"/>
+          <p:cNvPr id="9" name="PDF_TEXT_GROUP_449"/>
           <p:cNvSpPr txBox="1"/>
           <p:nvPr/>
         </p:nvSpPr>
@@ -26581,7 +26332,7 @@
       </p:sp>
       <p:sp>
         <p:nvSpPr>
-          <p:cNvPr id="10" name="PDF_TEXT_GROUP_455"/>
+          <p:cNvPr id="10" name="PDF_TEXT_GROUP_450"/>
           <p:cNvSpPr txBox="1"/>
           <p:nvPr/>
         </p:nvSpPr>
@@ -26629,7 +26380,7 @@
       </p:sp>
       <p:sp>
         <p:nvSpPr>
-          <p:cNvPr id="11" name="PDF_TEXT_GROUP_456"/>
+          <p:cNvPr id="11" name="PDF_TEXT_GROUP_451"/>
           <p:cNvSpPr txBox="1"/>
           <p:nvPr/>
         </p:nvSpPr>
@@ -26677,7 +26428,7 @@
       </p:sp>
       <p:sp>
         <p:nvSpPr>
-          <p:cNvPr id="12" name="PDF_TEXT_GROUP_457"/>
+          <p:cNvPr id="12" name="PDF_TEXT_GROUP_452"/>
           <p:cNvSpPr txBox="1"/>
           <p:nvPr/>
         </p:nvSpPr>
@@ -26725,7 +26476,7 @@
       </p:sp>
       <p:sp>
         <p:nvSpPr>
-          <p:cNvPr id="13" name="PDF_TEXT_GROUP_458"/>
+          <p:cNvPr id="13" name="PDF_TEXT_GROUP_453"/>
           <p:cNvSpPr txBox="1"/>
           <p:nvPr/>
         </p:nvSpPr>
@@ -26773,7 +26524,7 @@
       </p:sp>
       <p:sp>
         <p:nvSpPr>
-          <p:cNvPr id="14" name="PDF_BULLET_SPAN_648"/>
+          <p:cNvPr id="14" name="PDF_BULLET_SPAN_642"/>
           <p:cNvSpPr/>
           <p:nvPr/>
         </p:nvSpPr>
@@ -26816,7 +26567,7 @@
       </p:sp>
       <p:sp>
         <p:nvSpPr>
-          <p:cNvPr id="15" name="PDF_BULLET_SPAN_652"/>
+          <p:cNvPr id="15" name="PDF_BULLET_SPAN_646"/>
           <p:cNvSpPr/>
           <p:nvPr/>
         </p:nvSpPr>
@@ -26859,7 +26610,7 @@
       </p:sp>
       <p:sp>
         <p:nvSpPr>
-          <p:cNvPr id="16" name="PDF_BULLET_SPAN_656"/>
+          <p:cNvPr id="16" name="PDF_BULLET_SPAN_650"/>
           <p:cNvSpPr/>
           <p:nvPr/>
         </p:nvSpPr>
@@ -26902,7 +26653,7 @@
       </p:sp>
       <p:sp>
         <p:nvSpPr>
-          <p:cNvPr id="17" name="PDF_BULLET_SPAN_659"/>
+          <p:cNvPr id="17" name="PDF_BULLET_SPAN_653"/>
           <p:cNvSpPr/>
           <p:nvPr/>
         </p:nvSpPr>
@@ -26987,7 +26738,7 @@
       </p:pic>
       <p:sp>
         <p:nvSpPr>
-          <p:cNvPr id="3" name="PDF_TEXT_GROUP_459"/>
+          <p:cNvPr id="3" name="PDF_TEXT_GROUP_454"/>
           <p:cNvSpPr txBox="1"/>
           <p:nvPr/>
         </p:nvSpPr>
@@ -27035,7 +26786,7 @@
       </p:sp>
       <p:sp>
         <p:nvSpPr>
-          <p:cNvPr id="4" name="PDF_TEXT_GROUP_460"/>
+          <p:cNvPr id="4" name="PDF_TEXT_GROUP_455"/>
           <p:cNvSpPr txBox="1"/>
           <p:nvPr/>
         </p:nvSpPr>
@@ -27092,7 +26843,7 @@
       </p:sp>
       <p:sp>
         <p:nvSpPr>
-          <p:cNvPr id="5" name="PDF_TEXT_GROUP_461"/>
+          <p:cNvPr id="5" name="PDF_TEXT_GROUP_456"/>
           <p:cNvSpPr txBox="1"/>
           <p:nvPr/>
         </p:nvSpPr>
@@ -27149,7 +26900,7 @@
       </p:sp>
       <p:sp>
         <p:nvSpPr>
-          <p:cNvPr id="6" name="PDF_TEXT_GROUP_462"/>
+          <p:cNvPr id="6" name="PDF_TEXT_GROUP_457"/>
           <p:cNvSpPr txBox="1"/>
           <p:nvPr/>
         </p:nvSpPr>
@@ -27215,7 +26966,7 @@
       </p:sp>
       <p:sp>
         <p:nvSpPr>
-          <p:cNvPr id="7" name="PDF_TEXT_GROUP_463"/>
+          <p:cNvPr id="7" name="PDF_TEXT_GROUP_458"/>
           <p:cNvSpPr txBox="1"/>
           <p:nvPr/>
         </p:nvSpPr>
@@ -27272,7 +27023,7 @@
       </p:sp>
       <p:sp>
         <p:nvSpPr>
-          <p:cNvPr id="8" name="PDF_TEXT_GROUP_464"/>
+          <p:cNvPr id="8" name="PDF_TEXT_GROUP_459"/>
           <p:cNvSpPr txBox="1"/>
           <p:nvPr/>
         </p:nvSpPr>
@@ -27329,7 +27080,7 @@
       </p:sp>
       <p:sp>
         <p:nvSpPr>
-          <p:cNvPr id="9" name="PDF_TEXT_GROUP_465"/>
+          <p:cNvPr id="9" name="PDF_TEXT_GROUP_460"/>
           <p:cNvSpPr txBox="1"/>
           <p:nvPr/>
         </p:nvSpPr>
@@ -27377,7 +27128,7 @@
       </p:sp>
       <p:sp>
         <p:nvSpPr>
-          <p:cNvPr id="10" name="PDF_TEXT_GROUP_466"/>
+          <p:cNvPr id="10" name="PDF_TEXT_GROUP_461"/>
           <p:cNvSpPr txBox="1"/>
           <p:nvPr/>
         </p:nvSpPr>
@@ -27425,7 +27176,7 @@
       </p:sp>
       <p:sp>
         <p:nvSpPr>
-          <p:cNvPr id="11" name="PDF_TEXT_GROUP_467"/>
+          <p:cNvPr id="11" name="PDF_TEXT_GROUP_462"/>
           <p:cNvSpPr txBox="1"/>
           <p:nvPr/>
         </p:nvSpPr>
@@ -27473,7 +27224,7 @@
       </p:sp>
       <p:sp>
         <p:nvSpPr>
-          <p:cNvPr id="12" name="PDF_TEXT_GROUP_468"/>
+          <p:cNvPr id="12" name="PDF_TEXT_GROUP_463"/>
           <p:cNvSpPr txBox="1"/>
           <p:nvPr/>
         </p:nvSpPr>
@@ -27521,7 +27272,7 @@
       </p:sp>
       <p:sp>
         <p:nvSpPr>
-          <p:cNvPr id="13" name="PDF_TEXT_GROUP_469"/>
+          <p:cNvPr id="13" name="PDF_TEXT_GROUP_464"/>
           <p:cNvSpPr txBox="1"/>
           <p:nvPr/>
         </p:nvSpPr>
@@ -27611,7 +27362,7 @@
       </p:pic>
       <p:sp>
         <p:nvSpPr>
-          <p:cNvPr id="3" name="PDF_TEXT_GROUP_470"/>
+          <p:cNvPr id="3" name="PDF_TEXT_GROUP_465"/>
           <p:cNvSpPr txBox="1"/>
           <p:nvPr/>
         </p:nvSpPr>
@@ -27659,7 +27410,7 @@
       </p:sp>
       <p:sp>
         <p:nvSpPr>
-          <p:cNvPr id="4" name="PDF_TEXT_GROUP_471"/>
+          <p:cNvPr id="4" name="PDF_TEXT_GROUP_466"/>
           <p:cNvSpPr txBox="1"/>
           <p:nvPr/>
         </p:nvSpPr>
@@ -27707,7 +27458,7 @@
       </p:sp>
       <p:sp>
         <p:nvSpPr>
-          <p:cNvPr id="5" name="PDF_TEXT_GROUP_472"/>
+          <p:cNvPr id="5" name="PDF_TEXT_GROUP_467"/>
           <p:cNvSpPr txBox="1"/>
           <p:nvPr/>
         </p:nvSpPr>
@@ -27755,7 +27506,7 @@
       </p:sp>
       <p:sp>
         <p:nvSpPr>
-          <p:cNvPr id="6" name="PDF_TEXT_GROUP_473"/>
+          <p:cNvPr id="6" name="PDF_TEXT_GROUP_468"/>
           <p:cNvSpPr txBox="1"/>
           <p:nvPr/>
         </p:nvSpPr>
@@ -27803,7 +27554,7 @@
       </p:sp>
       <p:sp>
         <p:nvSpPr>
-          <p:cNvPr id="7" name="PDF_TEXT_GROUP_474"/>
+          <p:cNvPr id="7" name="PDF_TEXT_GROUP_469"/>
           <p:cNvSpPr txBox="1"/>
           <p:nvPr/>
         </p:nvSpPr>
@@ -27851,7 +27602,7 @@
       </p:sp>
       <p:sp>
         <p:nvSpPr>
-          <p:cNvPr id="8" name="PDF_TEXT_GROUP_475"/>
+          <p:cNvPr id="8" name="PDF_TEXT_GROUP_470"/>
           <p:cNvSpPr txBox="1"/>
           <p:nvPr/>
         </p:nvSpPr>
@@ -27899,7 +27650,7 @@
       </p:sp>
       <p:sp>
         <p:nvSpPr>
-          <p:cNvPr id="9" name="PDF_TEXT_GROUP_476"/>
+          <p:cNvPr id="9" name="PDF_TEXT_GROUP_471"/>
           <p:cNvSpPr txBox="1"/>
           <p:nvPr/>
         </p:nvSpPr>
@@ -27947,7 +27698,7 @@
       </p:sp>
       <p:sp>
         <p:nvSpPr>
-          <p:cNvPr id="10" name="PDF_TEXT_GROUP_477"/>
+          <p:cNvPr id="10" name="PDF_TEXT_GROUP_472"/>
           <p:cNvSpPr txBox="1"/>
           <p:nvPr/>
         </p:nvSpPr>
@@ -27995,7 +27746,7 @@
       </p:sp>
       <p:sp>
         <p:nvSpPr>
-          <p:cNvPr id="11" name="PDF_TEXT_GROUP_478"/>
+          <p:cNvPr id="11" name="PDF_TEXT_GROUP_473"/>
           <p:cNvSpPr txBox="1"/>
           <p:nvPr/>
         </p:nvSpPr>
@@ -28043,7 +27794,7 @@
       </p:sp>
       <p:sp>
         <p:nvSpPr>
-          <p:cNvPr id="12" name="PDF_TEXT_GROUP_479"/>
+          <p:cNvPr id="12" name="PDF_TEXT_GROUP_474"/>
           <p:cNvSpPr txBox="1"/>
           <p:nvPr/>
         </p:nvSpPr>
@@ -28100,7 +27851,7 @@
       </p:sp>
       <p:sp>
         <p:nvSpPr>
-          <p:cNvPr id="13" name="PDF_TEXT_GROUP_480"/>
+          <p:cNvPr id="13" name="PDF_TEXT_GROUP_475"/>
           <p:cNvSpPr txBox="1"/>
           <p:nvPr/>
         </p:nvSpPr>
@@ -28148,7 +27899,7 @@
       </p:sp>
       <p:sp>
         <p:nvSpPr>
-          <p:cNvPr id="14" name="PDF_TEXT_GROUP_481"/>
+          <p:cNvPr id="14" name="PDF_TEXT_GROUP_476"/>
           <p:cNvSpPr txBox="1"/>
           <p:nvPr/>
         </p:nvSpPr>
@@ -28196,7 +27947,7 @@
       </p:sp>
       <p:sp>
         <p:nvSpPr>
-          <p:cNvPr id="15" name="PDF_TEXT_GROUP_482"/>
+          <p:cNvPr id="15" name="PDF_TEXT_GROUP_477"/>
           <p:cNvSpPr txBox="1"/>
           <p:nvPr/>
         </p:nvSpPr>
@@ -28244,7 +27995,7 @@
       </p:sp>
       <p:sp>
         <p:nvSpPr>
-          <p:cNvPr id="16" name="PDF_TEXT_GROUP_483"/>
+          <p:cNvPr id="16" name="PDF_TEXT_GROUP_478"/>
           <p:cNvSpPr txBox="1"/>
           <p:nvPr/>
         </p:nvSpPr>
@@ -28292,7 +28043,7 @@
       </p:sp>
       <p:sp>
         <p:nvSpPr>
-          <p:cNvPr id="17" name="PDF_TEXT_GROUP_484"/>
+          <p:cNvPr id="17" name="PDF_TEXT_GROUP_479"/>
           <p:cNvSpPr txBox="1"/>
           <p:nvPr/>
         </p:nvSpPr>
@@ -28382,7 +28133,7 @@
       </p:pic>
       <p:sp>
         <p:nvSpPr>
-          <p:cNvPr id="3" name="PDF_TEXT_GROUP_485"/>
+          <p:cNvPr id="3" name="PDF_TEXT_GROUP_480"/>
           <p:cNvSpPr txBox="1"/>
           <p:nvPr/>
         </p:nvSpPr>
@@ -28430,7 +28181,7 @@
       </p:sp>
       <p:sp>
         <p:nvSpPr>
-          <p:cNvPr id="4" name="PDF_TEXT_GROUP_486"/>
+          <p:cNvPr id="4" name="PDF_TEXT_GROUP_481"/>
           <p:cNvSpPr txBox="1"/>
           <p:nvPr/>
         </p:nvSpPr>
@@ -28478,7 +28229,7 @@
       </p:sp>
       <p:sp>
         <p:nvSpPr>
-          <p:cNvPr id="5" name="PDF_TEXT_GROUP_487"/>
+          <p:cNvPr id="5" name="PDF_TEXT_GROUP_482"/>
           <p:cNvSpPr txBox="1"/>
           <p:nvPr/>
         </p:nvSpPr>
@@ -28526,7 +28277,7 @@
       </p:sp>
       <p:sp>
         <p:nvSpPr>
-          <p:cNvPr id="6" name="PDF_TEXT_GROUP_488"/>
+          <p:cNvPr id="6" name="PDF_TEXT_GROUP_483"/>
           <p:cNvSpPr txBox="1"/>
           <p:nvPr/>
         </p:nvSpPr>
@@ -28574,7 +28325,7 @@
       </p:sp>
       <p:sp>
         <p:nvSpPr>
-          <p:cNvPr id="7" name="PDF_TEXT_GROUP_489"/>
+          <p:cNvPr id="7" name="PDF_TEXT_GROUP_484"/>
           <p:cNvSpPr txBox="1"/>
           <p:nvPr/>
         </p:nvSpPr>
@@ -28622,7 +28373,7 @@
       </p:sp>
       <p:sp>
         <p:nvSpPr>
-          <p:cNvPr id="8" name="PDF_TEXT_GROUP_490"/>
+          <p:cNvPr id="8" name="PDF_TEXT_GROUP_485"/>
           <p:cNvSpPr txBox="1"/>
           <p:nvPr/>
         </p:nvSpPr>
@@ -28670,7 +28421,7 @@
       </p:sp>
       <p:sp>
         <p:nvSpPr>
-          <p:cNvPr id="9" name="PDF_TEXT_GROUP_491"/>
+          <p:cNvPr id="9" name="PDF_TEXT_GROUP_486"/>
           <p:cNvSpPr txBox="1"/>
           <p:nvPr/>
         </p:nvSpPr>
@@ -28718,7 +28469,7 @@
       </p:sp>
       <p:sp>
         <p:nvSpPr>
-          <p:cNvPr id="10" name="PDF_TEXT_GROUP_492"/>
+          <p:cNvPr id="10" name="PDF_TEXT_GROUP_487"/>
           <p:cNvSpPr txBox="1"/>
           <p:nvPr/>
         </p:nvSpPr>
@@ -28766,7 +28517,7 @@
       </p:sp>
       <p:sp>
         <p:nvSpPr>
-          <p:cNvPr id="11" name="PDF_TEXT_GROUP_493"/>
+          <p:cNvPr id="11" name="PDF_TEXT_GROUP_488"/>
           <p:cNvSpPr txBox="1"/>
           <p:nvPr/>
         </p:nvSpPr>
@@ -28814,7 +28565,7 @@
       </p:sp>
       <p:sp>
         <p:nvSpPr>
-          <p:cNvPr id="12" name="PDF_TEXT_GROUP_494"/>
+          <p:cNvPr id="12" name="PDF_TEXT_GROUP_489"/>
           <p:cNvSpPr txBox="1"/>
           <p:nvPr/>
         </p:nvSpPr>
@@ -28871,7 +28622,7 @@
       </p:sp>
       <p:sp>
         <p:nvSpPr>
-          <p:cNvPr id="13" name="PDF_TEXT_GROUP_495"/>
+          <p:cNvPr id="13" name="PDF_TEXT_GROUP_490"/>
           <p:cNvSpPr txBox="1"/>
           <p:nvPr/>
         </p:nvSpPr>
@@ -28919,7 +28670,7 @@
       </p:sp>
       <p:sp>
         <p:nvSpPr>
-          <p:cNvPr id="14" name="PDF_TEXT_GROUP_496"/>
+          <p:cNvPr id="14" name="PDF_TEXT_GROUP_491"/>
           <p:cNvSpPr txBox="1"/>
           <p:nvPr/>
         </p:nvSpPr>
@@ -29021,7 +28772,7 @@
       </p:sp>
       <p:sp>
         <p:nvSpPr>
-          <p:cNvPr id="15" name="PDF_TEXT_GROUP_497"/>
+          <p:cNvPr id="15" name="PDF_TEXT_GROUP_492"/>
           <p:cNvSpPr txBox="1"/>
           <p:nvPr/>
         </p:nvSpPr>
@@ -29069,7 +28820,7 @@
       </p:sp>
       <p:sp>
         <p:nvSpPr>
-          <p:cNvPr id="16" name="PDF_TEXT_GROUP_498"/>
+          <p:cNvPr id="16" name="PDF_TEXT_GROUP_493"/>
           <p:cNvSpPr txBox="1"/>
           <p:nvPr/>
         </p:nvSpPr>
@@ -29117,7 +28868,7 @@
       </p:sp>
       <p:sp>
         <p:nvSpPr>
-          <p:cNvPr id="17" name="PDF_TEXT_GROUP_499"/>
+          <p:cNvPr id="17" name="PDF_TEXT_GROUP_494"/>
           <p:cNvSpPr txBox="1"/>
           <p:nvPr/>
         </p:nvSpPr>
@@ -29165,7 +28916,7 @@
       </p:sp>
       <p:sp>
         <p:nvSpPr>
-          <p:cNvPr id="18" name="PDF_TEXT_GROUP_500"/>
+          <p:cNvPr id="18" name="PDF_TEXT_GROUP_495"/>
           <p:cNvSpPr txBox="1"/>
           <p:nvPr/>
         </p:nvSpPr>
@@ -29213,7 +28964,7 @@
       </p:sp>
       <p:sp>
         <p:nvSpPr>
-          <p:cNvPr id="19" name="PDF_TEXT_GROUP_501"/>
+          <p:cNvPr id="19" name="PDF_TEXT_GROUP_496"/>
           <p:cNvSpPr txBox="1"/>
           <p:nvPr/>
         </p:nvSpPr>
@@ -29261,7 +29012,7 @@
       </p:sp>
       <p:sp>
         <p:nvSpPr>
-          <p:cNvPr id="20" name="PDF_TEXT_GROUP_502"/>
+          <p:cNvPr id="20" name="PDF_TEXT_GROUP_497"/>
           <p:cNvSpPr txBox="1"/>
           <p:nvPr/>
         </p:nvSpPr>
@@ -29351,7 +29102,7 @@
       </p:pic>
       <p:sp>
         <p:nvSpPr>
-          <p:cNvPr id="3" name="PDF_TEXT_GROUP_503"/>
+          <p:cNvPr id="3" name="PDF_TEXT_GROUP_498"/>
           <p:cNvSpPr txBox="1"/>
           <p:nvPr/>
         </p:nvSpPr>
@@ -29399,7 +29150,7 @@
       </p:sp>
       <p:sp>
         <p:nvSpPr>
-          <p:cNvPr id="4" name="PDF_TEXT_GROUP_504"/>
+          <p:cNvPr id="4" name="PDF_TEXT_GROUP_499"/>
           <p:cNvSpPr txBox="1"/>
           <p:nvPr/>
         </p:nvSpPr>
@@ -29456,7 +29207,7 @@
       </p:sp>
       <p:sp>
         <p:nvSpPr>
-          <p:cNvPr id="5" name="PDF_TEXT_GROUP_505"/>
+          <p:cNvPr id="5" name="PDF_TEXT_GROUP_500"/>
           <p:cNvSpPr txBox="1"/>
           <p:nvPr/>
         </p:nvSpPr>
@@ -29513,7 +29264,7 @@
       </p:sp>
       <p:sp>
         <p:nvSpPr>
-          <p:cNvPr id="6" name="PDF_TEXT_GROUP_506"/>
+          <p:cNvPr id="6" name="PDF_TEXT_GROUP_501"/>
           <p:cNvSpPr txBox="1"/>
           <p:nvPr/>
         </p:nvSpPr>
@@ -29570,7 +29321,7 @@
       </p:sp>
       <p:sp>
         <p:nvSpPr>
-          <p:cNvPr id="7" name="PDF_TEXT_GROUP_507"/>
+          <p:cNvPr id="7" name="PDF_TEXT_GROUP_502"/>
           <p:cNvSpPr txBox="1"/>
           <p:nvPr/>
         </p:nvSpPr>
@@ -29627,7 +29378,7 @@
       </p:sp>
       <p:sp>
         <p:nvSpPr>
-          <p:cNvPr id="8" name="PDF_TEXT_GROUP_508"/>
+          <p:cNvPr id="8" name="PDF_TEXT_GROUP_503"/>
           <p:cNvSpPr txBox="1"/>
           <p:nvPr/>
         </p:nvSpPr>
@@ -29684,7 +29435,7 @@
       </p:sp>
       <p:sp>
         <p:nvSpPr>
-          <p:cNvPr id="9" name="PDF_TEXT_GROUP_509"/>
+          <p:cNvPr id="9" name="PDF_TEXT_GROUP_504"/>
           <p:cNvSpPr txBox="1"/>
           <p:nvPr/>
         </p:nvSpPr>
@@ -29732,7 +29483,7 @@
       </p:sp>
       <p:sp>
         <p:nvSpPr>
-          <p:cNvPr id="10" name="PDF_TEXT_GROUP_510"/>
+          <p:cNvPr id="10" name="PDF_TEXT_GROUP_505"/>
           <p:cNvSpPr txBox="1"/>
           <p:nvPr/>
         </p:nvSpPr>
@@ -29789,7 +29540,7 @@
       </p:sp>
       <p:sp>
         <p:nvSpPr>
-          <p:cNvPr id="11" name="PDF_TEXT_GROUP_511"/>
+          <p:cNvPr id="11" name="PDF_TEXT_GROUP_506"/>
           <p:cNvSpPr txBox="1"/>
           <p:nvPr/>
         </p:nvSpPr>
@@ -29846,7 +29597,7 @@
       </p:sp>
       <p:sp>
         <p:nvSpPr>
-          <p:cNvPr id="12" name="PDF_TEXT_GROUP_512"/>
+          <p:cNvPr id="12" name="PDF_TEXT_GROUP_507"/>
           <p:cNvSpPr txBox="1"/>
           <p:nvPr/>
         </p:nvSpPr>
@@ -29894,7 +29645,7 @@
       </p:sp>
       <p:sp>
         <p:nvSpPr>
-          <p:cNvPr id="13" name="PDF_TEXT_GROUP_513"/>
+          <p:cNvPr id="13" name="PDF_TEXT_GROUP_508"/>
           <p:cNvSpPr txBox="1"/>
           <p:nvPr/>
         </p:nvSpPr>
@@ -29951,7 +29702,7 @@
       </p:sp>
       <p:sp>
         <p:nvSpPr>
-          <p:cNvPr id="14" name="PDF_TEXT_GROUP_514"/>
+          <p:cNvPr id="14" name="PDF_TEXT_GROUP_509"/>
           <p:cNvSpPr txBox="1"/>
           <p:nvPr/>
         </p:nvSpPr>
@@ -29999,7 +29750,7 @@
       </p:sp>
       <p:sp>
         <p:nvSpPr>
-          <p:cNvPr id="15" name="PDF_TEXT_GROUP_515"/>
+          <p:cNvPr id="15" name="PDF_TEXT_GROUP_510"/>
           <p:cNvSpPr txBox="1"/>
           <p:nvPr/>
         </p:nvSpPr>
@@ -30047,7 +29798,7 @@
       </p:sp>
       <p:sp>
         <p:nvSpPr>
-          <p:cNvPr id="16" name="PDF_TEXT_GROUP_516"/>
+          <p:cNvPr id="16" name="PDF_TEXT_GROUP_511"/>
           <p:cNvSpPr txBox="1"/>
           <p:nvPr/>
         </p:nvSpPr>
@@ -30095,7 +29846,7 @@
       </p:sp>
       <p:sp>
         <p:nvSpPr>
-          <p:cNvPr id="17" name="PDF_TEXT_GROUP_517"/>
+          <p:cNvPr id="17" name="PDF_TEXT_GROUP_512"/>
           <p:cNvSpPr txBox="1"/>
           <p:nvPr/>
         </p:nvSpPr>
@@ -30143,7 +29894,7 @@
       </p:sp>
       <p:sp>
         <p:nvSpPr>
-          <p:cNvPr id="18" name="PDF_TEXT_GROUP_518"/>
+          <p:cNvPr id="18" name="PDF_TEXT_GROUP_513"/>
           <p:cNvSpPr txBox="1"/>
           <p:nvPr/>
         </p:nvSpPr>
@@ -30191,7 +29942,7 @@
       </p:sp>
       <p:sp>
         <p:nvSpPr>
-          <p:cNvPr id="19" name="PDF_TEXT_GROUP_519"/>
+          <p:cNvPr id="19" name="PDF_TEXT_GROUP_514"/>
           <p:cNvSpPr txBox="1"/>
           <p:nvPr/>
         </p:nvSpPr>
@@ -30281,7 +30032,7 @@
       </p:pic>
       <p:sp>
         <p:nvSpPr>
-          <p:cNvPr id="3" name="PDF_TEXT_GROUP_520"/>
+          <p:cNvPr id="3" name="PDF_TEXT_GROUP_515"/>
           <p:cNvSpPr txBox="1"/>
           <p:nvPr/>
         </p:nvSpPr>
@@ -30329,7 +30080,7 @@
       </p:sp>
       <p:sp>
         <p:nvSpPr>
-          <p:cNvPr id="4" name="PDF_TEXT_GROUP_521"/>
+          <p:cNvPr id="4" name="PDF_TEXT_GROUP_516"/>
           <p:cNvSpPr txBox="1"/>
           <p:nvPr/>
         </p:nvSpPr>
@@ -30386,7 +30137,7 @@
       </p:sp>
       <p:sp>
         <p:nvSpPr>
-          <p:cNvPr id="5" name="PDF_TEXT_GROUP_522"/>
+          <p:cNvPr id="5" name="PDF_TEXT_GROUP_517"/>
           <p:cNvSpPr txBox="1"/>
           <p:nvPr/>
         </p:nvSpPr>
@@ -30443,7 +30194,7 @@
       </p:sp>
       <p:sp>
         <p:nvSpPr>
-          <p:cNvPr id="6" name="PDF_TEXT_GROUP_523"/>
+          <p:cNvPr id="6" name="PDF_TEXT_GROUP_518"/>
           <p:cNvSpPr txBox="1"/>
           <p:nvPr/>
         </p:nvSpPr>
@@ -30500,7 +30251,7 @@
       </p:sp>
       <p:sp>
         <p:nvSpPr>
-          <p:cNvPr id="7" name="PDF_TEXT_GROUP_524"/>
+          <p:cNvPr id="7" name="PDF_TEXT_GROUP_519"/>
           <p:cNvSpPr txBox="1"/>
           <p:nvPr/>
         </p:nvSpPr>
@@ -30557,7 +30308,7 @@
       </p:sp>
       <p:sp>
         <p:nvSpPr>
-          <p:cNvPr id="8" name="PDF_TEXT_GROUP_525"/>
+          <p:cNvPr id="8" name="PDF_TEXT_GROUP_520"/>
           <p:cNvSpPr txBox="1"/>
           <p:nvPr/>
         </p:nvSpPr>
@@ -30605,7 +30356,7 @@
       </p:sp>
       <p:sp>
         <p:nvSpPr>
-          <p:cNvPr id="9" name="PDF_TEXT_GROUP_526"/>
+          <p:cNvPr id="9" name="PDF_TEXT_GROUP_521"/>
           <p:cNvSpPr txBox="1"/>
           <p:nvPr/>
         </p:nvSpPr>
@@ -30662,7 +30413,7 @@
       </p:sp>
       <p:sp>
         <p:nvSpPr>
-          <p:cNvPr id="10" name="PDF_TEXT_GROUP_527"/>
+          <p:cNvPr id="10" name="PDF_TEXT_GROUP_522"/>
           <p:cNvSpPr txBox="1"/>
           <p:nvPr/>
         </p:nvSpPr>
@@ -30710,7 +30461,7 @@
       </p:sp>
       <p:sp>
         <p:nvSpPr>
-          <p:cNvPr id="11" name="PDF_TEXT_GROUP_528"/>
+          <p:cNvPr id="11" name="PDF_TEXT_GROUP_523"/>
           <p:cNvSpPr txBox="1"/>
           <p:nvPr/>
         </p:nvSpPr>
@@ -30767,7 +30518,7 @@
       </p:sp>
       <p:sp>
         <p:nvSpPr>
-          <p:cNvPr id="12" name="PDF_TEXT_GROUP_529"/>
+          <p:cNvPr id="12" name="PDF_TEXT_GROUP_524"/>
           <p:cNvSpPr txBox="1"/>
           <p:nvPr/>
         </p:nvSpPr>
@@ -30824,7 +30575,7 @@
       </p:sp>
       <p:sp>
         <p:nvSpPr>
-          <p:cNvPr id="13" name="PDF_TEXT_GROUP_530"/>
+          <p:cNvPr id="13" name="PDF_TEXT_GROUP_525"/>
           <p:cNvSpPr txBox="1"/>
           <p:nvPr/>
         </p:nvSpPr>
@@ -30872,7 +30623,7 @@
       </p:sp>
       <p:sp>
         <p:nvSpPr>
-          <p:cNvPr id="14" name="PDF_TEXT_GROUP_531"/>
+          <p:cNvPr id="14" name="PDF_TEXT_GROUP_526"/>
           <p:cNvSpPr txBox="1"/>
           <p:nvPr/>
         </p:nvSpPr>
@@ -30920,7 +30671,7 @@
       </p:sp>
       <p:sp>
         <p:nvSpPr>
-          <p:cNvPr id="15" name="PDF_TEXT_GROUP_532"/>
+          <p:cNvPr id="15" name="PDF_TEXT_GROUP_527"/>
           <p:cNvSpPr txBox="1"/>
           <p:nvPr/>
         </p:nvSpPr>
@@ -30968,7 +30719,7 @@
       </p:sp>
       <p:sp>
         <p:nvSpPr>
-          <p:cNvPr id="16" name="PDF_TEXT_GROUP_533"/>
+          <p:cNvPr id="16" name="PDF_TEXT_GROUP_528"/>
           <p:cNvSpPr txBox="1"/>
           <p:nvPr/>
         </p:nvSpPr>
@@ -31016,7 +30767,7 @@
       </p:sp>
       <p:sp>
         <p:nvSpPr>
-          <p:cNvPr id="17" name="PDF_TEXT_GROUP_534"/>
+          <p:cNvPr id="17" name="PDF_TEXT_GROUP_529"/>
           <p:cNvSpPr txBox="1"/>
           <p:nvPr/>
         </p:nvSpPr>
@@ -31064,7 +30815,7 @@
       </p:sp>
       <p:sp>
         <p:nvSpPr>
-          <p:cNvPr id="18" name="PDF_TEXT_GROUP_535"/>
+          <p:cNvPr id="18" name="PDF_TEXT_GROUP_530"/>
           <p:cNvSpPr txBox="1"/>
           <p:nvPr/>
         </p:nvSpPr>
@@ -31154,7 +30905,7 @@
       </p:pic>
       <p:sp>
         <p:nvSpPr>
-          <p:cNvPr id="3" name="PDF_TEXT_GROUP_536"/>
+          <p:cNvPr id="3" name="PDF_TEXT_GROUP_531"/>
           <p:cNvSpPr txBox="1"/>
           <p:nvPr/>
         </p:nvSpPr>
@@ -31202,7 +30953,7 @@
       </p:sp>
       <p:sp>
         <p:nvSpPr>
-          <p:cNvPr id="4" name="PDF_TEXT_GROUP_537"/>
+          <p:cNvPr id="4" name="PDF_TEXT_GROUP_532"/>
           <p:cNvSpPr txBox="1"/>
           <p:nvPr/>
         </p:nvSpPr>
@@ -31259,7 +31010,7 @@
       </p:sp>
       <p:sp>
         <p:nvSpPr>
-          <p:cNvPr id="5" name="PDF_TEXT_GROUP_538"/>
+          <p:cNvPr id="5" name="PDF_TEXT_GROUP_533"/>
           <p:cNvSpPr txBox="1"/>
           <p:nvPr/>
         </p:nvSpPr>
@@ -31316,7 +31067,7 @@
       </p:sp>
       <p:sp>
         <p:nvSpPr>
-          <p:cNvPr id="6" name="PDF_TEXT_GROUP_539"/>
+          <p:cNvPr id="6" name="PDF_TEXT_GROUP_534"/>
           <p:cNvSpPr txBox="1"/>
           <p:nvPr/>
         </p:nvSpPr>
@@ -31373,7 +31124,7 @@
       </p:sp>
       <p:sp>
         <p:nvSpPr>
-          <p:cNvPr id="7" name="PDF_TEXT_GROUP_540"/>
+          <p:cNvPr id="7" name="PDF_TEXT_GROUP_535"/>
           <p:cNvSpPr txBox="1"/>
           <p:nvPr/>
         </p:nvSpPr>
@@ -31430,7 +31181,7 @@
       </p:sp>
       <p:sp>
         <p:nvSpPr>
-          <p:cNvPr id="8" name="PDF_TEXT_GROUP_541"/>
+          <p:cNvPr id="8" name="PDF_TEXT_GROUP_536"/>
           <p:cNvSpPr txBox="1"/>
           <p:nvPr/>
         </p:nvSpPr>
@@ -31487,7 +31238,7 @@
       </p:sp>
       <p:sp>
         <p:nvSpPr>
-          <p:cNvPr id="9" name="PDF_TEXT_GROUP_542"/>
+          <p:cNvPr id="9" name="PDF_TEXT_GROUP_537"/>
           <p:cNvSpPr txBox="1"/>
           <p:nvPr/>
         </p:nvSpPr>
@@ -31535,7 +31286,7 @@
       </p:sp>
       <p:sp>
         <p:nvSpPr>
-          <p:cNvPr id="10" name="PDF_TEXT_GROUP_543"/>
+          <p:cNvPr id="10" name="PDF_TEXT_GROUP_538"/>
           <p:cNvSpPr txBox="1"/>
           <p:nvPr/>
         </p:nvSpPr>
@@ -31592,7 +31343,7 @@
       </p:sp>
       <p:sp>
         <p:nvSpPr>
-          <p:cNvPr id="11" name="PDF_TEXT_GROUP_544"/>
+          <p:cNvPr id="11" name="PDF_TEXT_GROUP_539"/>
           <p:cNvSpPr txBox="1"/>
           <p:nvPr/>
         </p:nvSpPr>
@@ -31640,7 +31391,7 @@
       </p:sp>
       <p:sp>
         <p:nvSpPr>
-          <p:cNvPr id="12" name="PDF_TEXT_GROUP_545"/>
+          <p:cNvPr id="12" name="PDF_TEXT_GROUP_540"/>
           <p:cNvSpPr txBox="1"/>
           <p:nvPr/>
         </p:nvSpPr>
@@ -31697,7 +31448,7 @@
       </p:sp>
       <p:sp>
         <p:nvSpPr>
-          <p:cNvPr id="13" name="PDF_TEXT_GROUP_546"/>
+          <p:cNvPr id="13" name="PDF_TEXT_GROUP_541"/>
           <p:cNvSpPr txBox="1"/>
           <p:nvPr/>
         </p:nvSpPr>
@@ -31745,7 +31496,7 @@
       </p:sp>
       <p:sp>
         <p:nvSpPr>
-          <p:cNvPr id="14" name="PDF_TEXT_GROUP_547"/>
+          <p:cNvPr id="14" name="PDF_TEXT_GROUP_542"/>
           <p:cNvSpPr txBox="1"/>
           <p:nvPr/>
         </p:nvSpPr>
@@ -31793,7 +31544,7 @@
       </p:sp>
       <p:sp>
         <p:nvSpPr>
-          <p:cNvPr id="15" name="PDF_TEXT_GROUP_548"/>
+          <p:cNvPr id="15" name="PDF_TEXT_GROUP_543"/>
           <p:cNvSpPr txBox="1"/>
           <p:nvPr/>
         </p:nvSpPr>
@@ -31841,7 +31592,7 @@
       </p:sp>
       <p:sp>
         <p:nvSpPr>
-          <p:cNvPr id="16" name="PDF_TEXT_GROUP_549"/>
+          <p:cNvPr id="16" name="PDF_TEXT_GROUP_544"/>
           <p:cNvSpPr txBox="1"/>
           <p:nvPr/>
         </p:nvSpPr>
@@ -31889,7 +31640,7 @@
       </p:sp>
       <p:sp>
         <p:nvSpPr>
-          <p:cNvPr id="17" name="PDF_TEXT_GROUP_550"/>
+          <p:cNvPr id="17" name="PDF_TEXT_GROUP_545"/>
           <p:cNvSpPr txBox="1"/>
           <p:nvPr/>
         </p:nvSpPr>
@@ -31937,7 +31688,7 @@
       </p:sp>
       <p:sp>
         <p:nvSpPr>
-          <p:cNvPr id="18" name="PDF_TEXT_GROUP_551"/>
+          <p:cNvPr id="18" name="PDF_TEXT_GROUP_546"/>
           <p:cNvSpPr txBox="1"/>
           <p:nvPr/>
         </p:nvSpPr>

</xml_diff>

<commit_message>
docs: connect DNMP authorization precedent across proposal
</commit_message>
<xml_diff>
--- a/docs/PAPER/proposal-defense/slides/NDNSF_proposal_hybrid_editable.pptx
+++ b/docs/PAPER/proposal-defense/slides/NDNSF_proposal_hybrid_editable.pptx
@@ -393,7 +393,7 @@
           <a:p>
             <a:r>
               <a:rPr lang="en-US" sz="1200"/>
-              <a:t>KP-ABE encodes an access policy in each entity’s decryption key. [19] NDNSF combines service entitlements in that policy while retaining identity-signing credentials. [28] Challenge checks reuse these permissions for invocation; User permission keys and challenge processing still add cost. This avoids a separate role-based invocation policy in NDNSF. It does not eliminate key updates or prove lower total cost; role-based designs can also reuse credentials.</a:t>
+              <a:t>KP-ABE encodes an access policy in each entity’s decryption key. [19] NDNSF combines service entitlements in that policy while retaining identity-signing credentials. [28] Challenge checks reuse these permissions for invocation; User permission keys and challenge processing still add cost. DNMP [12] expresses command permissions through role keys and a Trust Schema. Roles can cover several permissions. Compare credential, policy and key updates; reuse alone does not prove lower total cost.</a:t>
             </a:r>
             <a:endParaRPr lang="en-US" sz="1200"/>
           </a:p>
@@ -1625,7 +1625,7 @@
           <a:p>
             <a:r>
               <a:rPr lang="en-US" sz="1200"/>
-              <a:t>RQ Required evidence Outcome and cost RQ1 Full authorization alternatives; unauthorized call, challenge/replay and withdrawal cases No unauthorized handler start; discovery delay, key/policy size, status delay and rekey traffic RQ2 One UAV and one DI graph; wrong role/edge; direct/cache parity; cancellation/replacement Correct task completion; validation, transfer and recovery cost RQ3 Matched workload and failure schedules; feasible single-device control; cold/warm state Completion plus latency, redundant work, bytes, uncertainty, and cases with no advantage Planned tests are not completed findings. Record all scheduled runs and failure boundaries.</a:t>
+              <a:t>RQ Required evidence Outcome and cost RQ1 ABE-backed versus DNMP-inspired rules plus encryption; unauthorized call, replay and withdrawal cases No unauthorized handler start; discovery delay, key/policy size, status delay and rekey traffic RQ2 One UAV and one DI graph; wrong role/edge; direct/cache parity; cancellation/replacement Correct task completion; validation, transfer and recovery cost RQ3 Matched workload and failure schedules; feasible single-device control; cold/warm state Completion plus latency, redundant work, bytes, uncertainty, and cases with no advantage Planned tests are not completed findings. Record all scheduled runs and failure boundaries.</a:t>
             </a:r>
             <a:endParaRPr lang="en-US" sz="1200"/>
           </a:p>
@@ -1737,7 +1737,7 @@
           <a:p>
             <a:r>
               <a:rPr lang="en-US" sz="1200"/>
-              <a:t>RQ1 answer: when ABE-encrypted discovery and ABE-backed service authorization justify their management and revocation costs. RQ2 answer: exactly which task-assignment mistakes are rejected and which recovery behavior is supported. RQ3 answer: measured benefits, negative results and deployment limits. Reproducible configurations and evidence linking each conclusion to its tested scope. The outcome is a tested service protocol and an evidence-backed account of when its mechanisms are worth their cost.</a:t>
+              <a:t>RQ1 answer: when ABE-backed authorization is preferable to DNMP-inspired role rules plus encryption, accounting for confidentiality, management and withdrawal costs. RQ2 answer: exactly which task-assignment mistakes are rejected and which recovery behavior is supported. RQ3 answer: measured benefits, negative results and deployment limits. Reproducible configurations and evidence linking each conclusion to its tested scope. The outcome is a tested service protocol and an evidence-backed account of when its mechanisms are worth their cost.</a:t>
             </a:r>
             <a:endParaRPr lang="en-US" sz="1200"/>
           </a:p>
@@ -2073,7 +2073,7 @@
           <a:p>
             <a:r>
               <a:rPr lang="en-US" sz="1200"/>
-              <a:t>NDN building block Remaining application responsibility Named Data and signatures [1] Validate signatures and signing-key relationships under trust rules; check task permissions separately Interest retrieval and caching [1,26] Enforce task identity, dependencies, and deadlines; caching is not persistent storage Dataset synchronization / SVS [2,3] Discover new names, then retrieve Data; define service-message state transitions NAC [4] / enhanced NAC-ABE [19] Use content encryption for read access; separately check service-invocation permissions and state NAC: Name-based Access Control; ABE: attribute-based encryption; SVS: State Vector Sync. NDNSF builds on these mechanisms; it does not invent them.</a:t>
+              <a:t>NDN building block Remaining application responsibility Named Data and signatures [1] Validate signatures under application trust policies, expressible through a Trust Schema [16] Interest retrieval and caching [1,26] Enforce task identity, dependencies, and deadlines; caching is not persistent storage Dataset synchronization / SVS [2,3] Discover new names, then retrieve Data; define service-message state transitions NAC [4] / enhanced NAC-ABE [19] Use content encryption for read access; separately check service-invocation permissions and state NAC: Name-based Access Control; ABE: attribute-based encryption; SVS: State Vector Sync. NDNSF builds on these mechanisms; it does not invent them.</a:t>
             </a:r>
             <a:endParaRPr lang="en-US" sz="1200"/>
           </a:p>
@@ -2241,7 +2241,7 @@
           <a:p>
             <a:r>
               <a:rPr lang="en-US" sz="1200"/>
-              <a:t>Prior work What the comparison must acknowledge NFN [6], NFaaS [7] Named computation and function execution/placement RICE [9], NSC [10] Invocation and security mechanisms; NSC validates signed calls using application trust rules DNMP [12] Role- and command-constrained signing and verification CaSCON [15] Service-composition research; requires a feature-level comparison before claiming a new composition mechanism gRPC [17,27] Complete configurations can include discovery/resolver integration, not only fixed addresses Collaboration research: make runtime assignments constrain intermediate Data use. Discovery and authorization are evaluated separately.</a:t>
+              <a:t>Prior work What the comparison must acknowledge NFN [6], NFaaS [7] Named computation and function execution/placement RICE [9], NSC [10] Invocation mechanisms; NSC checks signed calls using a Trust Schema DNMP [12] Trust Schema constrains roles and measurement commands CaSCON [15] Service-composition research; requires a feature-level comparison before claiming a new composition mechanism gRPC [17,27] Complete configurations can include discovery/resolver integration, not only fixed addresses Collaboration research: make runtime assignments constrain intermediate Data use. Discovery and authorization are evaluated separately.</a:t>
             </a:r>
             <a:endParaRPr lang="en-US" sz="1200"/>
           </a:p>
@@ -7177,7 +7177,7 @@
         </p:nvSpPr>
         <p:spPr>
           <a:xfrm>
-            <a:off x="1618972" y="2204706"/>
+            <a:off x="1618972" y="2023644"/>
             <a:ext cx="11203069" cy="440633"/>
           </a:xfrm>
           <a:prstGeom prst="rect">
@@ -7225,7 +7225,7 @@
         </p:nvSpPr>
         <p:spPr>
           <a:xfrm>
-            <a:off x="1618972" y="2739134"/>
+            <a:off x="1618972" y="2558072"/>
             <a:ext cx="10090610" cy="929891"/>
           </a:xfrm>
           <a:prstGeom prst="rect">
@@ -7282,7 +7282,7 @@
         </p:nvSpPr>
         <p:spPr>
           <a:xfrm>
-            <a:off x="1618972" y="3711401"/>
+            <a:off x="1618972" y="3530339"/>
             <a:ext cx="12209254" cy="929891"/>
           </a:xfrm>
           <a:prstGeom prst="rect">
@@ -7339,8 +7339,8 @@
         </p:nvSpPr>
         <p:spPr>
           <a:xfrm>
-            <a:off x="1143656" y="5305089"/>
-            <a:ext cx="12478059" cy="929891"/>
+            <a:off x="1143656" y="5138827"/>
+            <a:ext cx="12456195" cy="1367730"/>
           </a:xfrm>
           <a:prstGeom prst="rect">
             <a:avLst/>
@@ -7374,7 +7374,7 @@
                 </a:solidFill>
                 <a:latin typeface="Latin Modern Sans"/>
               </a:rPr>
-              <a:t>This avoids a separate role-based invocation policy in NDNSF. It does not eliminate</a:t>
+              <a:t>DNMP [12] expresses command permissions through role keys and a Trust Schema.</a:t>
             </a:r>
             <a:r>
               <a:rPr sz="2710" b="0" i="0">
@@ -7383,7 +7383,16 @@
                 </a:solidFill>
                 <a:latin typeface="Latin Modern Sans"/>
               </a:rPr>
-              <a:t> key updates or prove lower total cost; role-based designs can also reuse credentials.</a:t>
+              <a:t> Roles can cover several permissions. Compare credential, policy and key updates;</a:t>
+            </a:r>
+            <a:r>
+              <a:rPr sz="2710" b="0" i="0">
+                <a:solidFill>
+                  <a:srgbClr val="000000"/>
+                </a:solidFill>
+                <a:latin typeface="Latin Modern Sans"/>
+              </a:rPr>
+              <a:t> reuse alone does not prove lower total cost.</a:t>
             </a:r>
           </a:p>
         </p:txBody>
@@ -7636,7 +7645,7 @@
         </p:nvSpPr>
         <p:spPr>
           <a:xfrm rot="5400000">
-            <a:off x="1207424" y="2290497"/>
+            <a:off x="1207424" y="2109435"/>
             <a:ext cx="197164" cy="197164"/>
           </a:xfrm>
           <a:prstGeom prst="triangle">
@@ -7679,7 +7688,7 @@
         </p:nvSpPr>
         <p:spPr>
           <a:xfrm rot="5400000">
-            <a:off x="1207424" y="2824925"/>
+            <a:off x="1207424" y="2643863"/>
             <a:ext cx="197164" cy="197164"/>
           </a:xfrm>
           <a:prstGeom prst="triangle">
@@ -7722,7 +7731,7 @@
         </p:nvSpPr>
         <p:spPr>
           <a:xfrm rot="5400000">
-            <a:off x="1207424" y="3797192"/>
+            <a:off x="1207424" y="3616130"/>
             <a:ext cx="197164" cy="197164"/>
           </a:xfrm>
           <a:prstGeom prst="triangle">
@@ -10639,7 +10648,7 @@
       </p:sp>
       <p:sp>
         <p:nvSpPr>
-          <p:cNvPr id="14" name="PDF_BULLET_SPAN_288"/>
+          <p:cNvPr id="14" name="PDF_BULLET_SPAN_289"/>
           <p:cNvSpPr/>
           <p:nvPr/>
         </p:nvSpPr>
@@ -10682,7 +10691,7 @@
       </p:sp>
       <p:sp>
         <p:nvSpPr>
-          <p:cNvPr id="15" name="PDF_BULLET_SPAN_291"/>
+          <p:cNvPr id="15" name="PDF_BULLET_SPAN_292"/>
           <p:cNvSpPr/>
           <p:nvPr/>
         </p:nvSpPr>
@@ -10725,7 +10734,7 @@
       </p:sp>
       <p:sp>
         <p:nvSpPr>
-          <p:cNvPr id="16" name="PDF_BULLET_SPAN_293"/>
+          <p:cNvPr id="16" name="PDF_BULLET_SPAN_294"/>
           <p:cNvSpPr/>
           <p:nvPr/>
         </p:nvSpPr>
@@ -10768,7 +10777,7 @@
       </p:sp>
       <p:sp>
         <p:nvSpPr>
-          <p:cNvPr id="17" name="PDF_BULLET_SPAN_296"/>
+          <p:cNvPr id="17" name="PDF_BULLET_SPAN_297"/>
           <p:cNvSpPr/>
           <p:nvPr/>
         </p:nvSpPr>
@@ -11378,7 +11387,7 @@
       </p:sp>
       <p:sp>
         <p:nvSpPr>
-          <p:cNvPr id="13" name="PDF_BULLET_SPAN_307"/>
+          <p:cNvPr id="13" name="PDF_BULLET_SPAN_308"/>
           <p:cNvSpPr/>
           <p:nvPr/>
         </p:nvSpPr>
@@ -11421,7 +11430,7 @@
       </p:sp>
       <p:sp>
         <p:nvSpPr>
-          <p:cNvPr id="14" name="PDF_BULLET_SPAN_310"/>
+          <p:cNvPr id="14" name="PDF_BULLET_SPAN_311"/>
           <p:cNvSpPr/>
           <p:nvPr/>
         </p:nvSpPr>
@@ -11464,7 +11473,7 @@
       </p:sp>
       <p:sp>
         <p:nvSpPr>
-          <p:cNvPr id="15" name="PDF_BULLET_SPAN_313"/>
+          <p:cNvPr id="15" name="PDF_BULLET_SPAN_314"/>
           <p:cNvSpPr/>
           <p:nvPr/>
         </p:nvSpPr>
@@ -12113,7 +12122,7 @@
       </p:sp>
       <p:sp>
         <p:nvSpPr>
-          <p:cNvPr id="14" name="PDF_BULLET_SPAN_325"/>
+          <p:cNvPr id="14" name="PDF_BULLET_SPAN_326"/>
           <p:cNvSpPr/>
           <p:nvPr/>
         </p:nvSpPr>
@@ -12156,7 +12165,7 @@
       </p:sp>
       <p:sp>
         <p:nvSpPr>
-          <p:cNvPr id="15" name="PDF_BULLET_SPAN_327"/>
+          <p:cNvPr id="15" name="PDF_BULLET_SPAN_328"/>
           <p:cNvSpPr/>
           <p:nvPr/>
         </p:nvSpPr>
@@ -12199,7 +12208,7 @@
       </p:sp>
       <p:sp>
         <p:nvSpPr>
-          <p:cNvPr id="16" name="PDF_BULLET_SPAN_330"/>
+          <p:cNvPr id="16" name="PDF_BULLET_SPAN_331"/>
           <p:cNvSpPr/>
           <p:nvPr/>
         </p:nvSpPr>
@@ -12242,7 +12251,7 @@
       </p:sp>
       <p:sp>
         <p:nvSpPr>
-          <p:cNvPr id="17" name="PDF_BULLET_SPAN_333"/>
+          <p:cNvPr id="17" name="PDF_BULLET_SPAN_334"/>
           <p:cNvSpPr/>
           <p:nvPr/>
         </p:nvSpPr>
@@ -17642,7 +17651,7 @@
       </p:sp>
       <p:sp>
         <p:nvSpPr>
-          <p:cNvPr id="14" name="PDF_BULLET_SPAN_445"/>
+          <p:cNvPr id="14" name="PDF_BULLET_SPAN_446"/>
           <p:cNvSpPr/>
           <p:nvPr/>
         </p:nvSpPr>
@@ -17685,7 +17694,7 @@
       </p:sp>
       <p:sp>
         <p:nvSpPr>
-          <p:cNvPr id="15" name="PDF_BULLET_SPAN_447"/>
+          <p:cNvPr id="15" name="PDF_BULLET_SPAN_448"/>
           <p:cNvSpPr/>
           <p:nvPr/>
         </p:nvSpPr>
@@ -17728,7 +17737,7 @@
       </p:sp>
       <p:sp>
         <p:nvSpPr>
-          <p:cNvPr id="16" name="PDF_BULLET_SPAN_450"/>
+          <p:cNvPr id="16" name="PDF_BULLET_SPAN_451"/>
           <p:cNvSpPr/>
           <p:nvPr/>
         </p:nvSpPr>
@@ -17771,7 +17780,7 @@
       </p:sp>
       <p:sp>
         <p:nvSpPr>
-          <p:cNvPr id="17" name="PDF_BULLET_SPAN_453"/>
+          <p:cNvPr id="17" name="PDF_BULLET_SPAN_454"/>
           <p:cNvSpPr/>
           <p:nvPr/>
         </p:nvSpPr>
@@ -18633,7 +18642,7 @@
       </p:sp>
       <p:sp>
         <p:nvSpPr>
-          <p:cNvPr id="18" name="PDF_BULLET_SPAN_472"/>
+          <p:cNvPr id="18" name="PDF_BULLET_SPAN_473"/>
           <p:cNvSpPr/>
           <p:nvPr/>
         </p:nvSpPr>
@@ -18676,7 +18685,7 @@
       </p:sp>
       <p:sp>
         <p:nvSpPr>
-          <p:cNvPr id="19" name="PDF_BULLET_SPAN_475"/>
+          <p:cNvPr id="19" name="PDF_BULLET_SPAN_476"/>
           <p:cNvSpPr/>
           <p:nvPr/>
         </p:nvSpPr>
@@ -18719,7 +18728,7 @@
       </p:sp>
       <p:sp>
         <p:nvSpPr>
-          <p:cNvPr id="20" name="PDF_BULLET_SPAN_478"/>
+          <p:cNvPr id="20" name="PDF_BULLET_SPAN_479"/>
           <p:cNvSpPr/>
           <p:nvPr/>
         </p:nvSpPr>
@@ -19368,7 +19377,7 @@
       </p:sp>
       <p:sp>
         <p:nvSpPr>
-          <p:cNvPr id="14" name="PDF_BULLET_SPAN_488"/>
+          <p:cNvPr id="14" name="PDF_BULLET_SPAN_489"/>
           <p:cNvSpPr/>
           <p:nvPr/>
         </p:nvSpPr>
@@ -19411,7 +19420,7 @@
       </p:sp>
       <p:sp>
         <p:nvSpPr>
-          <p:cNvPr id="15" name="PDF_BULLET_SPAN_491"/>
+          <p:cNvPr id="15" name="PDF_BULLET_SPAN_492"/>
           <p:cNvSpPr/>
           <p:nvPr/>
         </p:nvSpPr>
@@ -19454,7 +19463,7 @@
       </p:sp>
       <p:sp>
         <p:nvSpPr>
-          <p:cNvPr id="16" name="PDF_BULLET_SPAN_494"/>
+          <p:cNvPr id="16" name="PDF_BULLET_SPAN_495"/>
           <p:cNvSpPr/>
           <p:nvPr/>
         </p:nvSpPr>
@@ -19497,7 +19506,7 @@
       </p:sp>
       <p:sp>
         <p:nvSpPr>
-          <p:cNvPr id="17" name="PDF_BULLET_SPAN_496"/>
+          <p:cNvPr id="17" name="PDF_BULLET_SPAN_497"/>
           <p:cNvSpPr/>
           <p:nvPr/>
         </p:nvSpPr>
@@ -20155,7 +20164,7 @@
       </p:sp>
       <p:sp>
         <p:nvSpPr>
-          <p:cNvPr id="14" name="PDF_BULLET_SPAN_507"/>
+          <p:cNvPr id="14" name="PDF_BULLET_SPAN_508"/>
           <p:cNvSpPr/>
           <p:nvPr/>
         </p:nvSpPr>
@@ -20198,7 +20207,7 @@
       </p:sp>
       <p:sp>
         <p:nvSpPr>
-          <p:cNvPr id="15" name="PDF_BULLET_SPAN_510"/>
+          <p:cNvPr id="15" name="PDF_BULLET_SPAN_511"/>
           <p:cNvSpPr/>
           <p:nvPr/>
         </p:nvSpPr>
@@ -20241,7 +20250,7 @@
       </p:sp>
       <p:sp>
         <p:nvSpPr>
-          <p:cNvPr id="16" name="PDF_BULLET_SPAN_513"/>
+          <p:cNvPr id="16" name="PDF_BULLET_SPAN_514"/>
           <p:cNvSpPr/>
           <p:nvPr/>
         </p:nvSpPr>
@@ -20284,7 +20293,7 @@
       </p:sp>
       <p:sp>
         <p:nvSpPr>
-          <p:cNvPr id="17" name="PDF_BULLET_SPAN_516"/>
+          <p:cNvPr id="17" name="PDF_BULLET_SPAN_517"/>
           <p:cNvSpPr/>
           <p:nvPr/>
         </p:nvSpPr>
@@ -25401,7 +25410,7 @@
         <p:spPr>
           <a:xfrm>
             <a:off x="2646188" y="1969156"/>
-            <a:ext cx="4407570" cy="385554"/>
+            <a:ext cx="5139353" cy="385554"/>
           </a:xfrm>
           <a:prstGeom prst="rect">
             <a:avLst/>
@@ -25435,7 +25444,7 @@
                 </a:solidFill>
                 <a:latin typeface="Latin Modern Sans"/>
               </a:rPr>
-              <a:t>Full authorization alternatives;</a:t>
+              <a:t>ABE-backed versus DNMP-inspired</a:t>
             </a:r>
           </a:p>
         </p:txBody>
@@ -25497,7 +25506,7 @@
         <p:spPr>
           <a:xfrm>
             <a:off x="2646187" y="2355484"/>
-            <a:ext cx="5376547" cy="828844"/>
+            <a:ext cx="5054937" cy="385554"/>
           </a:xfrm>
           <a:prstGeom prst="rect">
             <a:avLst/>
@@ -25531,8 +25540,47 @@
                 </a:solidFill>
                 <a:latin typeface="Latin Modern Sans"/>
               </a:rPr>
-              <a:t>unauthorized call, challenge/replay and</a:t>
-            </a:r>
+              <a:t>rules plus encryption; unauthorized</a:t>
+            </a:r>
+          </a:p>
+        </p:txBody>
+      </p:sp>
+      <p:sp>
+        <p:nvSpPr>
+          <p:cNvPr id="11" name="PDF_TEXT_GROUP_432"/>
+          <p:cNvSpPr txBox="1"/>
+          <p:nvPr/>
+        </p:nvSpPr>
+        <p:spPr>
+          <a:xfrm>
+            <a:off x="8280720" y="2355484"/>
+            <a:ext cx="5553511" cy="385554"/>
+          </a:xfrm>
+          <a:prstGeom prst="rect">
+            <a:avLst/>
+          </a:prstGeom>
+          <a:noFill/>
+          <a:ln>
+            <a:noFill/>
+          </a:ln>
+        </p:spPr>
+        <p:txBody>
+          <a:bodyPr wrap="square" anchor="t" lIns="0" rIns="0" tIns="0" bIns="0">
+            <a:noAutofit/>
+          </a:bodyPr>
+          <a:lstStyle/>
+          <a:p>
+            <a:pPr algn="l">
+              <a:lnSpc>
+                <a:spcPct val="100000"/>
+              </a:lnSpc>
+              <a:spcBef>
+                <a:spcPts val="0"/>
+              </a:spcBef>
+              <a:spcAft>
+                <a:spcPts val="0"/>
+              </a:spcAft>
+            </a:pPr>
             <a:r>
               <a:rPr sz="2371" b="0" i="0">
                 <a:solidFill>
@@ -25540,21 +25588,21 @@
                 </a:solidFill>
                 <a:latin typeface="Latin Modern Sans"/>
               </a:rPr>
-              <a:t> withdrawal cases</a:t>
-            </a:r>
-          </a:p>
-        </p:txBody>
-      </p:sp>
-      <p:sp>
-        <p:nvSpPr>
-          <p:cNvPr id="11" name="PDF_TEXT_GROUP_432"/>
-          <p:cNvSpPr txBox="1"/>
-          <p:nvPr/>
-        </p:nvSpPr>
-        <p:spPr>
-          <a:xfrm>
-            <a:off x="8280720" y="2355484"/>
-            <a:ext cx="5270155" cy="828844"/>
+              <a:t>discovery delay, key/policy size, status</a:t>
+            </a:r>
+          </a:p>
+        </p:txBody>
+      </p:sp>
+      <p:sp>
+        <p:nvSpPr>
+          <p:cNvPr id="12" name="PDF_TEXT_GROUP_433"/>
+          <p:cNvSpPr txBox="1"/>
+          <p:nvPr/>
+        </p:nvSpPr>
+        <p:spPr>
+          <a:xfrm>
+            <a:off x="2646187" y="2741812"/>
+            <a:ext cx="4724118" cy="385554"/>
           </a:xfrm>
           <a:prstGeom prst="rect">
             <a:avLst/>
@@ -25588,8 +25636,47 @@
                 </a:solidFill>
                 <a:latin typeface="Latin Modern Sans"/>
               </a:rPr>
-              <a:t>discovery delay, key/policy size, status</a:t>
-            </a:r>
+              <a:t>call, replay and withdrawal cases</a:t>
+            </a:r>
+          </a:p>
+        </p:txBody>
+      </p:sp>
+      <p:sp>
+        <p:nvSpPr>
+          <p:cNvPr id="13" name="PDF_TEXT_GROUP_434"/>
+          <p:cNvSpPr txBox="1"/>
+          <p:nvPr/>
+        </p:nvSpPr>
+        <p:spPr>
+          <a:xfrm>
+            <a:off x="8280720" y="2741812"/>
+            <a:ext cx="3202285" cy="385554"/>
+          </a:xfrm>
+          <a:prstGeom prst="rect">
+            <a:avLst/>
+          </a:prstGeom>
+          <a:noFill/>
+          <a:ln>
+            <a:noFill/>
+          </a:ln>
+        </p:spPr>
+        <p:txBody>
+          <a:bodyPr wrap="square" anchor="t" lIns="0" rIns="0" tIns="0" bIns="0">
+            <a:noAutofit/>
+          </a:bodyPr>
+          <a:lstStyle/>
+          <a:p>
+            <a:pPr algn="l">
+              <a:lnSpc>
+                <a:spcPct val="100000"/>
+              </a:lnSpc>
+              <a:spcBef>
+                <a:spcPts val="0"/>
+              </a:spcBef>
+              <a:spcAft>
+                <a:spcPts val="0"/>
+              </a:spcAft>
+            </a:pPr>
             <a:r>
               <a:rPr sz="2371" b="0" i="0">
                 <a:solidFill>
@@ -25597,14 +25684,14 @@
                 </a:solidFill>
                 <a:latin typeface="Latin Modern Sans"/>
               </a:rPr>
-              <a:t> delay and rekey traffic</a:t>
-            </a:r>
-          </a:p>
-        </p:txBody>
-      </p:sp>
-      <p:sp>
-        <p:nvSpPr>
-          <p:cNvPr id="12" name="PDF_TEXT_GROUP_433"/>
+              <a:t>delay and rekey traffic</a:t>
+            </a:r>
+          </a:p>
+        </p:txBody>
+      </p:sp>
+      <p:sp>
+        <p:nvSpPr>
+          <p:cNvPr id="14" name="PDF_TEXT_GROUP_435"/>
           <p:cNvSpPr txBox="1"/>
           <p:nvPr/>
         </p:nvSpPr>
@@ -25652,7 +25739,7 @@
       </p:sp>
       <p:sp>
         <p:nvSpPr>
-          <p:cNvPr id="13" name="PDF_TEXT_GROUP_434"/>
+          <p:cNvPr id="15" name="PDF_TEXT_GROUP_436"/>
           <p:cNvSpPr txBox="1"/>
           <p:nvPr/>
         </p:nvSpPr>
@@ -25700,7 +25787,7 @@
       </p:sp>
       <p:sp>
         <p:nvSpPr>
-          <p:cNvPr id="14" name="PDF_TEXT_GROUP_435"/>
+          <p:cNvPr id="16" name="PDF_TEXT_GROUP_437"/>
           <p:cNvSpPr txBox="1"/>
           <p:nvPr/>
         </p:nvSpPr>
@@ -25748,7 +25835,7 @@
       </p:sp>
       <p:sp>
         <p:nvSpPr>
-          <p:cNvPr id="15" name="PDF_TEXT_GROUP_436"/>
+          <p:cNvPr id="17" name="PDF_TEXT_GROUP_438"/>
           <p:cNvSpPr txBox="1"/>
           <p:nvPr/>
         </p:nvSpPr>
@@ -25805,7 +25892,7 @@
       </p:sp>
       <p:sp>
         <p:nvSpPr>
-          <p:cNvPr id="16" name="PDF_TEXT_GROUP_437"/>
+          <p:cNvPr id="18" name="PDF_TEXT_GROUP_439"/>
           <p:cNvSpPr txBox="1"/>
           <p:nvPr/>
         </p:nvSpPr>
@@ -25853,7 +25940,7 @@
       </p:sp>
       <p:sp>
         <p:nvSpPr>
-          <p:cNvPr id="17" name="PDF_TEXT_GROUP_438"/>
+          <p:cNvPr id="19" name="PDF_TEXT_GROUP_440"/>
           <p:cNvSpPr txBox="1"/>
           <p:nvPr/>
         </p:nvSpPr>
@@ -25901,7 +25988,7 @@
       </p:sp>
       <p:sp>
         <p:nvSpPr>
-          <p:cNvPr id="18" name="PDF_TEXT_GROUP_439"/>
+          <p:cNvPr id="20" name="PDF_TEXT_GROUP_441"/>
           <p:cNvSpPr txBox="1"/>
           <p:nvPr/>
         </p:nvSpPr>
@@ -25949,7 +26036,7 @@
       </p:sp>
       <p:sp>
         <p:nvSpPr>
-          <p:cNvPr id="19" name="PDF_TEXT_GROUP_440"/>
+          <p:cNvPr id="21" name="PDF_TEXT_GROUP_442"/>
           <p:cNvSpPr txBox="1"/>
           <p:nvPr/>
         </p:nvSpPr>
@@ -25997,7 +26084,7 @@
       </p:sp>
       <p:sp>
         <p:nvSpPr>
-          <p:cNvPr id="20" name="PDF_TEXT_GROUP_441"/>
+          <p:cNvPr id="22" name="PDF_TEXT_GROUP_443"/>
           <p:cNvSpPr txBox="1"/>
           <p:nvPr/>
         </p:nvSpPr>
@@ -26054,7 +26141,7 @@
       </p:sp>
       <p:sp>
         <p:nvSpPr>
-          <p:cNvPr id="21" name="PDF_TEXT_GROUP_442"/>
+          <p:cNvPr id="23" name="PDF_TEXT_GROUP_444"/>
           <p:cNvSpPr txBox="1"/>
           <p:nvPr/>
         </p:nvSpPr>
@@ -26111,7 +26198,7 @@
       </p:sp>
       <p:sp>
         <p:nvSpPr>
-          <p:cNvPr id="22" name="PDF_TEXT_GROUP_443"/>
+          <p:cNvPr id="24" name="PDF_TEXT_GROUP_445"/>
           <p:cNvSpPr txBox="1"/>
           <p:nvPr/>
         </p:nvSpPr>
@@ -26159,7 +26246,7 @@
       </p:sp>
       <p:sp>
         <p:nvSpPr>
-          <p:cNvPr id="23" name="PDF_TEXT_GROUP_444"/>
+          <p:cNvPr id="25" name="PDF_TEXT_GROUP_446"/>
           <p:cNvSpPr txBox="1"/>
           <p:nvPr/>
         </p:nvSpPr>
@@ -26207,7 +26294,7 @@
       </p:sp>
       <p:sp>
         <p:nvSpPr>
-          <p:cNvPr id="24" name="PDF_TEXT_GROUP_445"/>
+          <p:cNvPr id="26" name="PDF_TEXT_GROUP_447"/>
           <p:cNvSpPr txBox="1"/>
           <p:nvPr/>
         </p:nvSpPr>
@@ -26255,7 +26342,7 @@
       </p:sp>
       <p:sp>
         <p:nvSpPr>
-          <p:cNvPr id="25" name="PDF_TEXT_GROUP_446"/>
+          <p:cNvPr id="27" name="PDF_TEXT_GROUP_448"/>
           <p:cNvSpPr txBox="1"/>
           <p:nvPr/>
         </p:nvSpPr>
@@ -26303,7 +26390,7 @@
       </p:sp>
       <p:sp>
         <p:nvSpPr>
-          <p:cNvPr id="26" name="PDF_TEXT_GROUP_447"/>
+          <p:cNvPr id="28" name="PDF_TEXT_GROUP_449"/>
           <p:cNvSpPr txBox="1"/>
           <p:nvPr/>
         </p:nvSpPr>
@@ -26351,7 +26438,7 @@
       </p:sp>
       <p:sp>
         <p:nvSpPr>
-          <p:cNvPr id="27" name="PDF_TEXT_GROUP_448"/>
+          <p:cNvPr id="29" name="PDF_TEXT_GROUP_450"/>
           <p:cNvSpPr txBox="1"/>
           <p:nvPr/>
         </p:nvSpPr>
@@ -26441,7 +26528,7 @@
       </p:pic>
       <p:sp>
         <p:nvSpPr>
-          <p:cNvPr id="3" name="PDF_TEXT_GROUP_449"/>
+          <p:cNvPr id="3" name="PDF_TEXT_GROUP_451"/>
           <p:cNvSpPr txBox="1"/>
           <p:nvPr/>
         </p:nvSpPr>
@@ -26489,7 +26576,7 @@
       </p:sp>
       <p:sp>
         <p:nvSpPr>
-          <p:cNvPr id="4" name="PDF_TEXT_GROUP_450"/>
+          <p:cNvPr id="4" name="PDF_TEXT_GROUP_452"/>
           <p:cNvSpPr txBox="1"/>
           <p:nvPr/>
         </p:nvSpPr>
@@ -26537,7 +26624,7 @@
       </p:sp>
       <p:sp>
         <p:nvSpPr>
-          <p:cNvPr id="5" name="PDF_TEXT_GROUP_451"/>
+          <p:cNvPr id="5" name="PDF_TEXT_GROUP_453"/>
           <p:cNvSpPr txBox="1"/>
           <p:nvPr/>
         </p:nvSpPr>
@@ -26585,7 +26672,7 @@
       </p:sp>
       <p:sp>
         <p:nvSpPr>
-          <p:cNvPr id="6" name="PDF_TEXT_GROUP_452"/>
+          <p:cNvPr id="6" name="PDF_TEXT_GROUP_454"/>
           <p:cNvSpPr txBox="1"/>
           <p:nvPr/>
         </p:nvSpPr>
@@ -26633,7 +26720,7 @@
       </p:sp>
       <p:sp>
         <p:nvSpPr>
-          <p:cNvPr id="7" name="PDF_TEXT_GROUP_453"/>
+          <p:cNvPr id="7" name="PDF_TEXT_GROUP_455"/>
           <p:cNvSpPr txBox="1"/>
           <p:nvPr/>
         </p:nvSpPr>
@@ -26690,7 +26777,7 @@
       </p:sp>
       <p:sp>
         <p:nvSpPr>
-          <p:cNvPr id="8" name="PDF_TEXT_GROUP_454"/>
+          <p:cNvPr id="8" name="PDF_TEXT_GROUP_456"/>
           <p:cNvSpPr txBox="1"/>
           <p:nvPr/>
         </p:nvSpPr>
@@ -26747,7 +26834,7 @@
       </p:sp>
       <p:sp>
         <p:nvSpPr>
-          <p:cNvPr id="9" name="PDF_TEXT_GROUP_455"/>
+          <p:cNvPr id="9" name="PDF_TEXT_GROUP_457"/>
           <p:cNvSpPr txBox="1"/>
           <p:nvPr/>
         </p:nvSpPr>
@@ -26804,7 +26891,7 @@
       </p:sp>
       <p:sp>
         <p:nvSpPr>
-          <p:cNvPr id="10" name="PDF_TEXT_GROUP_456"/>
+          <p:cNvPr id="10" name="PDF_TEXT_GROUP_458"/>
           <p:cNvSpPr txBox="1"/>
           <p:nvPr/>
         </p:nvSpPr>
@@ -26852,7 +26939,7 @@
       </p:sp>
       <p:sp>
         <p:nvSpPr>
-          <p:cNvPr id="11" name="PDF_TEXT_GROUP_457"/>
+          <p:cNvPr id="11" name="PDF_TEXT_GROUP_459"/>
           <p:cNvSpPr txBox="1"/>
           <p:nvPr/>
         </p:nvSpPr>
@@ -26900,7 +26987,7 @@
       </p:sp>
       <p:sp>
         <p:nvSpPr>
-          <p:cNvPr id="12" name="PDF_TEXT_GROUP_458"/>
+          <p:cNvPr id="12" name="PDF_TEXT_GROUP_460"/>
           <p:cNvSpPr txBox="1"/>
           <p:nvPr/>
         </p:nvSpPr>
@@ -26948,7 +27035,7 @@
       </p:sp>
       <p:sp>
         <p:nvSpPr>
-          <p:cNvPr id="13" name="PDF_TEXT_GROUP_459"/>
+          <p:cNvPr id="13" name="PDF_TEXT_GROUP_461"/>
           <p:cNvSpPr txBox="1"/>
           <p:nvPr/>
         </p:nvSpPr>
@@ -27005,7 +27092,7 @@
       </p:sp>
       <p:sp>
         <p:nvSpPr>
-          <p:cNvPr id="14" name="PDF_TEXT_GROUP_460"/>
+          <p:cNvPr id="14" name="PDF_TEXT_GROUP_462"/>
           <p:cNvSpPr txBox="1"/>
           <p:nvPr/>
         </p:nvSpPr>
@@ -27053,7 +27140,7 @@
       </p:sp>
       <p:sp>
         <p:nvSpPr>
-          <p:cNvPr id="15" name="PDF_TEXT_GROUP_461"/>
+          <p:cNvPr id="15" name="PDF_TEXT_GROUP_463"/>
           <p:cNvSpPr txBox="1"/>
           <p:nvPr/>
         </p:nvSpPr>
@@ -27101,7 +27188,7 @@
       </p:sp>
       <p:sp>
         <p:nvSpPr>
-          <p:cNvPr id="16" name="PDF_TEXT_GROUP_462"/>
+          <p:cNvPr id="16" name="PDF_TEXT_GROUP_464"/>
           <p:cNvSpPr txBox="1"/>
           <p:nvPr/>
         </p:nvSpPr>
@@ -27158,7 +27245,7 @@
       </p:sp>
       <p:sp>
         <p:nvSpPr>
-          <p:cNvPr id="17" name="PDF_TEXT_GROUP_463"/>
+          <p:cNvPr id="17" name="PDF_TEXT_GROUP_465"/>
           <p:cNvSpPr txBox="1"/>
           <p:nvPr/>
         </p:nvSpPr>
@@ -27206,7 +27293,7 @@
       </p:sp>
       <p:sp>
         <p:nvSpPr>
-          <p:cNvPr id="18" name="PDF_TEXT_GROUP_464"/>
+          <p:cNvPr id="18" name="PDF_TEXT_GROUP_466"/>
           <p:cNvSpPr txBox="1"/>
           <p:nvPr/>
         </p:nvSpPr>
@@ -27254,7 +27341,7 @@
       </p:sp>
       <p:sp>
         <p:nvSpPr>
-          <p:cNvPr id="19" name="PDF_TEXT_GROUP_465"/>
+          <p:cNvPr id="19" name="PDF_TEXT_GROUP_467"/>
           <p:cNvSpPr txBox="1"/>
           <p:nvPr/>
         </p:nvSpPr>
@@ -27302,7 +27389,7 @@
       </p:sp>
       <p:sp>
         <p:nvSpPr>
-          <p:cNvPr id="20" name="PDF_TEXT_GROUP_466"/>
+          <p:cNvPr id="20" name="PDF_TEXT_GROUP_468"/>
           <p:cNvSpPr txBox="1"/>
           <p:nvPr/>
         </p:nvSpPr>
@@ -27350,7 +27437,7 @@
       </p:sp>
       <p:sp>
         <p:nvSpPr>
-          <p:cNvPr id="21" name="PDF_TEXT_GROUP_467"/>
+          <p:cNvPr id="21" name="PDF_TEXT_GROUP_469"/>
           <p:cNvSpPr txBox="1"/>
           <p:nvPr/>
         </p:nvSpPr>
@@ -27440,7 +27527,7 @@
       </p:pic>
       <p:sp>
         <p:nvSpPr>
-          <p:cNvPr id="3" name="PDF_TEXT_GROUP_468"/>
+          <p:cNvPr id="3" name="PDF_TEXT_GROUP_470"/>
           <p:cNvSpPr txBox="1"/>
           <p:nvPr/>
         </p:nvSpPr>
@@ -27488,14 +27575,14 @@
       </p:sp>
       <p:sp>
         <p:nvSpPr>
-          <p:cNvPr id="4" name="PDF_TEXT_GROUP_469"/>
-          <p:cNvSpPr txBox="1"/>
-          <p:nvPr/>
-        </p:nvSpPr>
-        <p:spPr>
-          <a:xfrm>
-            <a:off x="1618972" y="1953132"/>
-            <a:ext cx="10549005" cy="929891"/>
+          <p:cNvPr id="4" name="PDF_TEXT_GROUP_471"/>
+          <p:cNvSpPr txBox="1"/>
+          <p:nvPr/>
+        </p:nvSpPr>
+        <p:spPr>
+          <a:xfrm>
+            <a:off x="1618972" y="1777984"/>
+            <a:ext cx="11754312" cy="1367762"/>
           </a:xfrm>
           <a:prstGeom prst="rect">
             <a:avLst/>
@@ -27538,7 +27625,7 @@
                 </a:solidFill>
                 <a:latin typeface="Latin Modern Sans"/>
               </a:rPr>
-              <a:t> when ABE-encrypted discovery and ABE-backed service</a:t>
+              <a:t> when ABE-backed authorization is preferable to DNMP-inspired</a:t>
             </a:r>
             <a:r>
               <a:rPr sz="2710" b="0" i="0">
@@ -27547,20 +27634,29 @@
                 </a:solidFill>
                 <a:latin typeface="Latin Modern Sans"/>
               </a:rPr>
-              <a:t> authorization justify their management and revocation costs.</a:t>
-            </a:r>
-          </a:p>
-        </p:txBody>
-      </p:sp>
-      <p:sp>
-        <p:nvSpPr>
-          <p:cNvPr id="5" name="PDF_TEXT_GROUP_470"/>
-          <p:cNvSpPr txBox="1"/>
-          <p:nvPr/>
-        </p:nvSpPr>
-        <p:spPr>
-          <a:xfrm>
-            <a:off x="1618972" y="2925399"/>
+              <a:t> role rules plus encryption, accounting for confidentiality, management and</a:t>
+            </a:r>
+            <a:r>
+              <a:rPr sz="2710" b="0" i="0">
+                <a:solidFill>
+                  <a:srgbClr val="000000"/>
+                </a:solidFill>
+                <a:latin typeface="Latin Modern Sans"/>
+              </a:rPr>
+              <a:t> withdrawal costs.</a:t>
+            </a:r>
+          </a:p>
+        </p:txBody>
+      </p:sp>
+      <p:sp>
+        <p:nvSpPr>
+          <p:cNvPr id="5" name="PDF_TEXT_GROUP_472"/>
+          <p:cNvSpPr txBox="1"/>
+          <p:nvPr/>
+        </p:nvSpPr>
+        <p:spPr>
+          <a:xfrm>
+            <a:off x="1618972" y="3188121"/>
             <a:ext cx="11578665" cy="929891"/>
           </a:xfrm>
           <a:prstGeom prst="rect">
@@ -27620,13 +27716,13 @@
       </p:sp>
       <p:sp>
         <p:nvSpPr>
-          <p:cNvPr id="6" name="PDF_TEXT_GROUP_471"/>
-          <p:cNvSpPr txBox="1"/>
-          <p:nvPr/>
-        </p:nvSpPr>
-        <p:spPr>
-          <a:xfrm>
-            <a:off x="1618972" y="3897666"/>
+          <p:cNvPr id="6" name="PDF_TEXT_GROUP_473"/>
+          <p:cNvSpPr txBox="1"/>
+          <p:nvPr/>
+        </p:nvSpPr>
+        <p:spPr>
+          <a:xfrm>
+            <a:off x="1618972" y="4160388"/>
             <a:ext cx="11646728" cy="440633"/>
           </a:xfrm>
           <a:prstGeom prst="rect">
@@ -27677,13 +27773,13 @@
       </p:sp>
       <p:sp>
         <p:nvSpPr>
-          <p:cNvPr id="7" name="PDF_TEXT_GROUP_472"/>
-          <p:cNvSpPr txBox="1"/>
-          <p:nvPr/>
-        </p:nvSpPr>
-        <p:spPr>
-          <a:xfrm>
-            <a:off x="1618972" y="4432094"/>
+          <p:cNvPr id="7" name="PDF_TEXT_GROUP_474"/>
+          <p:cNvSpPr txBox="1"/>
+          <p:nvPr/>
+        </p:nvSpPr>
+        <p:spPr>
+          <a:xfrm>
+            <a:off x="1618972" y="4694817"/>
             <a:ext cx="11572749" cy="929891"/>
           </a:xfrm>
           <a:prstGeom prst="rect">
@@ -27734,14 +27830,14 @@
       </p:sp>
       <p:sp>
         <p:nvSpPr>
-          <p:cNvPr id="8" name="PDF_TEXT_GROUP_473"/>
-          <p:cNvSpPr txBox="1"/>
-          <p:nvPr/>
-        </p:nvSpPr>
-        <p:spPr>
-          <a:xfrm>
-            <a:off x="1143656" y="5750974"/>
-            <a:ext cx="12248862" cy="929891"/>
+          <p:cNvPr id="8" name="PDF_TEXT_GROUP_475"/>
+          <p:cNvSpPr txBox="1"/>
+          <p:nvPr/>
+        </p:nvSpPr>
+        <p:spPr>
+          <a:xfrm>
+            <a:off x="1143656" y="6013664"/>
+            <a:ext cx="12248862" cy="929924"/>
           </a:xfrm>
           <a:prstGeom prst="rect">
             <a:avLst/>
@@ -27791,7 +27887,7 @@
       </p:sp>
       <p:sp>
         <p:nvSpPr>
-          <p:cNvPr id="9" name="PDF_TEXT_GROUP_474"/>
+          <p:cNvPr id="9" name="PDF_TEXT_GROUP_476"/>
           <p:cNvSpPr txBox="1"/>
           <p:nvPr/>
         </p:nvSpPr>
@@ -27839,7 +27935,7 @@
       </p:sp>
       <p:sp>
         <p:nvSpPr>
-          <p:cNvPr id="10" name="PDF_TEXT_GROUP_475"/>
+          <p:cNvPr id="10" name="PDF_TEXT_GROUP_477"/>
           <p:cNvSpPr txBox="1"/>
           <p:nvPr/>
         </p:nvSpPr>
@@ -27887,7 +27983,7 @@
       </p:sp>
       <p:sp>
         <p:nvSpPr>
-          <p:cNvPr id="11" name="PDF_TEXT_GROUP_476"/>
+          <p:cNvPr id="11" name="PDF_TEXT_GROUP_478"/>
           <p:cNvSpPr txBox="1"/>
           <p:nvPr/>
         </p:nvSpPr>
@@ -27935,7 +28031,7 @@
       </p:sp>
       <p:sp>
         <p:nvSpPr>
-          <p:cNvPr id="12" name="PDF_TEXT_GROUP_477"/>
+          <p:cNvPr id="12" name="PDF_TEXT_GROUP_479"/>
           <p:cNvSpPr txBox="1"/>
           <p:nvPr/>
         </p:nvSpPr>
@@ -27983,7 +28079,7 @@
       </p:sp>
       <p:sp>
         <p:nvSpPr>
-          <p:cNvPr id="13" name="PDF_TEXT_GROUP_478"/>
+          <p:cNvPr id="13" name="PDF_TEXT_GROUP_480"/>
           <p:cNvSpPr txBox="1"/>
           <p:nvPr/>
         </p:nvSpPr>
@@ -28031,13 +28127,13 @@
       </p:sp>
       <p:sp>
         <p:nvSpPr>
-          <p:cNvPr id="14" name="PDF_BULLET_SPAN_681"/>
+          <p:cNvPr id="14" name="PDF_BULLET_SPAN_682"/>
           <p:cNvSpPr/>
           <p:nvPr/>
         </p:nvSpPr>
         <p:spPr>
           <a:xfrm rot="5400000">
-            <a:off x="1207424" y="2038923"/>
+            <a:off x="1207424" y="1863775"/>
             <a:ext cx="197164" cy="197164"/>
           </a:xfrm>
           <a:prstGeom prst="triangle">
@@ -28074,13 +28170,13 @@
       </p:sp>
       <p:sp>
         <p:nvSpPr>
-          <p:cNvPr id="15" name="PDF_BULLET_SPAN_685"/>
+          <p:cNvPr id="15" name="PDF_BULLET_SPAN_687"/>
           <p:cNvSpPr/>
           <p:nvPr/>
         </p:nvSpPr>
         <p:spPr>
           <a:xfrm rot="5400000">
-            <a:off x="1207424" y="3011190"/>
+            <a:off x="1207424" y="3273912"/>
             <a:ext cx="197164" cy="197164"/>
           </a:xfrm>
           <a:prstGeom prst="triangle">
@@ -28117,13 +28213,13 @@
       </p:sp>
       <p:sp>
         <p:nvSpPr>
-          <p:cNvPr id="16" name="PDF_BULLET_SPAN_689"/>
+          <p:cNvPr id="16" name="PDF_BULLET_SPAN_691"/>
           <p:cNvSpPr/>
           <p:nvPr/>
         </p:nvSpPr>
         <p:spPr>
           <a:xfrm rot="5400000">
-            <a:off x="1207424" y="3983457"/>
+            <a:off x="1207424" y="4246179"/>
             <a:ext cx="197164" cy="197164"/>
           </a:xfrm>
           <a:prstGeom prst="triangle">
@@ -28160,13 +28256,13 @@
       </p:sp>
       <p:sp>
         <p:nvSpPr>
-          <p:cNvPr id="17" name="PDF_BULLET_SPAN_692"/>
+          <p:cNvPr id="17" name="PDF_BULLET_SPAN_694"/>
           <p:cNvSpPr/>
           <p:nvPr/>
         </p:nvSpPr>
         <p:spPr>
           <a:xfrm rot="5400000">
-            <a:off x="1207424" y="4517885"/>
+            <a:off x="1207424" y="4780608"/>
             <a:ext cx="197164" cy="197164"/>
           </a:xfrm>
           <a:prstGeom prst="triangle">
@@ -28245,7 +28341,7 @@
       </p:pic>
       <p:sp>
         <p:nvSpPr>
-          <p:cNvPr id="3" name="PDF_TEXT_GROUP_479"/>
+          <p:cNvPr id="3" name="PDF_TEXT_GROUP_481"/>
           <p:cNvSpPr txBox="1"/>
           <p:nvPr/>
         </p:nvSpPr>
@@ -28293,7 +28389,7 @@
       </p:sp>
       <p:sp>
         <p:nvSpPr>
-          <p:cNvPr id="4" name="PDF_TEXT_GROUP_480"/>
+          <p:cNvPr id="4" name="PDF_TEXT_GROUP_482"/>
           <p:cNvSpPr txBox="1"/>
           <p:nvPr/>
         </p:nvSpPr>
@@ -28350,7 +28446,7 @@
       </p:sp>
       <p:sp>
         <p:nvSpPr>
-          <p:cNvPr id="5" name="PDF_TEXT_GROUP_481"/>
+          <p:cNvPr id="5" name="PDF_TEXT_GROUP_483"/>
           <p:cNvSpPr txBox="1"/>
           <p:nvPr/>
         </p:nvSpPr>
@@ -28407,7 +28503,7 @@
       </p:sp>
       <p:sp>
         <p:nvSpPr>
-          <p:cNvPr id="6" name="PDF_TEXT_GROUP_482"/>
+          <p:cNvPr id="6" name="PDF_TEXT_GROUP_484"/>
           <p:cNvSpPr txBox="1"/>
           <p:nvPr/>
         </p:nvSpPr>
@@ -28473,7 +28569,7 @@
       </p:sp>
       <p:sp>
         <p:nvSpPr>
-          <p:cNvPr id="7" name="PDF_TEXT_GROUP_483"/>
+          <p:cNvPr id="7" name="PDF_TEXT_GROUP_485"/>
           <p:cNvSpPr txBox="1"/>
           <p:nvPr/>
         </p:nvSpPr>
@@ -28530,7 +28626,7 @@
       </p:sp>
       <p:sp>
         <p:nvSpPr>
-          <p:cNvPr id="8" name="PDF_TEXT_GROUP_484"/>
+          <p:cNvPr id="8" name="PDF_TEXT_GROUP_486"/>
           <p:cNvSpPr txBox="1"/>
           <p:nvPr/>
         </p:nvSpPr>
@@ -28587,7 +28683,7 @@
       </p:sp>
       <p:sp>
         <p:nvSpPr>
-          <p:cNvPr id="9" name="PDF_TEXT_GROUP_485"/>
+          <p:cNvPr id="9" name="PDF_TEXT_GROUP_487"/>
           <p:cNvSpPr txBox="1"/>
           <p:nvPr/>
         </p:nvSpPr>
@@ -28635,7 +28731,7 @@
       </p:sp>
       <p:sp>
         <p:nvSpPr>
-          <p:cNvPr id="10" name="PDF_TEXT_GROUP_486"/>
+          <p:cNvPr id="10" name="PDF_TEXT_GROUP_488"/>
           <p:cNvSpPr txBox="1"/>
           <p:nvPr/>
         </p:nvSpPr>
@@ -28683,7 +28779,7 @@
       </p:sp>
       <p:sp>
         <p:nvSpPr>
-          <p:cNvPr id="11" name="PDF_TEXT_GROUP_487"/>
+          <p:cNvPr id="11" name="PDF_TEXT_GROUP_489"/>
           <p:cNvSpPr txBox="1"/>
           <p:nvPr/>
         </p:nvSpPr>
@@ -28731,7 +28827,7 @@
       </p:sp>
       <p:sp>
         <p:nvSpPr>
-          <p:cNvPr id="12" name="PDF_TEXT_GROUP_488"/>
+          <p:cNvPr id="12" name="PDF_TEXT_GROUP_490"/>
           <p:cNvSpPr txBox="1"/>
           <p:nvPr/>
         </p:nvSpPr>
@@ -28779,7 +28875,7 @@
       </p:sp>
       <p:sp>
         <p:nvSpPr>
-          <p:cNvPr id="13" name="PDF_TEXT_GROUP_489"/>
+          <p:cNvPr id="13" name="PDF_TEXT_GROUP_491"/>
           <p:cNvSpPr txBox="1"/>
           <p:nvPr/>
         </p:nvSpPr>
@@ -28869,7 +28965,7 @@
       </p:pic>
       <p:sp>
         <p:nvSpPr>
-          <p:cNvPr id="3" name="PDF_TEXT_GROUP_490"/>
+          <p:cNvPr id="3" name="PDF_TEXT_GROUP_492"/>
           <p:cNvSpPr txBox="1"/>
           <p:nvPr/>
         </p:nvSpPr>
@@ -28917,7 +29013,7 @@
       </p:sp>
       <p:sp>
         <p:nvSpPr>
-          <p:cNvPr id="4" name="PDF_TEXT_GROUP_491"/>
+          <p:cNvPr id="4" name="PDF_TEXT_GROUP_493"/>
           <p:cNvSpPr txBox="1"/>
           <p:nvPr/>
         </p:nvSpPr>
@@ -28965,7 +29061,7 @@
       </p:sp>
       <p:sp>
         <p:nvSpPr>
-          <p:cNvPr id="5" name="PDF_TEXT_GROUP_492"/>
+          <p:cNvPr id="5" name="PDF_TEXT_GROUP_494"/>
           <p:cNvSpPr txBox="1"/>
           <p:nvPr/>
         </p:nvSpPr>
@@ -29013,7 +29109,7 @@
       </p:sp>
       <p:sp>
         <p:nvSpPr>
-          <p:cNvPr id="6" name="PDF_TEXT_GROUP_493"/>
+          <p:cNvPr id="6" name="PDF_TEXT_GROUP_495"/>
           <p:cNvSpPr txBox="1"/>
           <p:nvPr/>
         </p:nvSpPr>
@@ -29061,7 +29157,7 @@
       </p:sp>
       <p:sp>
         <p:nvSpPr>
-          <p:cNvPr id="7" name="PDF_TEXT_GROUP_494"/>
+          <p:cNvPr id="7" name="PDF_TEXT_GROUP_496"/>
           <p:cNvSpPr txBox="1"/>
           <p:nvPr/>
         </p:nvSpPr>
@@ -29109,7 +29205,7 @@
       </p:sp>
       <p:sp>
         <p:nvSpPr>
-          <p:cNvPr id="8" name="PDF_TEXT_GROUP_495"/>
+          <p:cNvPr id="8" name="PDF_TEXT_GROUP_497"/>
           <p:cNvSpPr txBox="1"/>
           <p:nvPr/>
         </p:nvSpPr>
@@ -29157,7 +29253,7 @@
       </p:sp>
       <p:sp>
         <p:nvSpPr>
-          <p:cNvPr id="9" name="PDF_TEXT_GROUP_496"/>
+          <p:cNvPr id="9" name="PDF_TEXT_GROUP_498"/>
           <p:cNvSpPr txBox="1"/>
           <p:nvPr/>
         </p:nvSpPr>
@@ -29205,7 +29301,7 @@
       </p:sp>
       <p:sp>
         <p:nvSpPr>
-          <p:cNvPr id="10" name="PDF_TEXT_GROUP_497"/>
+          <p:cNvPr id="10" name="PDF_TEXT_GROUP_499"/>
           <p:cNvSpPr txBox="1"/>
           <p:nvPr/>
         </p:nvSpPr>
@@ -29253,7 +29349,7 @@
       </p:sp>
       <p:sp>
         <p:nvSpPr>
-          <p:cNvPr id="11" name="PDF_TEXT_GROUP_498"/>
+          <p:cNvPr id="11" name="PDF_TEXT_GROUP_500"/>
           <p:cNvSpPr txBox="1"/>
           <p:nvPr/>
         </p:nvSpPr>
@@ -29301,7 +29397,7 @@
       </p:sp>
       <p:sp>
         <p:nvSpPr>
-          <p:cNvPr id="12" name="PDF_TEXT_GROUP_499"/>
+          <p:cNvPr id="12" name="PDF_TEXT_GROUP_501"/>
           <p:cNvSpPr txBox="1"/>
           <p:nvPr/>
         </p:nvSpPr>
@@ -29358,7 +29454,7 @@
       </p:sp>
       <p:sp>
         <p:nvSpPr>
-          <p:cNvPr id="13" name="PDF_TEXT_GROUP_500"/>
+          <p:cNvPr id="13" name="PDF_TEXT_GROUP_502"/>
           <p:cNvSpPr txBox="1"/>
           <p:nvPr/>
         </p:nvSpPr>
@@ -29406,7 +29502,7 @@
       </p:sp>
       <p:sp>
         <p:nvSpPr>
-          <p:cNvPr id="14" name="PDF_TEXT_GROUP_501"/>
+          <p:cNvPr id="14" name="PDF_TEXT_GROUP_503"/>
           <p:cNvSpPr txBox="1"/>
           <p:nvPr/>
         </p:nvSpPr>
@@ -29454,7 +29550,7 @@
       </p:sp>
       <p:sp>
         <p:nvSpPr>
-          <p:cNvPr id="15" name="PDF_TEXT_GROUP_502"/>
+          <p:cNvPr id="15" name="PDF_TEXT_GROUP_504"/>
           <p:cNvSpPr txBox="1"/>
           <p:nvPr/>
         </p:nvSpPr>
@@ -29502,7 +29598,7 @@
       </p:sp>
       <p:sp>
         <p:nvSpPr>
-          <p:cNvPr id="16" name="PDF_TEXT_GROUP_503"/>
+          <p:cNvPr id="16" name="PDF_TEXT_GROUP_505"/>
           <p:cNvSpPr txBox="1"/>
           <p:nvPr/>
         </p:nvSpPr>
@@ -29550,7 +29646,7 @@
       </p:sp>
       <p:sp>
         <p:nvSpPr>
-          <p:cNvPr id="17" name="PDF_TEXT_GROUP_504"/>
+          <p:cNvPr id="17" name="PDF_TEXT_GROUP_506"/>
           <p:cNvSpPr txBox="1"/>
           <p:nvPr/>
         </p:nvSpPr>
@@ -29640,7 +29736,7 @@
       </p:pic>
       <p:sp>
         <p:nvSpPr>
-          <p:cNvPr id="3" name="PDF_TEXT_GROUP_505"/>
+          <p:cNvPr id="3" name="PDF_TEXT_GROUP_507"/>
           <p:cNvSpPr txBox="1"/>
           <p:nvPr/>
         </p:nvSpPr>
@@ -29688,7 +29784,7 @@
       </p:sp>
       <p:sp>
         <p:nvSpPr>
-          <p:cNvPr id="4" name="PDF_TEXT_GROUP_506"/>
+          <p:cNvPr id="4" name="PDF_TEXT_GROUP_508"/>
           <p:cNvSpPr txBox="1"/>
           <p:nvPr/>
         </p:nvSpPr>
@@ -29736,7 +29832,7 @@
       </p:sp>
       <p:sp>
         <p:nvSpPr>
-          <p:cNvPr id="5" name="PDF_TEXT_GROUP_507"/>
+          <p:cNvPr id="5" name="PDF_TEXT_GROUP_509"/>
           <p:cNvSpPr txBox="1"/>
           <p:nvPr/>
         </p:nvSpPr>
@@ -29784,7 +29880,7 @@
       </p:sp>
       <p:sp>
         <p:nvSpPr>
-          <p:cNvPr id="6" name="PDF_TEXT_GROUP_508"/>
+          <p:cNvPr id="6" name="PDF_TEXT_GROUP_510"/>
           <p:cNvSpPr txBox="1"/>
           <p:nvPr/>
         </p:nvSpPr>
@@ -29832,7 +29928,7 @@
       </p:sp>
       <p:sp>
         <p:nvSpPr>
-          <p:cNvPr id="7" name="PDF_TEXT_GROUP_509"/>
+          <p:cNvPr id="7" name="PDF_TEXT_GROUP_511"/>
           <p:cNvSpPr txBox="1"/>
           <p:nvPr/>
         </p:nvSpPr>
@@ -29880,7 +29976,7 @@
       </p:sp>
       <p:sp>
         <p:nvSpPr>
-          <p:cNvPr id="8" name="PDF_TEXT_GROUP_510"/>
+          <p:cNvPr id="8" name="PDF_TEXT_GROUP_512"/>
           <p:cNvSpPr txBox="1"/>
           <p:nvPr/>
         </p:nvSpPr>
@@ -29928,7 +30024,7 @@
       </p:sp>
       <p:sp>
         <p:nvSpPr>
-          <p:cNvPr id="9" name="PDF_TEXT_GROUP_511"/>
+          <p:cNvPr id="9" name="PDF_TEXT_GROUP_513"/>
           <p:cNvSpPr txBox="1"/>
           <p:nvPr/>
         </p:nvSpPr>
@@ -29976,7 +30072,7 @@
       </p:sp>
       <p:sp>
         <p:nvSpPr>
-          <p:cNvPr id="10" name="PDF_TEXT_GROUP_512"/>
+          <p:cNvPr id="10" name="PDF_TEXT_GROUP_514"/>
           <p:cNvSpPr txBox="1"/>
           <p:nvPr/>
         </p:nvSpPr>
@@ -30024,7 +30120,7 @@
       </p:sp>
       <p:sp>
         <p:nvSpPr>
-          <p:cNvPr id="11" name="PDF_TEXT_GROUP_513"/>
+          <p:cNvPr id="11" name="PDF_TEXT_GROUP_515"/>
           <p:cNvSpPr txBox="1"/>
           <p:nvPr/>
         </p:nvSpPr>
@@ -30072,7 +30168,7 @@
       </p:sp>
       <p:sp>
         <p:nvSpPr>
-          <p:cNvPr id="12" name="PDF_TEXT_GROUP_514"/>
+          <p:cNvPr id="12" name="PDF_TEXT_GROUP_516"/>
           <p:cNvSpPr txBox="1"/>
           <p:nvPr/>
         </p:nvSpPr>
@@ -30129,7 +30225,7 @@
       </p:sp>
       <p:sp>
         <p:nvSpPr>
-          <p:cNvPr id="13" name="PDF_TEXT_GROUP_515"/>
+          <p:cNvPr id="13" name="PDF_TEXT_GROUP_517"/>
           <p:cNvSpPr txBox="1"/>
           <p:nvPr/>
         </p:nvSpPr>
@@ -30177,7 +30273,7 @@
       </p:sp>
       <p:sp>
         <p:nvSpPr>
-          <p:cNvPr id="14" name="PDF_TEXT_GROUP_516"/>
+          <p:cNvPr id="14" name="PDF_TEXT_GROUP_518"/>
           <p:cNvSpPr txBox="1"/>
           <p:nvPr/>
         </p:nvSpPr>
@@ -30225,7 +30321,7 @@
       </p:sp>
       <p:sp>
         <p:nvSpPr>
-          <p:cNvPr id="15" name="PDF_TEXT_GROUP_517"/>
+          <p:cNvPr id="15" name="PDF_TEXT_GROUP_519"/>
           <p:cNvSpPr txBox="1"/>
           <p:nvPr/>
         </p:nvSpPr>
@@ -30273,7 +30369,7 @@
       </p:sp>
       <p:sp>
         <p:nvSpPr>
-          <p:cNvPr id="16" name="PDF_TEXT_GROUP_518"/>
+          <p:cNvPr id="16" name="PDF_TEXT_GROUP_520"/>
           <p:cNvSpPr txBox="1"/>
           <p:nvPr/>
         </p:nvSpPr>
@@ -30321,7 +30417,7 @@
       </p:sp>
       <p:sp>
         <p:nvSpPr>
-          <p:cNvPr id="17" name="PDF_TEXT_GROUP_519"/>
+          <p:cNvPr id="17" name="PDF_TEXT_GROUP_521"/>
           <p:cNvSpPr txBox="1"/>
           <p:nvPr/>
         </p:nvSpPr>
@@ -30369,7 +30465,7 @@
       </p:sp>
       <p:sp>
         <p:nvSpPr>
-          <p:cNvPr id="18" name="PDF_TEXT_GROUP_520"/>
+          <p:cNvPr id="18" name="PDF_TEXT_GROUP_522"/>
           <p:cNvSpPr txBox="1"/>
           <p:nvPr/>
         </p:nvSpPr>
@@ -30417,7 +30513,7 @@
       </p:sp>
       <p:sp>
         <p:nvSpPr>
-          <p:cNvPr id="19" name="PDF_TEXT_GROUP_521"/>
+          <p:cNvPr id="19" name="PDF_TEXT_GROUP_523"/>
           <p:cNvSpPr txBox="1"/>
           <p:nvPr/>
         </p:nvSpPr>
@@ -30507,7 +30603,7 @@
       </p:pic>
       <p:sp>
         <p:nvSpPr>
-          <p:cNvPr id="3" name="PDF_TEXT_GROUP_522"/>
+          <p:cNvPr id="3" name="PDF_TEXT_GROUP_524"/>
           <p:cNvSpPr txBox="1"/>
           <p:nvPr/>
         </p:nvSpPr>
@@ -30555,7 +30651,7 @@
       </p:sp>
       <p:sp>
         <p:nvSpPr>
-          <p:cNvPr id="4" name="PDF_TEXT_GROUP_523"/>
+          <p:cNvPr id="4" name="PDF_TEXT_GROUP_525"/>
           <p:cNvSpPr txBox="1"/>
           <p:nvPr/>
         </p:nvSpPr>
@@ -30612,7 +30708,7 @@
       </p:sp>
       <p:sp>
         <p:nvSpPr>
-          <p:cNvPr id="5" name="PDF_TEXT_GROUP_524"/>
+          <p:cNvPr id="5" name="PDF_TEXT_GROUP_526"/>
           <p:cNvSpPr txBox="1"/>
           <p:nvPr/>
         </p:nvSpPr>
@@ -30669,7 +30765,7 @@
       </p:sp>
       <p:sp>
         <p:nvSpPr>
-          <p:cNvPr id="6" name="PDF_TEXT_GROUP_525"/>
+          <p:cNvPr id="6" name="PDF_TEXT_GROUP_527"/>
           <p:cNvSpPr txBox="1"/>
           <p:nvPr/>
         </p:nvSpPr>
@@ -30726,7 +30822,7 @@
       </p:sp>
       <p:sp>
         <p:nvSpPr>
-          <p:cNvPr id="7" name="PDF_TEXT_GROUP_526"/>
+          <p:cNvPr id="7" name="PDF_TEXT_GROUP_528"/>
           <p:cNvSpPr txBox="1"/>
           <p:nvPr/>
         </p:nvSpPr>
@@ -30783,7 +30879,7 @@
       </p:sp>
       <p:sp>
         <p:nvSpPr>
-          <p:cNvPr id="8" name="PDF_TEXT_GROUP_527"/>
+          <p:cNvPr id="8" name="PDF_TEXT_GROUP_529"/>
           <p:cNvSpPr txBox="1"/>
           <p:nvPr/>
         </p:nvSpPr>
@@ -30840,7 +30936,7 @@
       </p:sp>
       <p:sp>
         <p:nvSpPr>
-          <p:cNvPr id="9" name="PDF_TEXT_GROUP_528"/>
+          <p:cNvPr id="9" name="PDF_TEXT_GROUP_530"/>
           <p:cNvSpPr txBox="1"/>
           <p:nvPr/>
         </p:nvSpPr>
@@ -30888,7 +30984,7 @@
       </p:sp>
       <p:sp>
         <p:nvSpPr>
-          <p:cNvPr id="10" name="PDF_TEXT_GROUP_529"/>
+          <p:cNvPr id="10" name="PDF_TEXT_GROUP_531"/>
           <p:cNvSpPr txBox="1"/>
           <p:nvPr/>
         </p:nvSpPr>
@@ -30945,7 +31041,7 @@
       </p:sp>
       <p:sp>
         <p:nvSpPr>
-          <p:cNvPr id="11" name="PDF_TEXT_GROUP_530"/>
+          <p:cNvPr id="11" name="PDF_TEXT_GROUP_532"/>
           <p:cNvSpPr txBox="1"/>
           <p:nvPr/>
         </p:nvSpPr>
@@ -31002,7 +31098,7 @@
       </p:sp>
       <p:sp>
         <p:nvSpPr>
-          <p:cNvPr id="12" name="PDF_TEXT_GROUP_531"/>
+          <p:cNvPr id="12" name="PDF_TEXT_GROUP_533"/>
           <p:cNvSpPr txBox="1"/>
           <p:nvPr/>
         </p:nvSpPr>
@@ -31050,7 +31146,7 @@
       </p:sp>
       <p:sp>
         <p:nvSpPr>
-          <p:cNvPr id="13" name="PDF_TEXT_GROUP_532"/>
+          <p:cNvPr id="13" name="PDF_TEXT_GROUP_534"/>
           <p:cNvSpPr txBox="1"/>
           <p:nvPr/>
         </p:nvSpPr>
@@ -31107,7 +31203,7 @@
       </p:sp>
       <p:sp>
         <p:nvSpPr>
-          <p:cNvPr id="14" name="PDF_TEXT_GROUP_533"/>
+          <p:cNvPr id="14" name="PDF_TEXT_GROUP_535"/>
           <p:cNvSpPr txBox="1"/>
           <p:nvPr/>
         </p:nvSpPr>
@@ -31155,7 +31251,7 @@
       </p:sp>
       <p:sp>
         <p:nvSpPr>
-          <p:cNvPr id="15" name="PDF_TEXT_GROUP_534"/>
+          <p:cNvPr id="15" name="PDF_TEXT_GROUP_536"/>
           <p:cNvSpPr txBox="1"/>
           <p:nvPr/>
         </p:nvSpPr>
@@ -31203,7 +31299,7 @@
       </p:sp>
       <p:sp>
         <p:nvSpPr>
-          <p:cNvPr id="16" name="PDF_TEXT_GROUP_535"/>
+          <p:cNvPr id="16" name="PDF_TEXT_GROUP_537"/>
           <p:cNvSpPr txBox="1"/>
           <p:nvPr/>
         </p:nvSpPr>
@@ -31251,7 +31347,7 @@
       </p:sp>
       <p:sp>
         <p:nvSpPr>
-          <p:cNvPr id="17" name="PDF_TEXT_GROUP_536"/>
+          <p:cNvPr id="17" name="PDF_TEXT_GROUP_538"/>
           <p:cNvSpPr txBox="1"/>
           <p:nvPr/>
         </p:nvSpPr>
@@ -31299,7 +31395,7 @@
       </p:sp>
       <p:sp>
         <p:nvSpPr>
-          <p:cNvPr id="18" name="PDF_TEXT_GROUP_537"/>
+          <p:cNvPr id="18" name="PDF_TEXT_GROUP_539"/>
           <p:cNvSpPr txBox="1"/>
           <p:nvPr/>
         </p:nvSpPr>
@@ -31347,7 +31443,7 @@
       </p:sp>
       <p:sp>
         <p:nvSpPr>
-          <p:cNvPr id="19" name="PDF_TEXT_GROUP_538"/>
+          <p:cNvPr id="19" name="PDF_TEXT_GROUP_540"/>
           <p:cNvSpPr txBox="1"/>
           <p:nvPr/>
         </p:nvSpPr>
@@ -31437,7 +31533,7 @@
       </p:pic>
       <p:sp>
         <p:nvSpPr>
-          <p:cNvPr id="3" name="PDF_TEXT_GROUP_539"/>
+          <p:cNvPr id="3" name="PDF_TEXT_GROUP_541"/>
           <p:cNvSpPr txBox="1"/>
           <p:nvPr/>
         </p:nvSpPr>
@@ -31485,7 +31581,7 @@
       </p:sp>
       <p:sp>
         <p:nvSpPr>
-          <p:cNvPr id="4" name="PDF_TEXT_GROUP_540"/>
+          <p:cNvPr id="4" name="PDF_TEXT_GROUP_542"/>
           <p:cNvSpPr txBox="1"/>
           <p:nvPr/>
         </p:nvSpPr>
@@ -31542,7 +31638,7 @@
       </p:sp>
       <p:sp>
         <p:nvSpPr>
-          <p:cNvPr id="5" name="PDF_TEXT_GROUP_541"/>
+          <p:cNvPr id="5" name="PDF_TEXT_GROUP_543"/>
           <p:cNvSpPr txBox="1"/>
           <p:nvPr/>
         </p:nvSpPr>
@@ -31599,7 +31695,7 @@
       </p:sp>
       <p:sp>
         <p:nvSpPr>
-          <p:cNvPr id="6" name="PDF_TEXT_GROUP_542"/>
+          <p:cNvPr id="6" name="PDF_TEXT_GROUP_544"/>
           <p:cNvSpPr txBox="1"/>
           <p:nvPr/>
         </p:nvSpPr>
@@ -31656,7 +31752,7 @@
       </p:sp>
       <p:sp>
         <p:nvSpPr>
-          <p:cNvPr id="7" name="PDF_TEXT_GROUP_543"/>
+          <p:cNvPr id="7" name="PDF_TEXT_GROUP_545"/>
           <p:cNvSpPr txBox="1"/>
           <p:nvPr/>
         </p:nvSpPr>
@@ -31713,7 +31809,7 @@
       </p:sp>
       <p:sp>
         <p:nvSpPr>
-          <p:cNvPr id="8" name="PDF_TEXT_GROUP_544"/>
+          <p:cNvPr id="8" name="PDF_TEXT_GROUP_546"/>
           <p:cNvSpPr txBox="1"/>
           <p:nvPr/>
         </p:nvSpPr>
@@ -31761,7 +31857,7 @@
       </p:sp>
       <p:sp>
         <p:nvSpPr>
-          <p:cNvPr id="9" name="PDF_TEXT_GROUP_545"/>
+          <p:cNvPr id="9" name="PDF_TEXT_GROUP_547"/>
           <p:cNvSpPr txBox="1"/>
           <p:nvPr/>
         </p:nvSpPr>
@@ -31818,7 +31914,7 @@
       </p:sp>
       <p:sp>
         <p:nvSpPr>
-          <p:cNvPr id="10" name="PDF_TEXT_GROUP_546"/>
+          <p:cNvPr id="10" name="PDF_TEXT_GROUP_548"/>
           <p:cNvSpPr txBox="1"/>
           <p:nvPr/>
         </p:nvSpPr>
@@ -31866,7 +31962,7 @@
       </p:sp>
       <p:sp>
         <p:nvSpPr>
-          <p:cNvPr id="11" name="PDF_TEXT_GROUP_547"/>
+          <p:cNvPr id="11" name="PDF_TEXT_GROUP_549"/>
           <p:cNvSpPr txBox="1"/>
           <p:nvPr/>
         </p:nvSpPr>
@@ -31923,7 +32019,7 @@
       </p:sp>
       <p:sp>
         <p:nvSpPr>
-          <p:cNvPr id="12" name="PDF_TEXT_GROUP_548"/>
+          <p:cNvPr id="12" name="PDF_TEXT_GROUP_550"/>
           <p:cNvSpPr txBox="1"/>
           <p:nvPr/>
         </p:nvSpPr>
@@ -31980,7 +32076,7 @@
       </p:sp>
       <p:sp>
         <p:nvSpPr>
-          <p:cNvPr id="13" name="PDF_TEXT_GROUP_549"/>
+          <p:cNvPr id="13" name="PDF_TEXT_GROUP_551"/>
           <p:cNvSpPr txBox="1"/>
           <p:nvPr/>
         </p:nvSpPr>
@@ -32028,7 +32124,7 @@
       </p:sp>
       <p:sp>
         <p:nvSpPr>
-          <p:cNvPr id="14" name="PDF_TEXT_GROUP_550"/>
+          <p:cNvPr id="14" name="PDF_TEXT_GROUP_552"/>
           <p:cNvSpPr txBox="1"/>
           <p:nvPr/>
         </p:nvSpPr>
@@ -32076,7 +32172,7 @@
       </p:sp>
       <p:sp>
         <p:nvSpPr>
-          <p:cNvPr id="15" name="PDF_TEXT_GROUP_551"/>
+          <p:cNvPr id="15" name="PDF_TEXT_GROUP_553"/>
           <p:cNvSpPr txBox="1"/>
           <p:nvPr/>
         </p:nvSpPr>
@@ -32124,7 +32220,7 @@
       </p:sp>
       <p:sp>
         <p:nvSpPr>
-          <p:cNvPr id="16" name="PDF_TEXT_GROUP_552"/>
+          <p:cNvPr id="16" name="PDF_TEXT_GROUP_554"/>
           <p:cNvSpPr txBox="1"/>
           <p:nvPr/>
         </p:nvSpPr>
@@ -32172,7 +32268,7 @@
       </p:sp>
       <p:sp>
         <p:nvSpPr>
-          <p:cNvPr id="17" name="PDF_TEXT_GROUP_553"/>
+          <p:cNvPr id="17" name="PDF_TEXT_GROUP_555"/>
           <p:cNvSpPr txBox="1"/>
           <p:nvPr/>
         </p:nvSpPr>
@@ -32220,7 +32316,7 @@
       </p:sp>
       <p:sp>
         <p:nvSpPr>
-          <p:cNvPr id="18" name="PDF_TEXT_GROUP_554"/>
+          <p:cNvPr id="18" name="PDF_TEXT_GROUP_556"/>
           <p:cNvSpPr txBox="1"/>
           <p:nvPr/>
         </p:nvSpPr>
@@ -32509,7 +32605,7 @@
         <p:spPr>
           <a:xfrm>
             <a:off x="6488446" y="1926823"/>
-            <a:ext cx="7024571" cy="828844"/>
+            <a:ext cx="7001071" cy="828844"/>
           </a:xfrm>
           <a:prstGeom prst="rect">
             <a:avLst/>
@@ -32543,7 +32639,7 @@
                 </a:solidFill>
                 <a:latin typeface="Latin Modern Sans"/>
               </a:rPr>
-              <a:t>Validate signatures and signing-key relationships</a:t>
+              <a:t>Validate signatures under application trust policies,</a:t>
             </a:r>
             <a:r>
               <a:rPr sz="2371" b="0" i="0">
@@ -32552,7 +32648,7 @@
                 </a:solidFill>
                 <a:latin typeface="Latin Modern Sans"/>
               </a:rPr>
-              <a:t> under trust rules; check task permissions separately</a:t>
+              <a:t> expressible through a Trust Schema [16]</a:t>
             </a:r>
           </a:p>
         </p:txBody>
@@ -33252,7 +33348,7 @@
       </p:pic>
       <p:sp>
         <p:nvSpPr>
-          <p:cNvPr id="3" name="PDF_TEXT_GROUP_555"/>
+          <p:cNvPr id="3" name="PDF_TEXT_GROUP_557"/>
           <p:cNvSpPr txBox="1"/>
           <p:nvPr/>
         </p:nvSpPr>
@@ -33300,7 +33396,7 @@
       </p:sp>
       <p:sp>
         <p:nvSpPr>
-          <p:cNvPr id="4" name="PDF_TEXT_GROUP_556"/>
+          <p:cNvPr id="4" name="PDF_TEXT_GROUP_558"/>
           <p:cNvSpPr txBox="1"/>
           <p:nvPr/>
         </p:nvSpPr>
@@ -33357,7 +33453,7 @@
       </p:sp>
       <p:sp>
         <p:nvSpPr>
-          <p:cNvPr id="5" name="PDF_TEXT_GROUP_557"/>
+          <p:cNvPr id="5" name="PDF_TEXT_GROUP_559"/>
           <p:cNvSpPr txBox="1"/>
           <p:nvPr/>
         </p:nvSpPr>
@@ -33414,7 +33510,7 @@
       </p:sp>
       <p:sp>
         <p:nvSpPr>
-          <p:cNvPr id="6" name="PDF_TEXT_GROUP_558"/>
+          <p:cNvPr id="6" name="PDF_TEXT_GROUP_560"/>
           <p:cNvSpPr txBox="1"/>
           <p:nvPr/>
         </p:nvSpPr>
@@ -33471,7 +33567,7 @@
       </p:sp>
       <p:sp>
         <p:nvSpPr>
-          <p:cNvPr id="7" name="PDF_TEXT_GROUP_559"/>
+          <p:cNvPr id="7" name="PDF_TEXT_GROUP_561"/>
           <p:cNvSpPr txBox="1"/>
           <p:nvPr/>
         </p:nvSpPr>
@@ -33528,7 +33624,7 @@
       </p:sp>
       <p:sp>
         <p:nvSpPr>
-          <p:cNvPr id="8" name="PDF_TEXT_GROUP_560"/>
+          <p:cNvPr id="8" name="PDF_TEXT_GROUP_562"/>
           <p:cNvSpPr txBox="1"/>
           <p:nvPr/>
         </p:nvSpPr>
@@ -33585,7 +33681,7 @@
       </p:sp>
       <p:sp>
         <p:nvSpPr>
-          <p:cNvPr id="9" name="PDF_TEXT_GROUP_561"/>
+          <p:cNvPr id="9" name="PDF_TEXT_GROUP_563"/>
           <p:cNvSpPr txBox="1"/>
           <p:nvPr/>
         </p:nvSpPr>
@@ -33633,7 +33729,7 @@
       </p:sp>
       <p:sp>
         <p:nvSpPr>
-          <p:cNvPr id="10" name="PDF_TEXT_GROUP_562"/>
+          <p:cNvPr id="10" name="PDF_TEXT_GROUP_564"/>
           <p:cNvSpPr txBox="1"/>
           <p:nvPr/>
         </p:nvSpPr>
@@ -33690,7 +33786,7 @@
       </p:sp>
       <p:sp>
         <p:nvSpPr>
-          <p:cNvPr id="11" name="PDF_TEXT_GROUP_563"/>
+          <p:cNvPr id="11" name="PDF_TEXT_GROUP_565"/>
           <p:cNvSpPr txBox="1"/>
           <p:nvPr/>
         </p:nvSpPr>
@@ -33738,7 +33834,7 @@
       </p:sp>
       <p:sp>
         <p:nvSpPr>
-          <p:cNvPr id="12" name="PDF_TEXT_GROUP_564"/>
+          <p:cNvPr id="12" name="PDF_TEXT_GROUP_566"/>
           <p:cNvSpPr txBox="1"/>
           <p:nvPr/>
         </p:nvSpPr>
@@ -33795,7 +33891,7 @@
       </p:sp>
       <p:sp>
         <p:nvSpPr>
-          <p:cNvPr id="13" name="PDF_TEXT_GROUP_565"/>
+          <p:cNvPr id="13" name="PDF_TEXT_GROUP_567"/>
           <p:cNvSpPr txBox="1"/>
           <p:nvPr/>
         </p:nvSpPr>
@@ -33843,7 +33939,7 @@
       </p:sp>
       <p:sp>
         <p:nvSpPr>
-          <p:cNvPr id="14" name="PDF_TEXT_GROUP_566"/>
+          <p:cNvPr id="14" name="PDF_TEXT_GROUP_568"/>
           <p:cNvSpPr txBox="1"/>
           <p:nvPr/>
         </p:nvSpPr>
@@ -33900,7 +33996,7 @@
       </p:sp>
       <p:sp>
         <p:nvSpPr>
-          <p:cNvPr id="15" name="PDF_TEXT_GROUP_567"/>
+          <p:cNvPr id="15" name="PDF_TEXT_GROUP_569"/>
           <p:cNvSpPr txBox="1"/>
           <p:nvPr/>
         </p:nvSpPr>
@@ -33948,7 +34044,7 @@
       </p:sp>
       <p:sp>
         <p:nvSpPr>
-          <p:cNvPr id="16" name="PDF_TEXT_GROUP_568"/>
+          <p:cNvPr id="16" name="PDF_TEXT_GROUP_570"/>
           <p:cNvSpPr txBox="1"/>
           <p:nvPr/>
         </p:nvSpPr>
@@ -33996,7 +34092,7 @@
       </p:sp>
       <p:sp>
         <p:nvSpPr>
-          <p:cNvPr id="17" name="PDF_TEXT_GROUP_569"/>
+          <p:cNvPr id="17" name="PDF_TEXT_GROUP_571"/>
           <p:cNvSpPr txBox="1"/>
           <p:nvPr/>
         </p:nvSpPr>
@@ -34044,7 +34140,7 @@
       </p:sp>
       <p:sp>
         <p:nvSpPr>
-          <p:cNvPr id="18" name="PDF_TEXT_GROUP_570"/>
+          <p:cNvPr id="18" name="PDF_TEXT_GROUP_572"/>
           <p:cNvSpPr txBox="1"/>
           <p:nvPr/>
         </p:nvSpPr>
@@ -34092,7 +34188,7 @@
       </p:sp>
       <p:sp>
         <p:nvSpPr>
-          <p:cNvPr id="19" name="PDF_TEXT_GROUP_571"/>
+          <p:cNvPr id="19" name="PDF_TEXT_GROUP_573"/>
           <p:cNvSpPr txBox="1"/>
           <p:nvPr/>
         </p:nvSpPr>
@@ -34140,7 +34236,7 @@
       </p:sp>
       <p:sp>
         <p:nvSpPr>
-          <p:cNvPr id="20" name="PDF_TEXT_GROUP_572"/>
+          <p:cNvPr id="20" name="PDF_TEXT_GROUP_574"/>
           <p:cNvSpPr txBox="1"/>
           <p:nvPr/>
         </p:nvSpPr>
@@ -35248,7 +35344,7 @@
         <p:spPr>
           <a:xfrm>
             <a:off x="4951472" y="2391871"/>
-            <a:ext cx="8650095" cy="828877"/>
+            <a:ext cx="8524252" cy="828877"/>
           </a:xfrm>
           <a:prstGeom prst="rect">
             <a:avLst/>
@@ -35282,7 +35378,7 @@
                 </a:solidFill>
                 <a:latin typeface="Latin Modern Sans"/>
               </a:rPr>
-              <a:t>Invocation and security mechanisms; NSC validates signed calls</a:t>
+              <a:t>Invocation mechanisms; NSC checks signed calls using a Trust</a:t>
             </a:r>
             <a:r>
               <a:rPr sz="2371" b="0" i="0">
@@ -35291,7 +35387,7 @@
                 </a:solidFill>
                 <a:latin typeface="Latin Modern Sans"/>
               </a:rPr>
-              <a:t> using application trust rules</a:t>
+              <a:t> Schema</a:t>
             </a:r>
           </a:p>
         </p:txBody>
@@ -35353,7 +35449,7 @@
         <p:spPr>
           <a:xfrm>
             <a:off x="4951601" y="3346591"/>
-            <a:ext cx="8139369" cy="385554"/>
+            <a:ext cx="8673187" cy="385554"/>
           </a:xfrm>
           <a:prstGeom prst="rect">
             <a:avLst/>
@@ -35387,7 +35483,7 @@
                 </a:solidFill>
                 <a:latin typeface="Latin Modern Sans"/>
               </a:rPr>
-              <a:t>Role- and command-constrained signing and verification</a:t>
+              <a:t>Trust Schema constrains roles and measurement commands</a:t>
             </a:r>
           </a:p>
         </p:txBody>

</xml_diff>

<commit_message>
docs: clarify request nonce and provider challenge terminology
</commit_message>
<xml_diff>
--- a/docs/PAPER/proposal-defense/slides/NDNSF_proposal_hybrid_editable.pptx
+++ b/docs/PAPER/proposal-defense/slides/NDNSF_proposal_hybrid_editable.pptx
@@ -449,7 +449,7 @@
           <a:p>
             <a:r>
               <a:rPr lang="en-US" sz="1200"/>
-              <a:t>1. The User places a Requester Challenge in ABE-protected Request content. 2. The Provider returns it in ACK Data; the User checks the value against the active request. 3. The Provider encrypts its challenge in ACK content. The User returns the value in Selection; the Provider checks it before execution. Both sides also validate signatures under trust rules and check service permissions and request state. Challenge responses show access to protected values; they do not grant permissions or prevent deliberate sharing.</a:t>
+              <a:t>1. The User puts a fresh random RequestNonce in ABE-protected Request content. This is not an Interest Nonce. 2. The Provider returns RequestNonce in ACK Data; the User checks it against the active request. 3. The Provider includes ProviderChallenge in ABE-protected ACK content and checks its challenge response in Selection before execution. Both sides also check signatures under trust rules, service permissions and request state. Matching challenge responses show access to protected values, not exclusive key possession.</a:t>
             </a:r>
             <a:endParaRPr lang="en-US" sz="1200"/>
           </a:p>
@@ -2409,7 +2409,7 @@
           <a:p>
             <a:r>
               <a:rPr lang="en-US" sz="1200"/>
-              <a:t>Data Logical purpose Request Describe required service and participation constraints; include protected discovery information and Requester Challenge ACK Report positive or negative participation; positive ACK supplies selection information and Provider Challenge Selection Assign selected execution; provide input/references, challenge response and protected request-scoped keys Response Return status, results or result references; the User still validates them before use Sync helps discover names; Interests retrieve Data. The Provider checks Selection before execution; a positive ACK alone does not start the task.</a:t>
+              <a:t>Data Logical purpose Request Describe required service and participation constraints; include protected discovery information and RequestNonce ACK Report positive or negative participation; positive ACK supplies selection information and ProviderChallenge Selection Assign selected execution; provide input/references, challenge response and protected request-scoped keys Response Return status, results or result references; the User still validates them before use Sync helps discover names; Interests retrieve Data. The Provider checks Selection before execution; a positive ACK alone does not start the task.</a:t>
             </a:r>
             <a:endParaRPr lang="en-US" sz="1200"/>
           </a:p>
@@ -7864,8 +7864,8 @@
         </p:nvSpPr>
         <p:spPr>
           <a:xfrm>
-            <a:off x="1169087" y="2039349"/>
-            <a:ext cx="12372860" cy="440633"/>
+            <a:off x="1169087" y="1854409"/>
+            <a:ext cx="12483305" cy="929924"/>
           </a:xfrm>
           <a:prstGeom prst="rect">
             <a:avLst/>
@@ -7908,7 +7908,16 @@
                 </a:solidFill>
                 <a:latin typeface="Latin Modern Sans"/>
               </a:rPr>
-              <a:t> The User places a Requester Challenge in ABE-protected Request content.</a:t>
+              <a:t> The User puts a fresh random RequestNonce in ABE-protected Request content.</a:t>
+            </a:r>
+            <a:r>
+              <a:rPr sz="2710" b="0" i="0">
+                <a:solidFill>
+                  <a:srgbClr val="000000"/>
+                </a:solidFill>
+                <a:latin typeface="Latin Modern Sans"/>
+              </a:rPr>
+              <a:t> This is not an Interest Nonce.</a:t>
             </a:r>
           </a:p>
         </p:txBody>
@@ -7921,8 +7930,8 @@
         </p:nvSpPr>
         <p:spPr>
           <a:xfrm>
-            <a:off x="1169087" y="2573777"/>
-            <a:ext cx="12681379" cy="929891"/>
+            <a:off x="1169087" y="2826708"/>
+            <a:ext cx="12474714" cy="929891"/>
           </a:xfrm>
           <a:prstGeom prst="rect">
             <a:avLst/>
@@ -7965,7 +7974,7 @@
                 </a:solidFill>
                 <a:latin typeface="Latin Modern Sans"/>
               </a:rPr>
-              <a:t> The Provider returns it in ACK Data; the User checks the value against the active</a:t>
+              <a:t> The Provider returns RequestNonce in ACK Data; the User checks it against the</a:t>
             </a:r>
             <a:r>
               <a:rPr sz="2710" b="0" i="0">
@@ -7974,7 +7983,7 @@
                 </a:solidFill>
                 <a:latin typeface="Latin Modern Sans"/>
               </a:rPr>
-              <a:t> request.</a:t>
+              <a:t> active request.</a:t>
             </a:r>
           </a:p>
         </p:txBody>
@@ -7987,8 +7996,8 @@
         </p:nvSpPr>
         <p:spPr>
           <a:xfrm>
-            <a:off x="1169087" y="3546044"/>
-            <a:ext cx="12383352" cy="929891"/>
+            <a:off x="1169087" y="3798975"/>
+            <a:ext cx="11895948" cy="929891"/>
           </a:xfrm>
           <a:prstGeom prst="rect">
             <a:avLst/>
@@ -8031,7 +8040,7 @@
                 </a:solidFill>
                 <a:latin typeface="Latin Modern Sans"/>
               </a:rPr>
-              <a:t> The Provider encrypts its challenge in ACK content. The User returns the value</a:t>
+              <a:t> The Provider includes ProviderChallenge in ABE-protected ACK content and</a:t>
             </a:r>
             <a:r>
               <a:rPr sz="2710" b="0" i="0">
@@ -8040,7 +8049,7 @@
                 </a:solidFill>
                 <a:latin typeface="Latin Modern Sans"/>
               </a:rPr>
-              <a:t> in Selection; the Provider checks it before execution.</a:t>
+              <a:t> checks its challenge response in Selection before execution.</a:t>
             </a:r>
           </a:p>
         </p:txBody>
@@ -8053,8 +8062,8 @@
         </p:nvSpPr>
         <p:spPr>
           <a:xfrm>
-            <a:off x="1143656" y="5115237"/>
-            <a:ext cx="12477812" cy="1367762"/>
+            <a:off x="1143656" y="5392631"/>
+            <a:ext cx="12333112" cy="1367762"/>
           </a:xfrm>
           <a:prstGeom prst="rect">
             <a:avLst/>
@@ -8088,7 +8097,7 @@
                 </a:solidFill>
                 <a:latin typeface="Latin Modern Sans"/>
               </a:rPr>
-              <a:t>Both sides also validate signatures under trust rules and check service permissions</a:t>
+              <a:t>Both sides also check signatures under trust rules, service permissions and request</a:t>
             </a:r>
             <a:r>
               <a:rPr sz="2710" b="0" i="0">
@@ -8097,7 +8106,7 @@
                 </a:solidFill>
                 <a:latin typeface="Latin Modern Sans"/>
               </a:rPr>
-              <a:t> and request state. Challenge responses show access to protected values; they do not</a:t>
+              <a:t> state. Matching challenge responses show access to protected values, not exclusive</a:t>
             </a:r>
             <a:r>
               <a:rPr sz="2710" b="0" i="0">
@@ -8106,7 +8115,7 @@
                 </a:solidFill>
                 <a:latin typeface="Latin Modern Sans"/>
               </a:rPr>
-              <a:t> grant permissions or prevent deliberate sharing.</a:t>
+              <a:t> key possession.</a:t>
             </a:r>
           </a:p>
         </p:txBody>
@@ -10648,7 +10657,7 @@
       </p:sp>
       <p:sp>
         <p:nvSpPr>
-          <p:cNvPr id="14" name="PDF_BULLET_SPAN_289"/>
+          <p:cNvPr id="14" name="PDF_BULLET_SPAN_290"/>
           <p:cNvSpPr/>
           <p:nvPr/>
         </p:nvSpPr>
@@ -10691,7 +10700,7 @@
       </p:sp>
       <p:sp>
         <p:nvSpPr>
-          <p:cNvPr id="15" name="PDF_BULLET_SPAN_292"/>
+          <p:cNvPr id="15" name="PDF_BULLET_SPAN_293"/>
           <p:cNvSpPr/>
           <p:nvPr/>
         </p:nvSpPr>
@@ -10734,7 +10743,7 @@
       </p:sp>
       <p:sp>
         <p:nvSpPr>
-          <p:cNvPr id="16" name="PDF_BULLET_SPAN_294"/>
+          <p:cNvPr id="16" name="PDF_BULLET_SPAN_295"/>
           <p:cNvSpPr/>
           <p:nvPr/>
         </p:nvSpPr>
@@ -10777,7 +10786,7 @@
       </p:sp>
       <p:sp>
         <p:nvSpPr>
-          <p:cNvPr id="17" name="PDF_BULLET_SPAN_297"/>
+          <p:cNvPr id="17" name="PDF_BULLET_SPAN_298"/>
           <p:cNvSpPr/>
           <p:nvPr/>
         </p:nvSpPr>
@@ -11387,7 +11396,7 @@
       </p:sp>
       <p:sp>
         <p:nvSpPr>
-          <p:cNvPr id="13" name="PDF_BULLET_SPAN_308"/>
+          <p:cNvPr id="13" name="PDF_BULLET_SPAN_309"/>
           <p:cNvSpPr/>
           <p:nvPr/>
         </p:nvSpPr>
@@ -11430,7 +11439,7 @@
       </p:sp>
       <p:sp>
         <p:nvSpPr>
-          <p:cNvPr id="14" name="PDF_BULLET_SPAN_311"/>
+          <p:cNvPr id="14" name="PDF_BULLET_SPAN_312"/>
           <p:cNvSpPr/>
           <p:nvPr/>
         </p:nvSpPr>
@@ -11473,7 +11482,7 @@
       </p:sp>
       <p:sp>
         <p:nvSpPr>
-          <p:cNvPr id="15" name="PDF_BULLET_SPAN_314"/>
+          <p:cNvPr id="15" name="PDF_BULLET_SPAN_315"/>
           <p:cNvSpPr/>
           <p:nvPr/>
         </p:nvSpPr>
@@ -12122,7 +12131,7 @@
       </p:sp>
       <p:sp>
         <p:nvSpPr>
-          <p:cNvPr id="14" name="PDF_BULLET_SPAN_326"/>
+          <p:cNvPr id="14" name="PDF_BULLET_SPAN_327"/>
           <p:cNvSpPr/>
           <p:nvPr/>
         </p:nvSpPr>
@@ -12165,7 +12174,7 @@
       </p:sp>
       <p:sp>
         <p:nvSpPr>
-          <p:cNvPr id="15" name="PDF_BULLET_SPAN_328"/>
+          <p:cNvPr id="15" name="PDF_BULLET_SPAN_329"/>
           <p:cNvSpPr/>
           <p:nvPr/>
         </p:nvSpPr>
@@ -12208,7 +12217,7 @@
       </p:sp>
       <p:sp>
         <p:nvSpPr>
-          <p:cNvPr id="16" name="PDF_BULLET_SPAN_331"/>
+          <p:cNvPr id="16" name="PDF_BULLET_SPAN_332"/>
           <p:cNvSpPr/>
           <p:nvPr/>
         </p:nvSpPr>
@@ -12251,7 +12260,7 @@
       </p:sp>
       <p:sp>
         <p:nvSpPr>
-          <p:cNvPr id="17" name="PDF_BULLET_SPAN_334"/>
+          <p:cNvPr id="17" name="PDF_BULLET_SPAN_335"/>
           <p:cNvSpPr/>
           <p:nvPr/>
         </p:nvSpPr>
@@ -17651,7 +17660,7 @@
       </p:sp>
       <p:sp>
         <p:nvSpPr>
-          <p:cNvPr id="14" name="PDF_BULLET_SPAN_446"/>
+          <p:cNvPr id="14" name="PDF_BULLET_SPAN_447"/>
           <p:cNvSpPr/>
           <p:nvPr/>
         </p:nvSpPr>
@@ -17694,7 +17703,7 @@
       </p:sp>
       <p:sp>
         <p:nvSpPr>
-          <p:cNvPr id="15" name="PDF_BULLET_SPAN_448"/>
+          <p:cNvPr id="15" name="PDF_BULLET_SPAN_449"/>
           <p:cNvSpPr/>
           <p:nvPr/>
         </p:nvSpPr>
@@ -17737,7 +17746,7 @@
       </p:sp>
       <p:sp>
         <p:nvSpPr>
-          <p:cNvPr id="16" name="PDF_BULLET_SPAN_451"/>
+          <p:cNvPr id="16" name="PDF_BULLET_SPAN_452"/>
           <p:cNvSpPr/>
           <p:nvPr/>
         </p:nvSpPr>
@@ -17780,7 +17789,7 @@
       </p:sp>
       <p:sp>
         <p:nvSpPr>
-          <p:cNvPr id="17" name="PDF_BULLET_SPAN_454"/>
+          <p:cNvPr id="17" name="PDF_BULLET_SPAN_455"/>
           <p:cNvSpPr/>
           <p:nvPr/>
         </p:nvSpPr>
@@ -18642,7 +18651,7 @@
       </p:sp>
       <p:sp>
         <p:nvSpPr>
-          <p:cNvPr id="18" name="PDF_BULLET_SPAN_473"/>
+          <p:cNvPr id="18" name="PDF_BULLET_SPAN_474"/>
           <p:cNvSpPr/>
           <p:nvPr/>
         </p:nvSpPr>
@@ -18685,7 +18694,7 @@
       </p:sp>
       <p:sp>
         <p:nvSpPr>
-          <p:cNvPr id="19" name="PDF_BULLET_SPAN_476"/>
+          <p:cNvPr id="19" name="PDF_BULLET_SPAN_477"/>
           <p:cNvSpPr/>
           <p:nvPr/>
         </p:nvSpPr>
@@ -18728,7 +18737,7 @@
       </p:sp>
       <p:sp>
         <p:nvSpPr>
-          <p:cNvPr id="20" name="PDF_BULLET_SPAN_479"/>
+          <p:cNvPr id="20" name="PDF_BULLET_SPAN_480"/>
           <p:cNvSpPr/>
           <p:nvPr/>
         </p:nvSpPr>
@@ -19377,7 +19386,7 @@
       </p:sp>
       <p:sp>
         <p:nvSpPr>
-          <p:cNvPr id="14" name="PDF_BULLET_SPAN_489"/>
+          <p:cNvPr id="14" name="PDF_BULLET_SPAN_490"/>
           <p:cNvSpPr/>
           <p:nvPr/>
         </p:nvSpPr>
@@ -19420,7 +19429,7 @@
       </p:sp>
       <p:sp>
         <p:nvSpPr>
-          <p:cNvPr id="15" name="PDF_BULLET_SPAN_492"/>
+          <p:cNvPr id="15" name="PDF_BULLET_SPAN_493"/>
           <p:cNvSpPr/>
           <p:nvPr/>
         </p:nvSpPr>
@@ -19463,7 +19472,7 @@
       </p:sp>
       <p:sp>
         <p:nvSpPr>
-          <p:cNvPr id="16" name="PDF_BULLET_SPAN_495"/>
+          <p:cNvPr id="16" name="PDF_BULLET_SPAN_496"/>
           <p:cNvSpPr/>
           <p:nvPr/>
         </p:nvSpPr>
@@ -19506,7 +19515,7 @@
       </p:sp>
       <p:sp>
         <p:nvSpPr>
-          <p:cNvPr id="17" name="PDF_BULLET_SPAN_497"/>
+          <p:cNvPr id="17" name="PDF_BULLET_SPAN_498"/>
           <p:cNvSpPr/>
           <p:nvPr/>
         </p:nvSpPr>
@@ -20164,7 +20173,7 @@
       </p:sp>
       <p:sp>
         <p:nvSpPr>
-          <p:cNvPr id="14" name="PDF_BULLET_SPAN_508"/>
+          <p:cNvPr id="14" name="PDF_BULLET_SPAN_509"/>
           <p:cNvSpPr/>
           <p:nvPr/>
         </p:nvSpPr>
@@ -20207,7 +20216,7 @@
       </p:sp>
       <p:sp>
         <p:nvSpPr>
-          <p:cNvPr id="15" name="PDF_BULLET_SPAN_511"/>
+          <p:cNvPr id="15" name="PDF_BULLET_SPAN_512"/>
           <p:cNvSpPr/>
           <p:nvPr/>
         </p:nvSpPr>
@@ -20250,7 +20259,7 @@
       </p:sp>
       <p:sp>
         <p:nvSpPr>
-          <p:cNvPr id="16" name="PDF_BULLET_SPAN_514"/>
+          <p:cNvPr id="16" name="PDF_BULLET_SPAN_515"/>
           <p:cNvSpPr/>
           <p:nvPr/>
         </p:nvSpPr>
@@ -20293,7 +20302,7 @@
       </p:sp>
       <p:sp>
         <p:nvSpPr>
-          <p:cNvPr id="17" name="PDF_BULLET_SPAN_517"/>
+          <p:cNvPr id="17" name="PDF_BULLET_SPAN_518"/>
           <p:cNvSpPr/>
           <p:nvPr/>
         </p:nvSpPr>
@@ -28127,7 +28136,7 @@
       </p:sp>
       <p:sp>
         <p:nvSpPr>
-          <p:cNvPr id="14" name="PDF_BULLET_SPAN_682"/>
+          <p:cNvPr id="14" name="PDF_BULLET_SPAN_683"/>
           <p:cNvSpPr/>
           <p:nvPr/>
         </p:nvSpPr>
@@ -28170,7 +28179,7 @@
       </p:sp>
       <p:sp>
         <p:nvSpPr>
-          <p:cNvPr id="15" name="PDF_BULLET_SPAN_687"/>
+          <p:cNvPr id="15" name="PDF_BULLET_SPAN_688"/>
           <p:cNvSpPr/>
           <p:nvPr/>
         </p:nvSpPr>
@@ -28213,7 +28222,7 @@
       </p:sp>
       <p:sp>
         <p:nvSpPr>
-          <p:cNvPr id="16" name="PDF_BULLET_SPAN_691"/>
+          <p:cNvPr id="16" name="PDF_BULLET_SPAN_692"/>
           <p:cNvSpPr/>
           <p:nvPr/>
         </p:nvSpPr>
@@ -28256,7 +28265,7 @@
       </p:sp>
       <p:sp>
         <p:nvSpPr>
-          <p:cNvPr id="17" name="PDF_BULLET_SPAN_694"/>
+          <p:cNvPr id="17" name="PDF_BULLET_SPAN_695"/>
           <p:cNvSpPr/>
           <p:nvPr/>
         </p:nvSpPr>
@@ -37893,7 +37902,7 @@
                 </a:solidFill>
                 <a:latin typeface="Latin Modern Sans"/>
               </a:rPr>
-              <a:t> discovery information and Requester Challenge</a:t>
+              <a:t> discovery information and RequestNonce</a:t>
             </a:r>
           </a:p>
         </p:txBody>
@@ -37998,7 +38007,7 @@
                 </a:solidFill>
                 <a:latin typeface="Latin Modern Sans"/>
               </a:rPr>
-              <a:t> information and Provider Challenge</a:t>
+              <a:t> information and ProviderChallenge</a:t>
             </a:r>
           </a:p>
         </p:txBody>

</xml_diff>

<commit_message>
docs: align paper and slides with dissertation proposal scope
</commit_message>
<xml_diff>
--- a/docs/PAPER/proposal-defense/slides/NDNSF_proposal_hybrid_editable.pptx
+++ b/docs/PAPER/proposal-defense/slides/NDNSF_proposal_hybrid_editable.pptx
@@ -2250,7 +2250,7 @@
           <a:p>
             <a:r>
               <a:rPr lang="en-US" sz="1200"/>
-              <a:t>Internal target Required deliverable September 2026 Agree scope/RQs; freeze one UAV graph and one DI partition; resolve correctness blockers October--November 2026 Complete registered experiments; freeze evidence and write bounded RQ answers December 2026 Complete integrated advisor-review draft January 2027 Committee review and readiness decision; reduce scope or revise timing if core evidence is missing February 2027 Target defense, conditional on evidence and committee approval Committee draft: two weeks before defense. Spring 2027 application/candidacy: February 5; final ProQuest: March 26. Recheck before filing. [29,30]</a:t>
+              <a:t>Internal target Required deliverable September 2026 Agree scope/RQs; freeze one UAV graph and one DI partition; resolve correctness blockers October--November 2026 Complete registered experiments; freeze evidence and write bounded RQ answers December 2026 Complete integrated advisor-review draft January 2027 Committee review and readiness decision; reduce scope or revise timing if core evidence is missing February 2027 Final dissertation defense, subject to committee approval Committee draft: two weeks before defense. Spring 2027 application/candidacy: February 5; final ProQuest: March 26. Recheck before filing. [29,30]</a:t>
             </a:r>
             <a:endParaRPr lang="en-US" sz="1200"/>
           </a:p>
@@ -2306,7 +2306,7 @@
           <a:p>
             <a:r>
               <a:rPr lang="en-US" sz="1200"/>
-              <a:t>RQ1 answer: when ABE-backed authorization is preferable to DNMP-inspired role rules plus encryption, accounting for confidentiality, management and withdrawal costs. RQ2 answer: exactly which task-assignment mistakes are rejected and which recovery behavior is supported. RQ3 answer: measured benefits, negative results and deployment limits. Reproducible configurations and evidence linking each conclusion to its tested scope. The outcome is a tested service protocol and an evidence-backed account of when its mechanisms are worth their cost.</a:t>
+              <a:t>RQ1 answer: when ABE-backed authorization is preferable to DNMP-inspired role rules plus encryption, accounting for confidentiality, management and withdrawal costs. RQ2 answer: exactly which task-assignment mistakes are rejected and which recovery behavior is supported. RQ3 answer: measured benefits, negative results and deployment limits. Reproducible configurations and evidence linking each conclusion to its tested scope. The intended outcome is a tested service protocol and an evidence-backed account of when its mechanisms are worth their cost.</a:t>
             </a:r>
             <a:endParaRPr lang="en-US" sz="1200"/>
           </a:p>
@@ -2362,7 +2362,7 @@
           <a:p>
             <a:r>
               <a:rPr lang="en-US" sz="1200"/>
-              <a:t>1. Are the three research questions specific enough to support defensible answers? 2. Are the authorization alternatives complete and fairly configured? 3. Are one UAV graph and one supported DI partition sufficient to test the abstraction? 4. Which optional features should be excluded if they delay the core evidence? NDNSF: evaluate runtime discovery and authorized invocation; extend the foundation to role-aware collaboration.</a:t>
+              <a:t>1. Are the three research questions specific enough to support defensible answers? 2. Are the authorization alternatives complete and fairly configured? 3. Are one UAV graph and one supported DI partition sufficient to test the abstraction? 4. Which optional features should be excluded if they delay the core evidence? Committee feedback sought: research significance, bounded scope, evaluation criteria, and a feasible completion plan.</a:t>
             </a:r>
             <a:endParaRPr lang="en-US" sz="1200"/>
           </a:p>
@@ -2866,7 +2866,7 @@
           <a:p>
             <a:r>
               <a:rPr lang="en-US" sz="1200"/>
-              <a:t>Intended contribution Current evidence boundary Discovery / authorization design and tradeoffs Invocation implementation and bounded experiments exist; full alternative lifecycle-cost comparison remains open ACK-derived plan and local input checks Design and implementation work; direct/cache and failure validation remains incomplete Cross-case empirical findings Existing mobility/work-efficiency and small-model results support limited configurations, not all new collaboration claims Proposal status, September 2026: implemented, locally tested, measured, and fully qualified are not interchangeable. [28]</a:t>
+              <a:t>Intended contribution Current evidence boundary Discovery / authorization design and tradeoffs Invocation implementation and bounded experiments exist; full alternative lifecycle-cost comparison remains open ACK-derived plan and local input checks Design and implementation work; direct/cache and failure validation remains incomplete Cross-case empirical findings Existing mobility/work-efficiency and small-model results support limited configurations, not all new collaboration claims Existing work supports feasibility. This proposal specifies what remains to be investigated and how the research claims will be tested. [28]</a:t>
             </a:r>
             <a:endParaRPr lang="en-US" sz="1200"/>
           </a:p>
@@ -21255,7 +21255,7 @@
                 </a:solidFill>
                 <a:latin typeface="Latin Modern Sans"/>
               </a:rPr>
-              <a:t>NDNSF-UAV: Application-Level Validation</a:t>
+              <a:t>NDNSF-UAV: Planned Framework Validation</a:t>
             </a:r>
           </a:p>
         </p:txBody>
@@ -24166,7 +24166,7 @@
                 </a:solidFill>
                 <a:latin typeface="Latin Modern Sans"/>
               </a:rPr>
-              <a:t>NDNSF-DI: Application-Level Validation</a:t>
+              <a:t>NDNSF-DI: Planned Framework Validation</a:t>
             </a:r>
           </a:p>
         </p:txBody>
@@ -28158,7 +28158,7 @@
                 </a:solidFill>
                 <a:latin typeface="Latin Modern Sans"/>
               </a:rPr>
-              <a:t>Mobility: Completion under Different Coverage Conditions</a:t>
+              <a:t>Preliminary Evidence: Mobility and Completion</a:t>
             </a:r>
           </a:p>
         </p:txBody>
@@ -29361,7 +29361,7 @@
                 </a:solidFill>
                 <a:latin typeface="Latin Modern Sans"/>
               </a:rPr>
-              <a:t>Mobility: Lower Tail Latency in a Defined Subset</a:t>
+              <a:t>Preliminary Evidence: Switching Latency</a:t>
             </a:r>
           </a:p>
         </p:txBody>
@@ -30420,7 +30420,7 @@
                 </a:solidFill>
                 <a:latin typeface="Latin Modern Sans"/>
               </a:rPr>
-              <a:t>Fewer Execution Starts than the Parallel Baseline</a:t>
+              <a:t>Preliminary Evidence: Execution Starts</a:t>
             </a:r>
           </a:p>
         </p:txBody>
@@ -32325,7 +32325,7 @@
                 </a:solidFill>
                 <a:latin typeface="Latin Modern Sans"/>
               </a:rPr>
-              <a:t>A Useful Negative Result: Splitting Can Be Slower</a:t>
+              <a:t>Preliminary Diagnostic: Splitting Can Be Slower</a:t>
             </a:r>
           </a:p>
         </p:txBody>
@@ -33288,7 +33288,7 @@
                 </a:solidFill>
                 <a:latin typeface="Latin Modern Sans"/>
               </a:rPr>
-              <a:t>Remaining Experiments Follow the Claims</a:t>
+              <a:t>Proposed Evaluation: Evidence for Each RQ</a:t>
             </a:r>
           </a:p>
         </p:txBody>
@@ -35231,7 +35231,7 @@
         <p:spPr>
           <a:xfrm>
             <a:off x="4695379" y="5243395"/>
-            <a:ext cx="9323228" cy="385554"/>
+            <a:ext cx="8274725" cy="385554"/>
           </a:xfrm>
           <a:prstGeom prst="rect">
             <a:avLst/>
@@ -35265,7 +35265,7 @@
                 </a:solidFill>
                 <a:latin typeface="Latin Modern Sans"/>
               </a:rPr>
-              <a:t>Target defense, conditional on evidence and committee approval</a:t>
+              <a:t>Final dissertation defense, subject to committee approval</a:t>
             </a:r>
           </a:p>
         </p:txBody>
@@ -35921,7 +35921,7 @@
         <p:spPr>
           <a:xfrm>
             <a:off x="1143656" y="6013664"/>
-            <a:ext cx="12248862" cy="929924"/>
+            <a:ext cx="12339027" cy="929924"/>
           </a:xfrm>
           <a:prstGeom prst="rect">
             <a:avLst/>
@@ -35955,7 +35955,7 @@
                 </a:solidFill>
                 <a:latin typeface="Latin Modern Sans"/>
               </a:rPr>
-              <a:t>The outcome is a tested service protocol and an evidence-backed account of when</a:t>
+              <a:t>The intended outcome is a tested service protocol and an evidence-backed account</a:t>
             </a:r>
             <a:r>
               <a:rPr sz="2710" b="0" i="0">
@@ -35964,7 +35964,7 @@
                 </a:solidFill>
                 <a:latin typeface="Latin Modern Sans"/>
               </a:rPr>
-              <a:t> its mechanisms are worth their cost.</a:t>
+              <a:t> of when its mechanisms are worth their cost.</a:t>
             </a:r>
           </a:p>
         </p:txBody>
@@ -36479,7 +36479,7 @@
         </p:nvSpPr>
         <p:spPr>
           <a:xfrm>
-            <a:off x="1169087" y="2156847"/>
+            <a:off x="1169087" y="2129411"/>
             <a:ext cx="13110552" cy="440633"/>
           </a:xfrm>
           <a:prstGeom prst="rect">
@@ -36536,7 +36536,7 @@
         </p:nvSpPr>
         <p:spPr>
           <a:xfrm>
-            <a:off x="1169087" y="2691275"/>
+            <a:off x="1169087" y="2663840"/>
             <a:ext cx="10917475" cy="440633"/>
           </a:xfrm>
           <a:prstGeom prst="rect">
@@ -36593,7 +36593,7 @@
         </p:nvSpPr>
         <p:spPr>
           <a:xfrm>
-            <a:off x="1169087" y="3225704"/>
+            <a:off x="1169087" y="3198268"/>
             <a:ext cx="11221526" cy="929891"/>
           </a:xfrm>
           <a:prstGeom prst="rect">
@@ -36659,7 +36659,7 @@
         </p:nvSpPr>
         <p:spPr>
           <a:xfrm>
-            <a:off x="1169087" y="4197971"/>
+            <a:off x="1169087" y="4170535"/>
             <a:ext cx="12521417" cy="440633"/>
           </a:xfrm>
           <a:prstGeom prst="rect">
@@ -36716,8 +36716,8 @@
         </p:nvSpPr>
         <p:spPr>
           <a:xfrm>
-            <a:off x="1143656" y="5445401"/>
-            <a:ext cx="11080733" cy="929891"/>
+            <a:off x="1143656" y="5417998"/>
+            <a:ext cx="11570144" cy="929891"/>
           </a:xfrm>
           <a:prstGeom prst="rect">
             <a:avLst/>
@@ -36751,7 +36751,7 @@
                 </a:solidFill>
                 <a:latin typeface="Latin Modern Sans"/>
               </a:rPr>
-              <a:t>NDNSF: evaluate runtime discovery and authorized invocation; extend the</a:t>
+              <a:t>Committee feedback sought: research significance, bounded scope, evaluation</a:t>
             </a:r>
             <a:r>
               <a:rPr sz="2710" b="0" i="0">
@@ -36760,7 +36760,7 @@
                 </a:solidFill>
                 <a:latin typeface="Latin Modern Sans"/>
               </a:rPr>
-              <a:t> foundation to role-aware collaboration.</a:t>
+              <a:t> criteria, and a feasible completion plan.</a:t>
             </a:r>
           </a:p>
         </p:txBody>
@@ -44248,7 +44248,7 @@
                 </a:solidFill>
                 <a:latin typeface="Latin Modern Sans"/>
               </a:rPr>
-              <a:t>Research Contributions and Current Evidence</a:t>
+              <a:t>Proposed Contributions and Current Foundation</a:t>
             </a:r>
           </a:p>
         </p:txBody>
@@ -44709,7 +44709,7 @@
         <p:spPr>
           <a:xfrm>
             <a:off x="1123808" y="5875092"/>
-            <a:ext cx="12516981" cy="828877"/>
+            <a:ext cx="12147455" cy="828877"/>
           </a:xfrm>
           <a:prstGeom prst="rect">
             <a:avLst/>
@@ -44743,7 +44743,7 @@
                 </a:solidFill>
                 <a:latin typeface="Latin Modern Sans"/>
               </a:rPr>
-              <a:t>Proposal status, September 2026: implemented, locally tested, measured, and fully qualified</a:t>
+              <a:t>Existing work supports feasibility. This proposal specifies what remains to be investigated</a:t>
             </a:r>
             <a:r>
               <a:rPr sz="2371" b="0" i="0">
@@ -44752,7 +44752,7 @@
                 </a:solidFill>
                 <a:latin typeface="Latin Modern Sans"/>
               </a:rPr>
-              <a:t> are not interchangeable. [28]</a:t>
+              <a:t> and how the research claims will be tested. [28]</a:t>
             </a:r>
           </a:p>
         </p:txBody>

</xml_diff>